<commit_message>
Update café proposal for The Daily Cup
Rework the deck to the new outline (executive summary through conclusion),
name the café and agency, and add green to the coffee palette.

Co-Authored-By: Claude Opus 5.5 <noreply@anthropic.com>
Claude-Session: https://claude.ai/code/session_01FBuHsgfNN7NePtiYw7LpVx
</commit_message>
<xml_diff>
--- a/Cafe_Marketing_Proposal.pptx
+++ b/Cafe_Marketing_Proposal.pptx
@@ -117,37 +117,37 @@
   <p:extLst>
     <p:ext uri="{521415D9-36F7-43E2-AB2F-B90AF26B5E84}">
       <p14:sectionLst xmlns:p14="http://schemas.microsoft.com/office/powerpoint/2010/main">
-        <p14:section name="Introduction" id="{2cac4cc6-226d-a040-991d-7b9f3558ee06}">
+        <p14:section name="Introduction" id="{e2b1dd3d-62ba-4e62-df16-e882d4886722}">
           <p14:sldIdLst>
             <p14:sldId id="256"/>
             <p14:sldId id="257"/>
           </p14:sldIdLst>
         </p14:section>
-        <p14:section name="Problem" id="{a181fbc2-5aac-f660-50fb-c920461791d3}">
+        <p14:section name="Problem" id="{49f65fef-79c9-ef57-eb77-9c9846c35fab}">
           <p14:sldIdLst>
             <p14:sldId id="258"/>
           </p14:sldIdLst>
         </p14:section>
-        <p14:section name="Solution" id="{a9f5ac3e-b809-3083-4eb9-9b970a444f75}">
+        <p14:section name="Solution" id="{1dd3e3ab-358d-cdff-2b0c-54b83b9ab916}">
           <p14:sldIdLst>
             <p14:sldId id="259"/>
             <p14:sldId id="260"/>
           </p14:sldIdLst>
         </p14:section>
-        <p14:section name="Budget and Timeline" id="{7ca85335-c341-6ff8-b9c3-0ecd7e18976f}">
+        <p14:section name="Budget and Timeline" id="{da5e3706-3aa2-8250-fd5d-62c22d81ef7c}">
           <p14:sldIdLst>
             <p14:sldId id="261"/>
             <p14:sldId id="262"/>
           </p14:sldIdLst>
         </p14:section>
-        <p14:section name="Results" id="{bcdd1cc8-5f15-f240-e602-12d4f17a2aea}">
+        <p14:section name="Results" id="{acff62f4-050c-9ce2-49a1-737b1cc3ff45}">
           <p14:sldIdLst>
             <p14:sldId id="263"/>
             <p14:sldId id="264"/>
             <p14:sldId id="265"/>
           </p14:sldIdLst>
         </p14:section>
-        <p14:section name="Conclusion" id="{05914f7c-f170-4f98-caaf-cde19a5bad77}">
+        <p14:section name="Conclusion" id="{79dde2e4-27d2-468c-c1c0-15917b20f069}">
           <p14:sldIdLst>
             <p14:sldId id="266"/>
           </p14:sldIdLst>
@@ -237,7 +237,7 @@
             <c:bubble3D val="0"/>
             <c:spPr>
               <a:solidFill>
-                <a:srgbClr val="6F4E37"/>
+                <a:srgbClr val="5B7F5E"/>
               </a:solidFill>
               <a:ln w="25400" cap="flat">
                 <a:solidFill>
@@ -399,7 +399,7 @@
                   <c:v>Social media management</c:v>
                 </c:pt>
                 <c:pt idx="1">
-                  <c:v>Paid advertising budget</c:v>
+                  <c:v>Paid advertising</c:v>
                 </c:pt>
                 <c:pt idx="2">
                   <c:v>Content creation</c:v>
@@ -853,8 +853,8 @@
           <a:p>
             <a:r>
               <a:rPr lang="en-US" dirty="0"/>
-              <a:t>Introduce the team and the agency.
-"Today we'll show you how digital marketing can help [Café Name] increase brand awareness, attract more customers and grow sales."</a:t>
+              <a:t>Introduce yourselves and BrandBrew Marketing.
+"Today we'll show you how we can help The Daily Cup reach more customers and grow its business."</a:t>
             </a:r>
             <a:endParaRPr lang="en-US" dirty="0"/>
           </a:p>
@@ -943,11 +943,11 @@
             <a:r>
               <a:rPr lang="en-US" dirty="0"/>
               <a:t>After the first month, we plan to:
-- Expand the advertising campaigns that work best.
-- Collaborate with local food influencers.
-- Introduce customer loyalty and referral programs.
-- Develop seasonal campaigns and special offers (for example Ramadan, summer, back to school).
-- Use performance data to build a long-term marketing strategy.</a:t>
+- Work with local food influencers.
+- Launch loyalty programs for regular customers.
+- Create seasonal offers.
+- Expand successful advertising campaigns.
+- Develop a long-term marketing strategy.</a:t>
             </a:r>
             <a:endParaRPr lang="en-US" dirty="0"/>
           </a:p>
@@ -1035,9 +1035,9 @@
           <a:p>
             <a:r>
               <a:rPr lang="en-US" dirty="0"/>
-              <a:t>We believe the right marketing strategy can help the café reach more customers and grow its business.
-Our agency is ready to turn this plan into action and build a strong digital presence for your brand.
-Let's grow your business together! Then open for questions.</a:t>
+              <a:t>Our agency is ready to help The Daily Cup grow and reach more customers.
+We believe that a good marketing strategy can improve the café's online presence and support its business growth.
+Let's grow together! Then thank the owner and open for questions.</a:t>
             </a:r>
             <a:endParaRPr lang="en-US" dirty="0"/>
           </a:p>
@@ -1125,9 +1125,13 @@
           <a:p>
             <a:r>
               <a:rPr lang="en-US" dirty="0"/>
-              <a:t>Our agency aims to help the café grow its business through a targeted digital marketing strategy.
-We will improve its online presence, attract new customers, and encourage existing customers to return.
-Our strategy focuses on three things (shown on the left): social media marketing, paid advertising, and engaging content.</a:t>
+              <a:t>Our marketing agency wants to help The Daily Cup grow its business.
+Our goals are to:
+- Increase brand awareness.
+- Attract more customers.
+- Increase sales.
+- Improve social media presence.
+We will use social media, online advertising, and creative content to achieve these goals (shown in the picture).</a:t>
             </a:r>
             <a:endParaRPr lang="en-US" dirty="0"/>
           </a:p>
@@ -1215,13 +1219,12 @@
           <a:p>
             <a:r>
               <a:rPr lang="en-US" dirty="0"/>
-              <a:t>The café may face several marketing challenges:
-- Low brand awareness: many people nearby don't know the café exists.
-- Limited reach on social media: posts are seen by very few people.
-- Strong competition from other cafés in the area.
-- Few new customers and limited customer engagement.
-- No clear digital marketing strategy: posting is random, with no plan or goals.
-(These are proposed challenges for the presentation scenario, not verified facts about a real café.)</a:t>
+              <a:t>The café may face some challenges:
+- Low brand awareness.
+- Few followers and low engagement on social media.
+- Strong competition from other cafés.
+- Difficulty attracting new customers.
+- Low sales during some periods.</a:t>
             </a:r>
             <a:endParaRPr lang="en-US" dirty="0"/>
           </a:p>
@@ -1309,11 +1312,11 @@
           <a:p>
             <a:r>
               <a:rPr lang="en-US" dirty="0"/>
-              <a:t>Our agency proposes a complete digital marketing plan with four parts:
-1. Social Media Management: attractive posts, reels and stories, with a consistent posting schedule.
-2. Paid Advertising: targeted Facebook and Instagram ads that reach potential customers near the café.
-3. Content Creation: high-quality photos and videos showing the drinks, food, offers and the café experience.
-4. Customer Engagement: replying to comments and messages, and introducing promotions and loyalty campaigns.</a:t>
+              <a:t>Our agency offers four main services:
+- Social Media Management: create regular posts, reels, and stories.
+- Paid Advertising: run Facebook and Instagram ads.
+- Content Creation: take attractive photos and videos of products.
+- Promotions: offer discounts and special deals to attract customers.</a:t>
             </a:r>
             <a:endParaRPr lang="en-US" dirty="0"/>
           </a:p>
@@ -1401,12 +1404,12 @@
           <a:p>
             <a:r>
               <a:rPr lang="en-US" dirty="0"/>
-              <a:t>1. Research: analyze the target audience and competitors.
-2. Planning: develop a content calendar and an advertising strategy.
-3. Execution: publish content and launch advertising campaigns.
-4. Monitoring: track engagement, reach, leads and sales.
-5. Optimization: improve campaigns based on performance data.
-Steps 3 to 5 are a continuous cycle.</a:t>
+              <a:t>We will follow five simple steps:
+1. Research the market and competitors.
+2. Identify the target audience.
+3. Create a monthly content plan.
+4. Publish content and launch advertisements.
+5. Measure results and improve the campaign.</a:t>
             </a:r>
             <a:endParaRPr lang="en-US" dirty="0"/>
           </a:p>
@@ -1494,13 +1497,13 @@
           <a:p>
             <a:r>
               <a:rPr lang="en-US" dirty="0"/>
-              <a:t>Illustrative budget for a one-month campaign (amounts are proposed for the presentation, not supplier quotes):
+              <a:t>Monthly budget:
 - Social media management: 5,000 EGP
-- Paid advertising budget: 4,000 EGP
+- Paid advertising: 4,000 EGP
 - Content creation: 3,000 EGP
-- Campaign reporting and optimization: 1,000 EGP
+- Reporting and optimization: 1,000 EGP
 Total: 13,000 EGP per month.
-The final quote should clarify whether taxes, photography expenses and other production costs are included.</a:t>
+This is a proposed budget for the presentation.</a:t>
             </a:r>
             <a:endParaRPr lang="en-US" dirty="0"/>
           </a:p>
@@ -1588,10 +1591,10 @@
           <a:p>
             <a:r>
               <a:rPr lang="en-US" dirty="0"/>
-              <a:t>Week 1 - Research and Planning: study the market, competitors and target audience.
-Week 2 - Content Creation: prepare posts, videos and advertising materials.
-Week 3 - Campaign Launch: publish content and start paid ads.
-Week 4 - Evaluation and Improvement: analyze performance and recommend improvements.</a:t>
+              <a:t>Week 1: Research and planning.
+Week 2: Content creation.
+Week 3: Launch marketing campaigns.
+Week 4: Measure results and improve.</a:t>
             </a:r>
             <a:endParaRPr lang="en-US" dirty="0"/>
           </a:p>
@@ -1679,12 +1682,12 @@
           <a:p>
             <a:r>
               <a:rPr lang="en-US" dirty="0"/>
-              <a:t>Working with our agency can help the café:
-- Increase brand awareness and online visibility.
-- Reach more potential customers.
-- Build stronger customer relationships.
-- Promote new products and special offers.
-- Make better marketing decisions using data.</a:t>
+              <a:t>Working with our agency will help the café:
+- Reach more people.
+- Attract new customers.
+- Build a strong brand.
+- Improve customer engagement.
+- Increase the chance of higher sales.</a:t>
             </a:r>
             <a:endParaRPr lang="en-US" dirty="0"/>
           </a:p>
@@ -1773,12 +1776,12 @@
             <a:r>
               <a:rPr lang="en-US" dirty="0"/>
               <a:t>During the first month, we aim to achieve:
-- Higher social media reach and engagement.
-- More profile visits, inquiries and direction requests.
-- More awareness of the café's products and offers.
-- More visits and sales that can be linked to the campaign.
-How we measure success: reach, engagement rate, cost per inquiry, customer visits, and sales where data is available.
-Targets should be set after reviewing the café's current performance. Results are not guaranteed.</a:t>
+- More social media followers and engagement.
+- More customer inquiries.
+- Greater awareness of the café.
+- More visits from potential customers.
+- Improved sales performance.
+We will track the results to understand what works best.</a:t>
             </a:r>
             <a:endParaRPr lang="en-US" dirty="0"/>
           </a:p>
@@ -2137,7 +2140,7 @@
                   <a:schemeClr val="accent5"/>
                 </a:solidFill>
               </a:rPr>
-              <a:t>[Agency Name]  |  Digital Marketing Proposal for [Café Name]</a:t>
+              <a:t>BrandBrew Marketing  |  Digital Marketing Proposal for The Daily Cup</a:t>
             </a:r>
             <a:endParaRPr lang="en-US" sz="1000" dirty="0"/>
           </a:p>
@@ -2569,7 +2572,7 @@
                   <a:schemeClr val="accent2"/>
                 </a:solidFill>
               </a:rPr>
-              <a:t>PRESENTED BY [AGENCY NAME]</a:t>
+              <a:t>PRESENTED BY BRANDBREW MARKETING</a:t>
             </a:r>
             <a:endParaRPr lang="en-US" sz="1200" dirty="0"/>
           </a:p>
@@ -2648,7 +2651,7 @@
                   <a:schemeClr val="accent2"/>
                 </a:solidFill>
               </a:rPr>
-              <a:t>Helping [Café Name] get discovered, attract more customers and grow sales.</a:t>
+              <a:t>For The Daily Cup Café</a:t>
             </a:r>
             <a:endParaRPr lang="en-US" sz="1500" dirty="0"/>
           </a:p>
@@ -2776,7 +2779,7 @@
                 <a:ea typeface="Cambria" pitchFamily="34" charset="-122"/>
                 <a:cs typeface="Cambria" pitchFamily="34" charset="-120"/>
               </a:rPr>
-              <a:t>After Month One: Keep Growing</a:t>
+              <a:t>After the First Month</a:t>
             </a:r>
             <a:endParaRPr lang="en-US" sz="3200" dirty="0"/>
           </a:p>
@@ -2806,7 +2809,7 @@
       </p:sp>
       <p:sp>
         <p:nvSpPr>
-          <p:cNvPr id="5" name="Scale the best ads circle"/>
+          <p:cNvPr id="5" name="Food influencers circle"/>
           <p:cNvSpPr/>
           <p:nvPr/>
         </p:nvSpPr>
@@ -2826,7 +2829,7 @@
       </p:sp>
       <p:pic>
         <p:nvPicPr>
-          <p:cNvPr id="6" name="Scale the best ads icon" descr="Scale the best ads">    </p:cNvPr>
+          <p:cNvPr id="6" name="Food influencers icon" descr="Food influencers">    </p:cNvPr>
           <p:cNvPicPr>
             <a:picLocks noChangeAspect="1"/>
           </p:cNvPicPr>
@@ -2873,14 +2876,14 @@
               <a:buNone/>
             </a:pPr>
             <a:r>
-              <a:rPr lang="en-US" sz="1300" b="1" dirty="0">
+              <a:rPr lang="en-US" sz="1400" b="1" dirty="0">
                 <a:solidFill>
                   <a:schemeClr val="tx2"/>
                 </a:solidFill>
               </a:rPr>
-              <a:t>Scale the best ads</a:t>
-            </a:r>
-            <a:endParaRPr lang="en-US" sz="1300" dirty="0"/>
+              <a:t>Food influencers</a:t>
+            </a:r>
+            <a:endParaRPr lang="en-US" sz="1400" dirty="0"/>
           </a:p>
         </p:txBody>
       </p:sp>
@@ -2908,7 +2911,7 @@
       </p:sp>
       <p:sp>
         <p:nvSpPr>
-          <p:cNvPr id="9" name="Food influencer collabs circle"/>
+          <p:cNvPr id="9" name="Loyalty programs circle"/>
           <p:cNvSpPr/>
           <p:nvPr/>
         </p:nvSpPr>
@@ -2928,7 +2931,7 @@
       </p:sp>
       <p:pic>
         <p:nvPicPr>
-          <p:cNvPr id="10" name="Food influencer collabs icon" descr="Food influencer collabs">    </p:cNvPr>
+          <p:cNvPr id="10" name="Loyalty programs icon" descr="Loyalty programs">    </p:cNvPr>
           <p:cNvPicPr>
             <a:picLocks noChangeAspect="1"/>
           </p:cNvPicPr>
@@ -2975,14 +2978,14 @@
               <a:buNone/>
             </a:pPr>
             <a:r>
-              <a:rPr lang="en-US" sz="1300" b="1" dirty="0">
+              <a:rPr lang="en-US" sz="1400" b="1" dirty="0">
                 <a:solidFill>
                   <a:schemeClr val="tx2"/>
                 </a:solidFill>
               </a:rPr>
-              <a:t>Food influencer collabs</a:t>
-            </a:r>
-            <a:endParaRPr lang="en-US" sz="1300" dirty="0"/>
+              <a:t>Loyalty programs</a:t>
+            </a:r>
+            <a:endParaRPr lang="en-US" sz="1400" dirty="0"/>
           </a:p>
         </p:txBody>
       </p:sp>
@@ -3003,14 +3006,14 @@
             </a:avLst>
           </a:prstGeom>
           <a:solidFill>
-            <a:schemeClr val="accent1"/>
+            <a:schemeClr val="accent4"/>
           </a:solidFill>
           <a:ln/>
         </p:spPr>
       </p:sp>
       <p:sp>
         <p:nvSpPr>
-          <p:cNvPr id="13" name="Loyalty and referral programs circle"/>
+          <p:cNvPr id="13" name="Seasonal offers circle"/>
           <p:cNvSpPr/>
           <p:nvPr/>
         </p:nvSpPr>
@@ -3030,7 +3033,7 @@
       </p:sp>
       <p:pic>
         <p:nvPicPr>
-          <p:cNvPr id="14" name="Loyalty and referral programs icon" descr="Loyalty and referral programs">    </p:cNvPr>
+          <p:cNvPr id="14" name="Seasonal offers icon" descr="Seasonal offers">    </p:cNvPr>
           <p:cNvPicPr>
             <a:picLocks noChangeAspect="1"/>
           </p:cNvPicPr>
@@ -3077,14 +3080,14 @@
               <a:buNone/>
             </a:pPr>
             <a:r>
-              <a:rPr lang="en-US" sz="1300" b="1" dirty="0">
+              <a:rPr lang="en-US" sz="1400" b="1" dirty="0">
                 <a:solidFill>
                   <a:schemeClr val="bg1"/>
                 </a:solidFill>
               </a:rPr>
-              <a:t>Loyalty and referral programs</a:t>
-            </a:r>
-            <a:endParaRPr lang="en-US" sz="1300" dirty="0"/>
+              <a:t>Seasonal offers</a:t>
+            </a:r>
+            <a:endParaRPr lang="en-US" sz="1400" dirty="0"/>
           </a:p>
         </p:txBody>
       </p:sp>
@@ -3112,7 +3115,7 @@
       </p:sp>
       <p:sp>
         <p:nvSpPr>
-          <p:cNvPr id="17" name="Seasonal campaigns and offers circle"/>
+          <p:cNvPr id="17" name="Expand the best ads circle"/>
           <p:cNvSpPr/>
           <p:nvPr/>
         </p:nvSpPr>
@@ -3132,7 +3135,7 @@
       </p:sp>
       <p:pic>
         <p:nvPicPr>
-          <p:cNvPr id="18" name="Seasonal campaigns and offers icon" descr="Seasonal campaigns and offers">    </p:cNvPr>
+          <p:cNvPr id="18" name="Expand the best ads icon" descr="Expand the best ads">    </p:cNvPr>
           <p:cNvPicPr>
             <a:picLocks noChangeAspect="1"/>
           </p:cNvPicPr>
@@ -3179,14 +3182,14 @@
               <a:buNone/>
             </a:pPr>
             <a:r>
-              <a:rPr lang="en-US" sz="1300" b="1" dirty="0">
+              <a:rPr lang="en-US" sz="1400" b="1" dirty="0">
                 <a:solidFill>
                   <a:schemeClr val="bg1"/>
                 </a:solidFill>
               </a:rPr>
-              <a:t>Seasonal campaigns and offers</a:t>
-            </a:r>
-            <a:endParaRPr lang="en-US" sz="1300" dirty="0"/>
+              <a:t>Expand the best ads</a:t>
+            </a:r>
+            <a:endParaRPr lang="en-US" sz="1400" dirty="0"/>
           </a:p>
         </p:txBody>
       </p:sp>
@@ -3214,7 +3217,7 @@
       </p:sp>
       <p:sp>
         <p:nvSpPr>
-          <p:cNvPr id="21" name="Long-term marketing strategy circle"/>
+          <p:cNvPr id="21" name="Long-term strategy circle"/>
           <p:cNvSpPr/>
           <p:nvPr/>
         </p:nvSpPr>
@@ -3234,7 +3237,7 @@
       </p:sp>
       <p:pic>
         <p:nvPicPr>
-          <p:cNvPr id="22" name="Long-term marketing strategy icon" descr="Long-term marketing strategy">    </p:cNvPr>
+          <p:cNvPr id="22" name="Long-term strategy icon" descr="Long-term strategy">    </p:cNvPr>
           <p:cNvPicPr>
             <a:picLocks noChangeAspect="1"/>
           </p:cNvPicPr>
@@ -3281,14 +3284,14 @@
               <a:buNone/>
             </a:pPr>
             <a:r>
-              <a:rPr lang="en-US" sz="1300" b="1" dirty="0">
+              <a:rPr lang="en-US" sz="1400" b="1" dirty="0">
                 <a:solidFill>
                   <a:schemeClr val="bg1"/>
                 </a:solidFill>
               </a:rPr>
-              <a:t>Long-term marketing strategy</a:t>
-            </a:r>
-            <a:endParaRPr lang="en-US" sz="1300" dirty="0"/>
+              <a:t>Long-term strategy</a:t>
+            </a:r>
+            <a:endParaRPr lang="en-US" sz="1400" dirty="0"/>
           </a:p>
         </p:txBody>
       </p:sp>
@@ -3394,7 +3397,7 @@
                   <a:schemeClr val="accent2"/>
                 </a:solidFill>
               </a:rPr>
-              <a:t>CONCLUSION</a:t>
+              <a:t>10  CONCLUSION</a:t>
             </a:r>
             <a:endParaRPr lang="en-US" sz="1200" dirty="0"/>
           </a:p>
@@ -3435,7 +3438,7 @@
                 <a:ea typeface="Cambria" pitchFamily="34" charset="-122"/>
                 <a:cs typeface="Cambria" pitchFamily="34" charset="-120"/>
               </a:rPr>
-              <a:t>Let's Grow Your Business Together!</a:t>
+              <a:t>Let's Grow Together!</a:t>
             </a:r>
             <a:endParaRPr lang="en-US" sz="4000" dirty="0"/>
           </a:p>
@@ -3473,7 +3476,7 @@
                   <a:schemeClr val="accent2"/>
                 </a:solidFill>
               </a:rPr>
-              <a:t>We're ready to turn this plan into action.</a:t>
+              <a:t>We're ready to help The Daily Cup grow and reach more customers.</a:t>
             </a:r>
             <a:endParaRPr lang="en-US" sz="1500" dirty="0"/>
           </a:p>
@@ -3509,7 +3512,7 @@
                   <a:schemeClr val="accent2"/>
                 </a:solidFill>
               </a:rPr>
-              <a:t>[Agency Name]   |   [Phone]   |   [Email]</a:t>
+              <a:t>BrandBrew Marketing   |   [Phone]   |   [Email]</a:t>
             </a:r>
             <a:endParaRPr lang="en-US" sz="1300" dirty="0"/>
           </a:p>
@@ -3645,7 +3648,7 @@
       </p:sp>
       <p:pic>
         <p:nvPicPr>
-          <p:cNvPr id="4" name="Strategy focus illustration" descr="Strategy focus illustration">    </p:cNvPr>
+          <p:cNvPr id="4" name="Social media, online ads and content illustration" descr="Social media, online ads and content illustration">    </p:cNvPr>
           <p:cNvPicPr>
             <a:picLocks noChangeAspect="1"/>
           </p:cNvPicPr>
@@ -3676,7 +3679,7 @@
         <p:spPr>
           <a:xfrm>
             <a:off x="4389120" y="1325880"/>
-            <a:ext cx="4297680" cy="868680"/>
+            <a:ext cx="4297680" cy="457200"/>
           </a:xfrm>
           <a:prstGeom prst="rect">
             <a:avLst/>
@@ -3700,7 +3703,7 @@
                 <a:ea typeface="Cambria" pitchFamily="34" charset="-122"/>
                 <a:cs typeface="Cambria" pitchFamily="34" charset="-120"/>
               </a:rPr>
-              <a:t>More people discover, visit and come back to [Café Name].</a:t>
+              <a:t>Our goal: help The Daily Cup grow</a:t>
             </a:r>
             <a:endParaRPr lang="en-US" sz="2000" dirty="0"/>
           </a:p>
@@ -3708,13 +3711,13 @@
       </p:sp>
       <p:sp>
         <p:nvSpPr>
-          <p:cNvPr id="6" name="Stronger online presence circle"/>
-          <p:cNvSpPr/>
-          <p:nvPr/>
-        </p:nvSpPr>
-        <p:spPr>
-          <a:xfrm>
-            <a:off x="4389120" y="2377440"/>
+          <p:cNvPr id="6" name="Increase brand awareness circle"/>
+          <p:cNvSpPr/>
+          <p:nvPr/>
+        </p:nvSpPr>
+        <p:spPr>
+          <a:xfrm>
+            <a:off x="4389120" y="2011680"/>
             <a:ext cx="457200" cy="457200"/>
           </a:xfrm>
           <a:prstGeom prst="ellipse">
@@ -3728,7 +3731,7 @@
       </p:sp>
       <p:pic>
         <p:nvPicPr>
-          <p:cNvPr id="7" name="Stronger online presence icon" descr="Stronger online presence">    </p:cNvPr>
+          <p:cNvPr id="7" name="Increase brand awareness icon" descr="Increase brand awareness">    </p:cNvPr>
           <p:cNvPicPr>
             <a:picLocks noChangeAspect="1"/>
           </p:cNvPicPr>
@@ -3742,7 +3745,7 @@
         </p:blipFill>
         <p:spPr>
           <a:xfrm>
-            <a:off x="4512564" y="2500884"/>
+            <a:off x="4512564" y="2135124"/>
             <a:ext cx="210312" cy="210312"/>
           </a:xfrm>
           <a:prstGeom prst="rect">
@@ -3758,7 +3761,7 @@
         </p:nvSpPr>
         <p:spPr>
           <a:xfrm>
-            <a:off x="5029200" y="2377440"/>
+            <a:off x="5029200" y="2011680"/>
             <a:ext cx="3657600" cy="457200"/>
           </a:xfrm>
           <a:prstGeom prst="rect">
@@ -3780,7 +3783,7 @@
                   <a:schemeClr val="tx2"/>
                 </a:solidFill>
               </a:rPr>
-              <a:t>Stronger online presence</a:t>
+              <a:t>Increase brand awareness</a:t>
             </a:r>
             <a:endParaRPr lang="en-US" sz="1600" dirty="0"/>
           </a:p>
@@ -3788,13 +3791,13 @@
       </p:sp>
       <p:sp>
         <p:nvSpPr>
-          <p:cNvPr id="9" name="New customers circle"/>
-          <p:cNvSpPr/>
-          <p:nvPr/>
-        </p:nvSpPr>
-        <p:spPr>
-          <a:xfrm>
-            <a:off x="4389120" y="3108960"/>
+          <p:cNvPr id="9" name="Attract more customers circle"/>
+          <p:cNvSpPr/>
+          <p:nvPr/>
+        </p:nvSpPr>
+        <p:spPr>
+          <a:xfrm>
+            <a:off x="4389120" y="2670048"/>
             <a:ext cx="457200" cy="457200"/>
           </a:xfrm>
           <a:prstGeom prst="ellipse">
@@ -3808,7 +3811,7 @@
       </p:sp>
       <p:pic>
         <p:nvPicPr>
-          <p:cNvPr id="10" name="New customers icon" descr="New customers">    </p:cNvPr>
+          <p:cNvPr id="10" name="Attract more customers icon" descr="Attract more customers">    </p:cNvPr>
           <p:cNvPicPr>
             <a:picLocks noChangeAspect="1"/>
           </p:cNvPicPr>
@@ -3822,7 +3825,7 @@
         </p:blipFill>
         <p:spPr>
           <a:xfrm>
-            <a:off x="4512564" y="3232404"/>
+            <a:off x="4512564" y="2793492"/>
             <a:ext cx="210312" cy="210312"/>
           </a:xfrm>
           <a:prstGeom prst="rect">
@@ -3838,7 +3841,7 @@
         </p:nvSpPr>
         <p:spPr>
           <a:xfrm>
-            <a:off x="5029200" y="3108960"/>
+            <a:off x="5029200" y="2670048"/>
             <a:ext cx="3657600" cy="457200"/>
           </a:xfrm>
           <a:prstGeom prst="rect">
@@ -3860,7 +3863,7 @@
                   <a:schemeClr val="tx2"/>
                 </a:solidFill>
               </a:rPr>
-              <a:t>New customers</a:t>
+              <a:t>Attract more customers</a:t>
             </a:r>
             <a:endParaRPr lang="en-US" sz="1600" dirty="0"/>
           </a:p>
@@ -3868,13 +3871,13 @@
       </p:sp>
       <p:sp>
         <p:nvSpPr>
-          <p:cNvPr id="12" name="Customers who return circle"/>
-          <p:cNvSpPr/>
-          <p:nvPr/>
-        </p:nvSpPr>
-        <p:spPr>
-          <a:xfrm>
-            <a:off x="4389120" y="3840480"/>
+          <p:cNvPr id="12" name="Increase sales circle"/>
+          <p:cNvSpPr/>
+          <p:nvPr/>
+        </p:nvSpPr>
+        <p:spPr>
+          <a:xfrm>
+            <a:off x="4389120" y="3328416"/>
             <a:ext cx="457200" cy="457200"/>
           </a:xfrm>
           <a:prstGeom prst="ellipse">
@@ -3888,7 +3891,7 @@
       </p:sp>
       <p:pic>
         <p:nvPicPr>
-          <p:cNvPr id="13" name="Customers who return icon" descr="Customers who return">    </p:cNvPr>
+          <p:cNvPr id="13" name="Increase sales icon" descr="Increase sales">    </p:cNvPr>
           <p:cNvPicPr>
             <a:picLocks noChangeAspect="1"/>
           </p:cNvPicPr>
@@ -3902,7 +3905,7 @@
         </p:blipFill>
         <p:spPr>
           <a:xfrm>
-            <a:off x="4512564" y="3963924"/>
+            <a:off x="4512564" y="3451860"/>
             <a:ext cx="210312" cy="210312"/>
           </a:xfrm>
           <a:prstGeom prst="rect">
@@ -3918,7 +3921,7 @@
         </p:nvSpPr>
         <p:spPr>
           <a:xfrm>
-            <a:off x="5029200" y="3840480"/>
+            <a:off x="5029200" y="3328416"/>
             <a:ext cx="3657600" cy="457200"/>
           </a:xfrm>
           <a:prstGeom prst="rect">
@@ -3940,7 +3943,87 @@
                   <a:schemeClr val="tx2"/>
                 </a:solidFill>
               </a:rPr>
-              <a:t>Customers who return</a:t>
+              <a:t>Increase sales</a:t>
+            </a:r>
+            <a:endParaRPr lang="en-US" sz="1600" dirty="0"/>
+          </a:p>
+        </p:txBody>
+      </p:sp>
+      <p:sp>
+        <p:nvSpPr>
+          <p:cNvPr id="15" name="Improve social media presence circle"/>
+          <p:cNvSpPr/>
+          <p:nvPr/>
+        </p:nvSpPr>
+        <p:spPr>
+          <a:xfrm>
+            <a:off x="4389120" y="3986784"/>
+            <a:ext cx="457200" cy="457200"/>
+          </a:xfrm>
+          <a:prstGeom prst="ellipse">
+            <a:avLst/>
+          </a:prstGeom>
+          <a:solidFill>
+            <a:schemeClr val="accent1"/>
+          </a:solidFill>
+          <a:ln/>
+        </p:spPr>
+      </p:sp>
+      <p:pic>
+        <p:nvPicPr>
+          <p:cNvPr id="16" name="Improve social media presence icon" descr="Improve social media presence">    </p:cNvPr>
+          <p:cNvPicPr>
+            <a:picLocks noChangeAspect="1"/>
+          </p:cNvPicPr>
+          <p:nvPr/>
+        </p:nvPicPr>
+        <p:blipFill>
+          <a:blip r:embed="rId5"/>
+          <a:stretch>
+            <a:fillRect/>
+          </a:stretch>
+        </p:blipFill>
+        <p:spPr>
+          <a:xfrm>
+            <a:off x="4512564" y="4110228"/>
+            <a:ext cx="210312" cy="210312"/>
+          </a:xfrm>
+          <a:prstGeom prst="rect">
+            <a:avLst/>
+          </a:prstGeom>
+        </p:spPr>
+      </p:pic>
+      <p:sp>
+        <p:nvSpPr>
+          <p:cNvPr id="17" name="Row text 4"/>
+          <p:cNvSpPr txBox="1"/>
+          <p:nvPr/>
+        </p:nvSpPr>
+        <p:spPr>
+          <a:xfrm>
+            <a:off x="5029200" y="3986784"/>
+            <a:ext cx="3657600" cy="457200"/>
+          </a:xfrm>
+          <a:prstGeom prst="rect">
+            <a:avLst/>
+          </a:prstGeom>
+          <a:noFill/>
+          <a:ln/>
+        </p:spPr>
+        <p:txBody>
+          <a:bodyPr wrap="square" lIns="0" tIns="0" rIns="0" bIns="0" rtlCol="0" anchor="ctr"/>
+          <a:lstStyle/>
+          <a:p>
+            <a:pPr indent="0" marL="0">
+              <a:buNone/>
+            </a:pPr>
+            <a:r>
+              <a:rPr lang="en-US" sz="1600" b="1" dirty="0">
+                <a:solidFill>
+                  <a:schemeClr val="tx2"/>
+                </a:solidFill>
+              </a:rPr>
+              <a:t>Improve social media presence</a:t>
             </a:r>
             <a:endParaRPr lang="en-US" sz="1600" dirty="0"/>
           </a:p>
@@ -4089,7 +4172,7 @@
                 <a:ea typeface="Cambria" pitchFamily="34" charset="-122"/>
                 <a:cs typeface="Cambria" pitchFamily="34" charset="-120"/>
               </a:rPr>
-              <a:t>What's Holding the Café Back</a:t>
+              <a:t>The Challenges</a:t>
             </a:r>
             <a:endParaRPr lang="en-US" sz="3200" dirty="0"/>
           </a:p>
@@ -4177,7 +4260,7 @@
       </p:sp>
       <p:sp>
         <p:nvSpPr>
-          <p:cNvPr id="7" name="Limited reach on social media circle"/>
+          <p:cNvPr id="7" name="Few followers, low engagement circle"/>
           <p:cNvSpPr/>
           <p:nvPr/>
         </p:nvSpPr>
@@ -4197,7 +4280,7 @@
       </p:sp>
       <p:pic>
         <p:nvPicPr>
-          <p:cNvPr id="8" name="Limited reach on social media icon" descr="Limited reach on social media">    </p:cNvPr>
+          <p:cNvPr id="8" name="Few followers, low engagement icon" descr="Few followers, low engagement">    </p:cNvPr>
           <p:cNvPicPr>
             <a:picLocks noChangeAspect="1"/>
           </p:cNvPicPr>
@@ -4249,7 +4332,7 @@
                   <a:schemeClr val="tx2"/>
                 </a:solidFill>
               </a:rPr>
-              <a:t>Limited reach on social media</a:t>
+              <a:t>Few followers, low engagement</a:t>
             </a:r>
             <a:endParaRPr lang="en-US" sz="1600" dirty="0"/>
           </a:p>
@@ -4337,7 +4420,7 @@
       </p:sp>
       <p:sp>
         <p:nvSpPr>
-          <p:cNvPr id="13" name="Few new customers, low engagement circle"/>
+          <p:cNvPr id="13" name="Hard to attract new customers circle"/>
           <p:cNvSpPr/>
           <p:nvPr/>
         </p:nvSpPr>
@@ -4357,7 +4440,7 @@
       </p:sp>
       <p:pic>
         <p:nvPicPr>
-          <p:cNvPr id="14" name="Few new customers, low engagement icon" descr="Few new customers, low engagement">    </p:cNvPr>
+          <p:cNvPr id="14" name="Hard to attract new customers icon" descr="Hard to attract new customers">    </p:cNvPr>
           <p:cNvPicPr>
             <a:picLocks noChangeAspect="1"/>
           </p:cNvPicPr>
@@ -4409,7 +4492,7 @@
                   <a:schemeClr val="tx2"/>
                 </a:solidFill>
               </a:rPr>
-              <a:t>Few new customers, low engagement</a:t>
+              <a:t>Hard to attract new customers</a:t>
             </a:r>
             <a:endParaRPr lang="en-US" sz="1600" dirty="0"/>
           </a:p>
@@ -4417,7 +4500,7 @@
       </p:sp>
       <p:sp>
         <p:nvSpPr>
-          <p:cNvPr id="16" name="No clear digital marketing strategy circle"/>
+          <p:cNvPr id="16" name="Low sales in some periods circle"/>
           <p:cNvSpPr/>
           <p:nvPr/>
         </p:nvSpPr>
@@ -4437,7 +4520,7 @@
       </p:sp>
       <p:pic>
         <p:nvPicPr>
-          <p:cNvPr id="17" name="No clear digital marketing strategy icon" descr="No clear digital marketing strategy">    </p:cNvPr>
+          <p:cNvPr id="17" name="Low sales in some periods icon" descr="Low sales in some periods">    </p:cNvPr>
           <p:cNvPicPr>
             <a:picLocks noChangeAspect="1"/>
           </p:cNvPicPr>
@@ -4489,7 +4572,7 @@
                   <a:schemeClr val="tx2"/>
                 </a:solidFill>
               </a:rPr>
-              <a:t>No clear digital marketing strategy</a:t>
+              <a:t>Low sales in some periods</a:t>
             </a:r>
             <a:endParaRPr lang="en-US" sz="1600" dirty="0"/>
           </a:p>
@@ -4662,7 +4745,7 @@
                 <a:ea typeface="Cambria" pitchFamily="34" charset="-122"/>
                 <a:cs typeface="Cambria" pitchFamily="34" charset="-120"/>
               </a:rPr>
-              <a:t>Our 4-Part Marketing Plan</a:t>
+              <a:t>Our Four Main Services</a:t>
             </a:r>
             <a:endParaRPr lang="en-US" sz="3200" dirty="0"/>
           </a:p>
@@ -4670,7 +4753,7 @@
       </p:sp>
       <p:sp>
         <p:nvSpPr>
-          <p:cNvPr id="4" name="Solution card 1"/>
+          <p:cNvPr id="4" name="Service card 1"/>
           <p:cNvSpPr/>
           <p:nvPr/>
         </p:nvSpPr>
@@ -4716,7 +4799,7 @@
       </p:pic>
       <p:sp>
         <p:nvSpPr>
-          <p:cNvPr id="6" name="Solution title 1"/>
+          <p:cNvPr id="6" name="Service title 1"/>
           <p:cNvSpPr txBox="1"/>
           <p:nvPr/>
         </p:nvSpPr>
@@ -4752,7 +4835,7 @@
       </p:sp>
       <p:sp>
         <p:nvSpPr>
-          <p:cNvPr id="7" name="Solution text 1"/>
+          <p:cNvPr id="7" name="Service text 1"/>
           <p:cNvSpPr txBox="1"/>
           <p:nvPr/>
         </p:nvSpPr>
@@ -4775,20 +4858,20 @@
               <a:buNone/>
             </a:pPr>
             <a:r>
-              <a:rPr lang="en-US" sz="1200" dirty="0">
+              <a:rPr lang="en-US" sz="1300" dirty="0">
                 <a:solidFill>
                   <a:schemeClr val="tx1"/>
                 </a:solidFill>
               </a:rPr>
-              <a:t>Posts, reels and stories on a steady schedule</a:t>
-            </a:r>
-            <a:endParaRPr lang="en-US" sz="1200" dirty="0"/>
-          </a:p>
-        </p:txBody>
-      </p:sp>
-      <p:sp>
-        <p:nvSpPr>
-          <p:cNvPr id="8" name="Solution card 2"/>
+              <a:t>Regular posts, reels and stories</a:t>
+            </a:r>
+            <a:endParaRPr lang="en-US" sz="1300" dirty="0"/>
+          </a:p>
+        </p:txBody>
+      </p:sp>
+      <p:sp>
+        <p:nvSpPr>
+          <p:cNvPr id="8" name="Service card 2"/>
           <p:cNvSpPr/>
           <p:nvPr/>
         </p:nvSpPr>
@@ -4834,7 +4917,7 @@
       </p:pic>
       <p:sp>
         <p:nvSpPr>
-          <p:cNvPr id="10" name="Solution title 2"/>
+          <p:cNvPr id="10" name="Service title 2"/>
           <p:cNvSpPr txBox="1"/>
           <p:nvPr/>
         </p:nvSpPr>
@@ -4870,7 +4953,7 @@
       </p:sp>
       <p:sp>
         <p:nvSpPr>
-          <p:cNvPr id="11" name="Solution text 2"/>
+          <p:cNvPr id="11" name="Service text 2"/>
           <p:cNvSpPr txBox="1"/>
           <p:nvPr/>
         </p:nvSpPr>
@@ -4893,20 +4976,20 @@
               <a:buNone/>
             </a:pPr>
             <a:r>
-              <a:rPr lang="en-US" sz="1200" dirty="0">
+              <a:rPr lang="en-US" sz="1300" dirty="0">
                 <a:solidFill>
                   <a:schemeClr val="tx1"/>
                 </a:solidFill>
               </a:rPr>
-              <a:t>Facebook and Instagram ads for people nearby</a:t>
-            </a:r>
-            <a:endParaRPr lang="en-US" sz="1200" dirty="0"/>
-          </a:p>
-        </p:txBody>
-      </p:sp>
-      <p:sp>
-        <p:nvSpPr>
-          <p:cNvPr id="12" name="Solution card 3"/>
+              <a:t>Facebook and Instagram ads</a:t>
+            </a:r>
+            <a:endParaRPr lang="en-US" sz="1300" dirty="0"/>
+          </a:p>
+        </p:txBody>
+      </p:sp>
+      <p:sp>
+        <p:nvSpPr>
+          <p:cNvPr id="12" name="Service card 3"/>
           <p:cNvSpPr/>
           <p:nvPr/>
         </p:nvSpPr>
@@ -4952,7 +5035,7 @@
       </p:pic>
       <p:sp>
         <p:nvSpPr>
-          <p:cNvPr id="14" name="Solution title 3"/>
+          <p:cNvPr id="14" name="Service title 3"/>
           <p:cNvSpPr txBox="1"/>
           <p:nvPr/>
         </p:nvSpPr>
@@ -4988,7 +5071,7 @@
       </p:sp>
       <p:sp>
         <p:nvSpPr>
-          <p:cNvPr id="15" name="Solution text 3"/>
+          <p:cNvPr id="15" name="Service text 3"/>
           <p:cNvSpPr txBox="1"/>
           <p:nvPr/>
         </p:nvSpPr>
@@ -5011,20 +5094,20 @@
               <a:buNone/>
             </a:pPr>
             <a:r>
-              <a:rPr lang="en-US" sz="1200" dirty="0">
+              <a:rPr lang="en-US" sz="1300" dirty="0">
                 <a:solidFill>
                   <a:schemeClr val="tx1"/>
                 </a:solidFill>
               </a:rPr>
-              <a:t>Photos and videos of drinks, food and the vibe</a:t>
-            </a:r>
-            <a:endParaRPr lang="en-US" sz="1200" dirty="0"/>
-          </a:p>
-        </p:txBody>
-      </p:sp>
-      <p:sp>
-        <p:nvSpPr>
-          <p:cNvPr id="16" name="Solution card 4"/>
+              <a:t>Attractive photos and videos of products</a:t>
+            </a:r>
+            <a:endParaRPr lang="en-US" sz="1300" dirty="0"/>
+          </a:p>
+        </p:txBody>
+      </p:sp>
+      <p:sp>
+        <p:nvSpPr>
+          <p:cNvPr id="16" name="Service card 4"/>
           <p:cNvSpPr/>
           <p:nvPr/>
         </p:nvSpPr>
@@ -5046,7 +5129,7 @@
       </p:sp>
       <p:pic>
         <p:nvPicPr>
-          <p:cNvPr id="17" name="Customer Engagement illustration" descr="Customer Engagement illustration">    </p:cNvPr>
+          <p:cNvPr id="17" name="Promotions illustration" descr="Promotions illustration">    </p:cNvPr>
           <p:cNvPicPr>
             <a:picLocks noChangeAspect="1"/>
           </p:cNvPicPr>
@@ -5070,7 +5153,7 @@
       </p:pic>
       <p:sp>
         <p:nvSpPr>
-          <p:cNvPr id="18" name="Solution title 4"/>
+          <p:cNvPr id="18" name="Service title 4"/>
           <p:cNvSpPr txBox="1"/>
           <p:nvPr/>
         </p:nvSpPr>
@@ -5098,7 +5181,7 @@
                   <a:schemeClr val="tx2"/>
                 </a:solidFill>
               </a:rPr>
-              <a:t>Customer Engagement</a:t>
+              <a:t>Promotions</a:t>
             </a:r>
             <a:endParaRPr lang="en-US" sz="1500" dirty="0"/>
           </a:p>
@@ -5106,7 +5189,7 @@
       </p:sp>
       <p:sp>
         <p:nvSpPr>
-          <p:cNvPr id="19" name="Solution text 4"/>
+          <p:cNvPr id="19" name="Service text 4"/>
           <p:cNvSpPr txBox="1"/>
           <p:nvPr/>
         </p:nvSpPr>
@@ -5129,14 +5212,14 @@
               <a:buNone/>
             </a:pPr>
             <a:r>
-              <a:rPr lang="en-US" sz="1200" dirty="0">
+              <a:rPr lang="en-US" sz="1300" dirty="0">
                 <a:solidFill>
                   <a:schemeClr val="tx1"/>
                 </a:solidFill>
               </a:rPr>
-              <a:t>Replies, offers and loyalty rewards</a:t>
-            </a:r>
-            <a:endParaRPr lang="en-US" sz="1200" dirty="0"/>
+              <a:t>Discounts and special deals</a:t>
+            </a:r>
+            <a:endParaRPr lang="en-US" sz="1300" dirty="0"/>
           </a:p>
         </p:txBody>
       </p:sp>
@@ -5283,7 +5366,7 @@
                 <a:ea typeface="Cambria" pitchFamily="34" charset="-122"/>
                 <a:cs typeface="Cambria" pitchFamily="34" charset="-120"/>
               </a:rPr>
-              <a:t>How We'll Do It: 5 Steps</a:t>
+              <a:t>Five Simple Steps</a:t>
             </a:r>
             <a:endParaRPr lang="en-US" sz="3200" dirty="0"/>
           </a:p>
@@ -5478,20 +5561,20 @@
               <a:buNone/>
             </a:pPr>
             <a:r>
-              <a:rPr lang="en-US" sz="1200" dirty="0">
+              <a:rPr lang="en-US" sz="1300" dirty="0">
                 <a:solidFill>
                   <a:schemeClr val="tx1"/>
                 </a:solidFill>
               </a:rPr>
-              <a:t>Audience and competitors</a:t>
-            </a:r>
-            <a:endParaRPr lang="en-US" sz="1200" dirty="0"/>
-          </a:p>
-        </p:txBody>
-      </p:sp>
-      <p:sp>
-        <p:nvSpPr>
-          <p:cNvPr id="11" name="Planning circle"/>
+              <a:t>Market and competitors</a:t>
+            </a:r>
+            <a:endParaRPr lang="en-US" sz="1300" dirty="0"/>
+          </a:p>
+        </p:txBody>
+      </p:sp>
+      <p:sp>
+        <p:nvSpPr>
+          <p:cNvPr id="11" name="Audience circle"/>
           <p:cNvSpPr/>
           <p:nvPr/>
         </p:nvSpPr>
@@ -5511,7 +5594,7 @@
       </p:sp>
       <p:pic>
         <p:nvPicPr>
-          <p:cNvPr id="12" name="Planning icon" descr="Planning">    </p:cNvPr>
+          <p:cNvPr id="12" name="Audience icon" descr="Audience">    </p:cNvPr>
           <p:cNvPicPr>
             <a:picLocks noChangeAspect="1"/>
           </p:cNvPicPr>
@@ -5624,7 +5707,7 @@
                   <a:schemeClr val="tx2"/>
                 </a:solidFill>
               </a:rPr>
-              <a:t>Planning</a:t>
+              <a:t>Audience</a:t>
             </a:r>
             <a:endParaRPr lang="en-US" sz="1600" dirty="0"/>
           </a:p>
@@ -5655,20 +5738,20 @@
               <a:buNone/>
             </a:pPr>
             <a:r>
-              <a:rPr lang="en-US" sz="1200" dirty="0">
+              <a:rPr lang="en-US" sz="1300" dirty="0">
                 <a:solidFill>
                   <a:schemeClr val="tx1"/>
                 </a:solidFill>
               </a:rPr>
-              <a:t>Content calendar and ad strategy</a:t>
-            </a:r>
-            <a:endParaRPr lang="en-US" sz="1200" dirty="0"/>
-          </a:p>
-        </p:txBody>
-      </p:sp>
-      <p:sp>
-        <p:nvSpPr>
-          <p:cNvPr id="17" name="Execution circle"/>
+              <a:t>Identify who to target</a:t>
+            </a:r>
+            <a:endParaRPr lang="en-US" sz="1300" dirty="0"/>
+          </a:p>
+        </p:txBody>
+      </p:sp>
+      <p:sp>
+        <p:nvSpPr>
+          <p:cNvPr id="17" name="Content Plan circle"/>
           <p:cNvSpPr/>
           <p:nvPr/>
         </p:nvSpPr>
@@ -5681,14 +5764,14 @@
             <a:avLst/>
           </a:prstGeom>
           <a:solidFill>
-            <a:schemeClr val="accent1"/>
+            <a:schemeClr val="tx2"/>
           </a:solidFill>
           <a:ln/>
         </p:spPr>
       </p:sp>
       <p:pic>
         <p:nvPicPr>
-          <p:cNvPr id="18" name="Execution icon" descr="Execution">    </p:cNvPr>
+          <p:cNvPr id="18" name="Content Plan icon" descr="Content Plan">    </p:cNvPr>
           <p:cNvPicPr>
             <a:picLocks noChangeAspect="1"/>
           </p:cNvPicPr>
@@ -5801,7 +5884,7 @@
                   <a:schemeClr val="tx2"/>
                 </a:solidFill>
               </a:rPr>
-              <a:t>Execution</a:t>
+              <a:t>Content Plan</a:t>
             </a:r>
             <a:endParaRPr lang="en-US" sz="1600" dirty="0"/>
           </a:p>
@@ -5832,20 +5915,20 @@
               <a:buNone/>
             </a:pPr>
             <a:r>
-              <a:rPr lang="en-US" sz="1200" dirty="0">
+              <a:rPr lang="en-US" sz="1300" dirty="0">
                 <a:solidFill>
                   <a:schemeClr val="tx1"/>
                 </a:solidFill>
               </a:rPr>
-              <a:t>Publish content, launch ads</a:t>
-            </a:r>
-            <a:endParaRPr lang="en-US" sz="1200" dirty="0"/>
-          </a:p>
-        </p:txBody>
-      </p:sp>
-      <p:sp>
-        <p:nvSpPr>
-          <p:cNvPr id="23" name="Monitoring circle"/>
+              <a:t>A plan for the month</a:t>
+            </a:r>
+            <a:endParaRPr lang="en-US" sz="1300" dirty="0"/>
+          </a:p>
+        </p:txBody>
+      </p:sp>
+      <p:sp>
+        <p:nvSpPr>
+          <p:cNvPr id="23" name="Launch circle"/>
           <p:cNvSpPr/>
           <p:nvPr/>
         </p:nvSpPr>
@@ -5858,14 +5941,14 @@
             <a:avLst/>
           </a:prstGeom>
           <a:solidFill>
-            <a:schemeClr val="tx2"/>
+            <a:schemeClr val="accent1"/>
           </a:solidFill>
           <a:ln/>
         </p:spPr>
       </p:sp>
       <p:pic>
         <p:nvPicPr>
-          <p:cNvPr id="24" name="Monitoring icon" descr="Monitoring">    </p:cNvPr>
+          <p:cNvPr id="24" name="Launch icon" descr="Launch">    </p:cNvPr>
           <p:cNvPicPr>
             <a:picLocks noChangeAspect="1"/>
           </p:cNvPicPr>
@@ -5978,7 +6061,7 @@
                   <a:schemeClr val="tx2"/>
                 </a:solidFill>
               </a:rPr>
-              <a:t>Monitoring</a:t>
+              <a:t>Launch</a:t>
             </a:r>
             <a:endParaRPr lang="en-US" sz="1600" dirty="0"/>
           </a:p>
@@ -6009,20 +6092,20 @@
               <a:buNone/>
             </a:pPr>
             <a:r>
-              <a:rPr lang="en-US" sz="1200" dirty="0">
+              <a:rPr lang="en-US" sz="1300" dirty="0">
                 <a:solidFill>
                   <a:schemeClr val="tx1"/>
                 </a:solidFill>
               </a:rPr>
-              <a:t>Track reach, leads and sales</a:t>
-            </a:r>
-            <a:endParaRPr lang="en-US" sz="1200" dirty="0"/>
-          </a:p>
-        </p:txBody>
-      </p:sp>
-      <p:sp>
-        <p:nvSpPr>
-          <p:cNvPr id="29" name="Optimization circle"/>
+              <a:t>Publish content and ads</a:t>
+            </a:r>
+            <a:endParaRPr lang="en-US" sz="1300" dirty="0"/>
+          </a:p>
+        </p:txBody>
+      </p:sp>
+      <p:sp>
+        <p:nvSpPr>
+          <p:cNvPr id="29" name="Measure circle"/>
           <p:cNvSpPr/>
           <p:nvPr/>
         </p:nvSpPr>
@@ -6035,14 +6118,14 @@
             <a:avLst/>
           </a:prstGeom>
           <a:solidFill>
-            <a:schemeClr val="tx2"/>
+            <a:schemeClr val="accent4"/>
           </a:solidFill>
           <a:ln/>
         </p:spPr>
       </p:sp>
       <p:pic>
         <p:nvPicPr>
-          <p:cNvPr id="30" name="Optimization icon" descr="Optimization">    </p:cNvPr>
+          <p:cNvPr id="30" name="Measure icon" descr="Measure">    </p:cNvPr>
           <p:cNvPicPr>
             <a:picLocks noChangeAspect="1"/>
           </p:cNvPicPr>
@@ -6155,7 +6238,7 @@
                   <a:schemeClr val="tx2"/>
                 </a:solidFill>
               </a:rPr>
-              <a:t>Optimization</a:t>
+              <a:t>Measure</a:t>
             </a:r>
             <a:endParaRPr lang="en-US" sz="1600" dirty="0"/>
           </a:p>
@@ -6186,14 +6269,14 @@
               <a:buNone/>
             </a:pPr>
             <a:r>
-              <a:rPr lang="en-US" sz="1200" dirty="0">
+              <a:rPr lang="en-US" sz="1300" dirty="0">
                 <a:solidFill>
                   <a:schemeClr val="tx1"/>
                 </a:solidFill>
               </a:rPr>
-              <a:t>Improve using the data</a:t>
-            </a:r>
-            <a:endParaRPr lang="en-US" sz="1200" dirty="0"/>
+              <a:t>Track results and improve</a:t>
+            </a:r>
+            <a:endParaRPr lang="en-US" sz="1300" dirty="0"/>
           </a:p>
         </p:txBody>
       </p:sp>
@@ -6273,7 +6356,7 @@
                   <a:schemeClr val="tx2"/>
                 </a:solidFill>
               </a:rPr>
-              <a:t>Steps 3 to 5 repeat every week to keep improving</a:t>
+              <a:t>What we learn in step 5 improves next month's plan</a:t>
             </a:r>
             <a:endParaRPr lang="en-US" sz="1400" dirty="0"/>
           </a:p>
@@ -6422,7 +6505,7 @@
                 <a:ea typeface="Cambria" pitchFamily="34" charset="-122"/>
                 <a:cs typeface="Cambria" pitchFamily="34" charset="-120"/>
               </a:rPr>
-              <a:t>Monthly Investment</a:t>
+              <a:t>Monthly Budget</a:t>
             </a:r>
             <a:endParaRPr lang="en-US" sz="3200" dirty="0"/>
           </a:p>
@@ -6561,8 +6644,8 @@
         </p:nvSpPr>
         <p:spPr>
           <a:xfrm>
-            <a:off x="7406640" y="1463040"/>
-            <a:ext cx="1280160" cy="475488"/>
+            <a:off x="7223760" y="1463040"/>
+            <a:ext cx="1463040" cy="475488"/>
           </a:xfrm>
           <a:prstGeom prst="rect">
             <a:avLst/>
@@ -6583,7 +6666,7 @@
                   <a:schemeClr val="tx2"/>
                 </a:solidFill>
               </a:rPr>
-              <a:t>5,000</a:t>
+              <a:t>5,000 EGP</a:t>
             </a:r>
             <a:endParaRPr lang="en-US" sz="1500" dirty="0"/>
           </a:p>
@@ -6639,7 +6722,7 @@
                   <a:schemeClr val="tx1"/>
                 </a:solidFill>
               </a:rPr>
-              <a:t>Paid advertising budget</a:t>
+              <a:t>Paid advertising</a:t>
             </a:r>
             <a:endParaRPr lang="en-US" sz="1500" dirty="0"/>
           </a:p>
@@ -6653,8 +6736,8 @@
         </p:nvSpPr>
         <p:spPr>
           <a:xfrm>
-            <a:off x="7406640" y="2029968"/>
-            <a:ext cx="1280160" cy="475488"/>
+            <a:off x="7223760" y="2029968"/>
+            <a:ext cx="1463040" cy="475488"/>
           </a:xfrm>
           <a:prstGeom prst="rect">
             <a:avLst/>
@@ -6675,7 +6758,7 @@
                   <a:schemeClr val="tx2"/>
                 </a:solidFill>
               </a:rPr>
-              <a:t>4,000</a:t>
+              <a:t>4,000 EGP</a:t>
             </a:r>
             <a:endParaRPr lang="en-US" sz="1500" dirty="0"/>
           </a:p>
@@ -6696,7 +6779,7 @@
             <a:avLst/>
           </a:prstGeom>
           <a:solidFill>
-            <a:srgbClr val="6F4E37"/>
+            <a:srgbClr val="5B7F5E"/>
           </a:solidFill>
           <a:ln/>
         </p:spPr>
@@ -6745,8 +6828,8 @@
         </p:nvSpPr>
         <p:spPr>
           <a:xfrm>
-            <a:off x="7406640" y="2596896"/>
-            <a:ext cx="1280160" cy="475488"/>
+            <a:off x="7223760" y="2596896"/>
+            <a:ext cx="1463040" cy="475488"/>
           </a:xfrm>
           <a:prstGeom prst="rect">
             <a:avLst/>
@@ -6767,7 +6850,7 @@
                   <a:schemeClr val="tx2"/>
                 </a:solidFill>
               </a:rPr>
-              <a:t>3,000</a:t>
+              <a:t>3,000 EGP</a:t>
             </a:r>
             <a:endParaRPr lang="en-US" sz="1500" dirty="0"/>
           </a:p>
@@ -6837,8 +6920,8 @@
         </p:nvSpPr>
         <p:spPr>
           <a:xfrm>
-            <a:off x="7406640" y="3163824"/>
-            <a:ext cx="1280160" cy="475488"/>
+            <a:off x="7223760" y="3163824"/>
+            <a:ext cx="1463040" cy="475488"/>
           </a:xfrm>
           <a:prstGeom prst="rect">
             <a:avLst/>
@@ -6859,7 +6942,7 @@
                   <a:schemeClr val="tx2"/>
                 </a:solidFill>
               </a:rPr>
-              <a:t>1,000</a:t>
+              <a:t>1,000 EGP</a:t>
             </a:r>
             <a:endParaRPr lang="en-US" sz="1500" dirty="0"/>
           </a:p>
@@ -6917,7 +7000,7 @@
                   <a:schemeClr val="bg1"/>
                 </a:solidFill>
               </a:rPr>
-              <a:t>Total per month</a:t>
+              <a:t>Total</a:t>
             </a:r>
             <a:endParaRPr lang="en-US" sz="1500" dirty="0"/>
           </a:p>
@@ -6968,7 +7051,7 @@
         <p:spPr>
           <a:xfrm>
             <a:off x="4389120" y="4343400"/>
-            <a:ext cx="4297680" cy="365760"/>
+            <a:ext cx="4297680" cy="274320"/>
           </a:xfrm>
           <a:prstGeom prst="rect">
             <a:avLst/>
@@ -6989,7 +7072,7 @@
                   <a:schemeClr val="accent5"/>
                 </a:solidFill>
               </a:rPr>
-              <a:t>Illustrative one-month budget. The final quote will confirm taxes, photography and other production costs.</a:t>
+              <a:t>This is a proposed budget for the presentation.</a:t>
             </a:r>
             <a:endParaRPr lang="en-US" sz="1000" dirty="0"/>
           </a:p>
@@ -7138,7 +7221,7 @@
                 <a:ea typeface="Cambria" pitchFamily="34" charset="-122"/>
                 <a:cs typeface="Cambria" pitchFamily="34" charset="-120"/>
               </a:rPr>
-              <a:t>The First Month, Week by Week</a:t>
+              <a:t>The First Month</a:t>
             </a:r>
             <a:endParaRPr lang="en-US" sz="3200" dirty="0"/>
           </a:p>
@@ -7184,7 +7267,7 @@
             </a:avLst>
           </a:prstGeom>
           <a:solidFill>
-            <a:schemeClr val="accent1"/>
+            <a:schemeClr val="accent4"/>
           </a:solidFill>
           <a:ln/>
         </p:spPr>
@@ -7227,7 +7310,7 @@
       </p:sp>
       <p:sp>
         <p:nvSpPr>
-          <p:cNvPr id="7" name="Research and Planning circle"/>
+          <p:cNvPr id="7" name="Research and planning circle"/>
           <p:cNvSpPr/>
           <p:nvPr/>
         </p:nvSpPr>
@@ -7247,7 +7330,7 @@
       </p:sp>
       <p:pic>
         <p:nvPicPr>
-          <p:cNvPr id="8" name="Research and Planning icon" descr="Research and Planning">    </p:cNvPr>
+          <p:cNvPr id="8" name="Research and planning icon" descr="Research and planning">    </p:cNvPr>
           <p:cNvPicPr>
             <a:picLocks noChangeAspect="1"/>
           </p:cNvPicPr>
@@ -7271,101 +7354,7 @@
       </p:pic>
       <p:sp>
         <p:nvSpPr>
-          <p:cNvPr id="9" name="Week card 1"/>
-          <p:cNvSpPr/>
-          <p:nvPr/>
-        </p:nvSpPr>
-        <p:spPr>
-          <a:xfrm>
-            <a:off x="571500" y="2743200"/>
-            <a:ext cx="1828800" cy="1737360"/>
-          </a:xfrm>
-          <a:prstGeom prst="roundRect">
-            <a:avLst>
-              <a:gd name="adj" fmla="val 6316"/>
-            </a:avLst>
-          </a:prstGeom>
-          <a:solidFill>
-            <a:schemeClr val="bg2"/>
-          </a:solidFill>
-          <a:ln/>
-        </p:spPr>
-      </p:sp>
-      <p:sp>
-        <p:nvSpPr>
-          <p:cNvPr id="10" name="Week title 1"/>
-          <p:cNvSpPr txBox="1"/>
-          <p:nvPr/>
-        </p:nvSpPr>
-        <p:spPr>
-          <a:xfrm>
-            <a:off x="708660" y="2880360"/>
-            <a:ext cx="1554480" cy="548640"/>
-          </a:xfrm>
-          <a:prstGeom prst="rect">
-            <a:avLst/>
-          </a:prstGeom>
-          <a:noFill/>
-          <a:ln/>
-        </p:spPr>
-        <p:txBody>
-          <a:bodyPr wrap="square" lIns="0" tIns="0" rIns="0" bIns="0" rtlCol="0" anchor="t"/>
-          <a:lstStyle/>
-          <a:p>
-            <a:pPr indent="0" marL="0">
-              <a:buNone/>
-            </a:pPr>
-            <a:r>
-              <a:rPr lang="en-US" sz="1500" b="1" dirty="0">
-                <a:solidFill>
-                  <a:schemeClr val="tx2"/>
-                </a:solidFill>
-              </a:rPr>
-              <a:t>Research and Planning</a:t>
-            </a:r>
-            <a:endParaRPr lang="en-US" sz="1500" dirty="0"/>
-          </a:p>
-        </p:txBody>
-      </p:sp>
-      <p:sp>
-        <p:nvSpPr>
-          <p:cNvPr id="11" name="Week text 1"/>
-          <p:cNvSpPr txBox="1"/>
-          <p:nvPr/>
-        </p:nvSpPr>
-        <p:spPr>
-          <a:xfrm>
-            <a:off x="708660" y="3474720"/>
-            <a:ext cx="1554480" cy="914400"/>
-          </a:xfrm>
-          <a:prstGeom prst="rect">
-            <a:avLst/>
-          </a:prstGeom>
-          <a:noFill/>
-          <a:ln/>
-        </p:spPr>
-        <p:txBody>
-          <a:bodyPr wrap="square" lIns="0" tIns="0" rIns="0" bIns="0" rtlCol="0" anchor="t"/>
-          <a:lstStyle/>
-          <a:p>
-            <a:pPr indent="0" marL="0">
-              <a:buNone/>
-            </a:pPr>
-            <a:r>
-              <a:rPr lang="en-US" sz="1200" dirty="0">
-                <a:solidFill>
-                  <a:schemeClr val="tx1"/>
-                </a:solidFill>
-              </a:rPr>
-              <a:t>Study the market, competitors and audience</a:t>
-            </a:r>
-            <a:endParaRPr lang="en-US" sz="1200" dirty="0"/>
-          </a:p>
-        </p:txBody>
-      </p:sp>
-      <p:sp>
-        <p:nvSpPr>
-          <p:cNvPr id="12" name="Week pill 2"/>
+          <p:cNvPr id="9" name="Week pill 2"/>
           <p:cNvSpPr/>
           <p:nvPr/>
         </p:nvSpPr>
@@ -7380,14 +7369,14 @@
             </a:avLst>
           </a:prstGeom>
           <a:solidFill>
-            <a:schemeClr val="accent1"/>
+            <a:schemeClr val="accent4"/>
           </a:solidFill>
           <a:ln/>
         </p:spPr>
       </p:sp>
       <p:sp>
         <p:nvSpPr>
-          <p:cNvPr id="13" name="Week label 2"/>
+          <p:cNvPr id="10" name="Week label 2"/>
           <p:cNvSpPr txBox="1"/>
           <p:nvPr/>
         </p:nvSpPr>
@@ -7423,7 +7412,7 @@
       </p:sp>
       <p:sp>
         <p:nvSpPr>
-          <p:cNvPr id="14" name="Content Creation circle"/>
+          <p:cNvPr id="11" name="Content creation circle"/>
           <p:cNvSpPr/>
           <p:nvPr/>
         </p:nvSpPr>
@@ -7443,7 +7432,7 @@
       </p:sp>
       <p:pic>
         <p:nvPicPr>
-          <p:cNvPr id="15" name="Content Creation icon" descr="Content Creation">    </p:cNvPr>
+          <p:cNvPr id="12" name="Content creation icon" descr="Content creation">    </p:cNvPr>
           <p:cNvPicPr>
             <a:picLocks noChangeAspect="1"/>
           </p:cNvPicPr>
@@ -7467,101 +7456,7 @@
       </p:pic>
       <p:sp>
         <p:nvSpPr>
-          <p:cNvPr id="16" name="Week card 2"/>
-          <p:cNvSpPr/>
-          <p:nvPr/>
-        </p:nvSpPr>
-        <p:spPr>
-          <a:xfrm>
-            <a:off x="2628900" y="2743200"/>
-            <a:ext cx="1828800" cy="1737360"/>
-          </a:xfrm>
-          <a:prstGeom prst="roundRect">
-            <a:avLst>
-              <a:gd name="adj" fmla="val 6316"/>
-            </a:avLst>
-          </a:prstGeom>
-          <a:solidFill>
-            <a:schemeClr val="bg2"/>
-          </a:solidFill>
-          <a:ln/>
-        </p:spPr>
-      </p:sp>
-      <p:sp>
-        <p:nvSpPr>
-          <p:cNvPr id="17" name="Week title 2"/>
-          <p:cNvSpPr txBox="1"/>
-          <p:nvPr/>
-        </p:nvSpPr>
-        <p:spPr>
-          <a:xfrm>
-            <a:off x="2766060" y="2880360"/>
-            <a:ext cx="1554480" cy="548640"/>
-          </a:xfrm>
-          <a:prstGeom prst="rect">
-            <a:avLst/>
-          </a:prstGeom>
-          <a:noFill/>
-          <a:ln/>
-        </p:spPr>
-        <p:txBody>
-          <a:bodyPr wrap="square" lIns="0" tIns="0" rIns="0" bIns="0" rtlCol="0" anchor="t"/>
-          <a:lstStyle/>
-          <a:p>
-            <a:pPr indent="0" marL="0">
-              <a:buNone/>
-            </a:pPr>
-            <a:r>
-              <a:rPr lang="en-US" sz="1500" b="1" dirty="0">
-                <a:solidFill>
-                  <a:schemeClr val="tx2"/>
-                </a:solidFill>
-              </a:rPr>
-              <a:t>Content Creation</a:t>
-            </a:r>
-            <a:endParaRPr lang="en-US" sz="1500" dirty="0"/>
-          </a:p>
-        </p:txBody>
-      </p:sp>
-      <p:sp>
-        <p:nvSpPr>
-          <p:cNvPr id="18" name="Week text 2"/>
-          <p:cNvSpPr txBox="1"/>
-          <p:nvPr/>
-        </p:nvSpPr>
-        <p:spPr>
-          <a:xfrm>
-            <a:off x="2766060" y="3474720"/>
-            <a:ext cx="1554480" cy="914400"/>
-          </a:xfrm>
-          <a:prstGeom prst="rect">
-            <a:avLst/>
-          </a:prstGeom>
-          <a:noFill/>
-          <a:ln/>
-        </p:spPr>
-        <p:txBody>
-          <a:bodyPr wrap="square" lIns="0" tIns="0" rIns="0" bIns="0" rtlCol="0" anchor="t"/>
-          <a:lstStyle/>
-          <a:p>
-            <a:pPr indent="0" marL="0">
-              <a:buNone/>
-            </a:pPr>
-            <a:r>
-              <a:rPr lang="en-US" sz="1200" dirty="0">
-                <a:solidFill>
-                  <a:schemeClr val="tx1"/>
-                </a:solidFill>
-              </a:rPr>
-              <a:t>Prepare posts, videos and ad designs</a:t>
-            </a:r>
-            <a:endParaRPr lang="en-US" sz="1200" dirty="0"/>
-          </a:p>
-        </p:txBody>
-      </p:sp>
-      <p:sp>
-        <p:nvSpPr>
-          <p:cNvPr id="19" name="Week pill 3"/>
+          <p:cNvPr id="13" name="Week pill 3"/>
           <p:cNvSpPr/>
           <p:nvPr/>
         </p:nvSpPr>
@@ -7576,70 +7471,70 @@
             </a:avLst>
           </a:prstGeom>
           <a:solidFill>
+            <a:schemeClr val="accent4"/>
+          </a:solidFill>
+          <a:ln/>
+        </p:spPr>
+      </p:sp>
+      <p:sp>
+        <p:nvSpPr>
+          <p:cNvPr id="14" name="Week label 3"/>
+          <p:cNvSpPr txBox="1"/>
+          <p:nvPr/>
+        </p:nvSpPr>
+        <p:spPr>
+          <a:xfrm>
+            <a:off x="5097780" y="1298448"/>
+            <a:ext cx="1005840" cy="310896"/>
+          </a:xfrm>
+          <a:prstGeom prst="rect">
+            <a:avLst/>
+          </a:prstGeom>
+          <a:noFill/>
+          <a:ln/>
+        </p:spPr>
+        <p:txBody>
+          <a:bodyPr wrap="square" lIns="0" tIns="0" rIns="0" bIns="0" rtlCol="0" anchor="ctr"/>
+          <a:lstStyle/>
+          <a:p>
+            <a:pPr algn="ctr" indent="0" marL="0">
+              <a:buNone/>
+            </a:pPr>
+            <a:r>
+              <a:rPr lang="en-US" sz="1100" b="1" spc="100" kern="0" dirty="0">
+                <a:solidFill>
+                  <a:schemeClr val="bg1"/>
+                </a:solidFill>
+              </a:rPr>
+              <a:t>WEEK 3</a:t>
+            </a:r>
+            <a:endParaRPr lang="en-US" sz="1100" dirty="0"/>
+          </a:p>
+        </p:txBody>
+      </p:sp>
+      <p:sp>
+        <p:nvSpPr>
+          <p:cNvPr id="15" name="Launch marketing campaigns circle"/>
+          <p:cNvSpPr/>
+          <p:nvPr/>
+        </p:nvSpPr>
+        <p:spPr>
+          <a:xfrm>
+            <a:off x="5216652" y="1719072"/>
+            <a:ext cx="768096" cy="768096"/>
+          </a:xfrm>
+          <a:prstGeom prst="ellipse">
+            <a:avLst/>
+          </a:prstGeom>
+          <a:solidFill>
             <a:schemeClr val="accent1"/>
           </a:solidFill>
           <a:ln/>
         </p:spPr>
       </p:sp>
-      <p:sp>
-        <p:nvSpPr>
-          <p:cNvPr id="20" name="Week label 3"/>
-          <p:cNvSpPr txBox="1"/>
-          <p:nvPr/>
-        </p:nvSpPr>
-        <p:spPr>
-          <a:xfrm>
-            <a:off x="5097780" y="1298448"/>
-            <a:ext cx="1005840" cy="310896"/>
-          </a:xfrm>
-          <a:prstGeom prst="rect">
-            <a:avLst/>
-          </a:prstGeom>
-          <a:noFill/>
-          <a:ln/>
-        </p:spPr>
-        <p:txBody>
-          <a:bodyPr wrap="square" lIns="0" tIns="0" rIns="0" bIns="0" rtlCol="0" anchor="ctr"/>
-          <a:lstStyle/>
-          <a:p>
-            <a:pPr algn="ctr" indent="0" marL="0">
-              <a:buNone/>
-            </a:pPr>
-            <a:r>
-              <a:rPr lang="en-US" sz="1100" b="1" spc="100" kern="0" dirty="0">
-                <a:solidFill>
-                  <a:schemeClr val="bg1"/>
-                </a:solidFill>
-              </a:rPr>
-              <a:t>WEEK 3</a:t>
-            </a:r>
-            <a:endParaRPr lang="en-US" sz="1100" dirty="0"/>
-          </a:p>
-        </p:txBody>
-      </p:sp>
-      <p:sp>
-        <p:nvSpPr>
-          <p:cNvPr id="21" name="Campaign Launch circle"/>
-          <p:cNvSpPr/>
-          <p:nvPr/>
-        </p:nvSpPr>
-        <p:spPr>
-          <a:xfrm>
-            <a:off x="5216652" y="1719072"/>
-            <a:ext cx="768096" cy="768096"/>
-          </a:xfrm>
-          <a:prstGeom prst="ellipse">
-            <a:avLst/>
-          </a:prstGeom>
-          <a:solidFill>
-            <a:schemeClr val="tx2"/>
-          </a:solidFill>
-          <a:ln/>
-        </p:spPr>
-      </p:sp>
       <p:pic>
         <p:nvPicPr>
-          <p:cNvPr id="22" name="Campaign Launch icon" descr="Campaign Launch">    </p:cNvPr>
+          <p:cNvPr id="16" name="Launch marketing campaigns icon" descr="Launch marketing campaigns">    </p:cNvPr>
           <p:cNvPicPr>
             <a:picLocks noChangeAspect="1"/>
           </p:cNvPicPr>
@@ -7663,101 +7558,7 @@
       </p:pic>
       <p:sp>
         <p:nvSpPr>
-          <p:cNvPr id="23" name="Week card 3"/>
-          <p:cNvSpPr/>
-          <p:nvPr/>
-        </p:nvSpPr>
-        <p:spPr>
-          <a:xfrm>
-            <a:off x="4686300" y="2743200"/>
-            <a:ext cx="1828800" cy="1737360"/>
-          </a:xfrm>
-          <a:prstGeom prst="roundRect">
-            <a:avLst>
-              <a:gd name="adj" fmla="val 6316"/>
-            </a:avLst>
-          </a:prstGeom>
-          <a:solidFill>
-            <a:schemeClr val="bg2"/>
-          </a:solidFill>
-          <a:ln/>
-        </p:spPr>
-      </p:sp>
-      <p:sp>
-        <p:nvSpPr>
-          <p:cNvPr id="24" name="Week title 3"/>
-          <p:cNvSpPr txBox="1"/>
-          <p:nvPr/>
-        </p:nvSpPr>
-        <p:spPr>
-          <a:xfrm>
-            <a:off x="4823460" y="2880360"/>
-            <a:ext cx="1554480" cy="548640"/>
-          </a:xfrm>
-          <a:prstGeom prst="rect">
-            <a:avLst/>
-          </a:prstGeom>
-          <a:noFill/>
-          <a:ln/>
-        </p:spPr>
-        <p:txBody>
-          <a:bodyPr wrap="square" lIns="0" tIns="0" rIns="0" bIns="0" rtlCol="0" anchor="t"/>
-          <a:lstStyle/>
-          <a:p>
-            <a:pPr indent="0" marL="0">
-              <a:buNone/>
-            </a:pPr>
-            <a:r>
-              <a:rPr lang="en-US" sz="1500" b="1" dirty="0">
-                <a:solidFill>
-                  <a:schemeClr val="tx2"/>
-                </a:solidFill>
-              </a:rPr>
-              <a:t>Campaign Launch</a:t>
-            </a:r>
-            <a:endParaRPr lang="en-US" sz="1500" dirty="0"/>
-          </a:p>
-        </p:txBody>
-      </p:sp>
-      <p:sp>
-        <p:nvSpPr>
-          <p:cNvPr id="25" name="Week text 3"/>
-          <p:cNvSpPr txBox="1"/>
-          <p:nvPr/>
-        </p:nvSpPr>
-        <p:spPr>
-          <a:xfrm>
-            <a:off x="4823460" y="3474720"/>
-            <a:ext cx="1554480" cy="914400"/>
-          </a:xfrm>
-          <a:prstGeom prst="rect">
-            <a:avLst/>
-          </a:prstGeom>
-          <a:noFill/>
-          <a:ln/>
-        </p:spPr>
-        <p:txBody>
-          <a:bodyPr wrap="square" lIns="0" tIns="0" rIns="0" bIns="0" rtlCol="0" anchor="t"/>
-          <a:lstStyle/>
-          <a:p>
-            <a:pPr indent="0" marL="0">
-              <a:buNone/>
-            </a:pPr>
-            <a:r>
-              <a:rPr lang="en-US" sz="1200" dirty="0">
-                <a:solidFill>
-                  <a:schemeClr val="tx1"/>
-                </a:solidFill>
-              </a:rPr>
-              <a:t>Publish content and start paid ads</a:t>
-            </a:r>
-            <a:endParaRPr lang="en-US" sz="1200" dirty="0"/>
-          </a:p>
-        </p:txBody>
-      </p:sp>
-      <p:sp>
-        <p:nvSpPr>
-          <p:cNvPr id="26" name="Week pill 4"/>
+          <p:cNvPr id="17" name="Week pill 4"/>
           <p:cNvSpPr/>
           <p:nvPr/>
         </p:nvSpPr>
@@ -7772,14 +7573,14 @@
             </a:avLst>
           </a:prstGeom>
           <a:solidFill>
-            <a:schemeClr val="accent1"/>
+            <a:schemeClr val="accent4"/>
           </a:solidFill>
           <a:ln/>
         </p:spPr>
       </p:sp>
       <p:sp>
         <p:nvSpPr>
-          <p:cNvPr id="27" name="Week label 4"/>
+          <p:cNvPr id="18" name="Week label 4"/>
           <p:cNvSpPr txBox="1"/>
           <p:nvPr/>
         </p:nvSpPr>
@@ -7815,7 +7616,7 @@
       </p:sp>
       <p:sp>
         <p:nvSpPr>
-          <p:cNvPr id="28" name="Evaluate and Improve circle"/>
+          <p:cNvPr id="19" name="Measure results and improve circle"/>
           <p:cNvSpPr/>
           <p:nvPr/>
         </p:nvSpPr>
@@ -7835,7 +7636,7 @@
       </p:sp>
       <p:pic>
         <p:nvPicPr>
-          <p:cNvPr id="29" name="Evaluate and Improve icon" descr="Evaluate and Improve">    </p:cNvPr>
+          <p:cNvPr id="20" name="Measure results and improve icon" descr="Measure results and improve">    </p:cNvPr>
           <p:cNvPicPr>
             <a:picLocks noChangeAspect="1"/>
           </p:cNvPicPr>
@@ -7859,18 +7660,18 @@
       </p:pic>
       <p:sp>
         <p:nvSpPr>
-          <p:cNvPr id="30" name="Week card 4"/>
-          <p:cNvSpPr/>
-          <p:nvPr/>
-        </p:nvSpPr>
-        <p:spPr>
-          <a:xfrm>
-            <a:off x="6743700" y="2743200"/>
-            <a:ext cx="1828800" cy="1737360"/>
+          <p:cNvPr id="21" name="Week card 1"/>
+          <p:cNvSpPr/>
+          <p:nvPr/>
+        </p:nvSpPr>
+        <p:spPr>
+          <a:xfrm>
+            <a:off x="571500" y="2743200"/>
+            <a:ext cx="1828800" cy="1783080"/>
           </a:xfrm>
           <a:prstGeom prst="roundRect">
             <a:avLst>
-              <a:gd name="adj" fmla="val 6316"/>
+              <a:gd name="adj" fmla="val 6154"/>
             </a:avLst>
           </a:prstGeom>
           <a:solidFill>
@@ -7879,15 +7680,39 @@
           <a:ln/>
         </p:spPr>
       </p:sp>
-      <p:sp>
-        <p:nvSpPr>
-          <p:cNvPr id="31" name="Week title 4"/>
+      <p:pic>
+        <p:nvPicPr>
+          <p:cNvPr id="22" name="Research and planning illustration" descr="Research and planning illustration">    </p:cNvPr>
+          <p:cNvPicPr>
+            <a:picLocks noChangeAspect="1"/>
+          </p:cNvPicPr>
+          <p:nvPr/>
+        </p:nvPicPr>
+        <p:blipFill>
+          <a:blip r:embed="rId5"/>
+          <a:stretch>
+            <a:fillRect/>
+          </a:stretch>
+        </p:blipFill>
+        <p:spPr>
+          <a:xfrm>
+            <a:off x="662940" y="2834640"/>
+            <a:ext cx="1645920" cy="960120"/>
+          </a:xfrm>
+          <a:prstGeom prst="rect">
+            <a:avLst/>
+          </a:prstGeom>
+        </p:spPr>
+      </p:pic>
+      <p:sp>
+        <p:nvSpPr>
+          <p:cNvPr id="23" name="Week title 1"/>
           <p:cNvSpPr txBox="1"/>
           <p:nvPr/>
         </p:nvSpPr>
         <p:spPr>
           <a:xfrm>
-            <a:off x="6880860" y="2880360"/>
+            <a:off x="708660" y="3886200"/>
             <a:ext cx="1554480" cy="548640"/>
           </a:xfrm>
           <a:prstGeom prst="rect">
@@ -7904,27 +7729,73 @@
               <a:buNone/>
             </a:pPr>
             <a:r>
-              <a:rPr lang="en-US" sz="1500" b="1" dirty="0">
+              <a:rPr lang="en-US" sz="1400" b="1" dirty="0">
                 <a:solidFill>
                   <a:schemeClr val="tx2"/>
                 </a:solidFill>
               </a:rPr>
-              <a:t>Evaluate and Improve</a:t>
-            </a:r>
-            <a:endParaRPr lang="en-US" sz="1500" dirty="0"/>
-          </a:p>
-        </p:txBody>
-      </p:sp>
-      <p:sp>
-        <p:nvSpPr>
-          <p:cNvPr id="32" name="Week text 4"/>
+              <a:t>Research and planning</a:t>
+            </a:r>
+            <a:endParaRPr lang="en-US" sz="1400" dirty="0"/>
+          </a:p>
+        </p:txBody>
+      </p:sp>
+      <p:sp>
+        <p:nvSpPr>
+          <p:cNvPr id="24" name="Week card 2"/>
+          <p:cNvSpPr/>
+          <p:nvPr/>
+        </p:nvSpPr>
+        <p:spPr>
+          <a:xfrm>
+            <a:off x="2628900" y="2743200"/>
+            <a:ext cx="1828800" cy="1783080"/>
+          </a:xfrm>
+          <a:prstGeom prst="roundRect">
+            <a:avLst>
+              <a:gd name="adj" fmla="val 6154"/>
+            </a:avLst>
+          </a:prstGeom>
+          <a:solidFill>
+            <a:schemeClr val="bg2"/>
+          </a:solidFill>
+          <a:ln/>
+        </p:spPr>
+      </p:sp>
+      <p:pic>
+        <p:nvPicPr>
+          <p:cNvPr id="25" name="Content creation illustration" descr="Content creation illustration">    </p:cNvPr>
+          <p:cNvPicPr>
+            <a:picLocks noChangeAspect="1"/>
+          </p:cNvPicPr>
+          <p:nvPr/>
+        </p:nvPicPr>
+        <p:blipFill>
+          <a:blip r:embed="rId6"/>
+          <a:stretch>
+            <a:fillRect/>
+          </a:stretch>
+        </p:blipFill>
+        <p:spPr>
+          <a:xfrm>
+            <a:off x="2720340" y="2834640"/>
+            <a:ext cx="1645920" cy="960120"/>
+          </a:xfrm>
+          <a:prstGeom prst="rect">
+            <a:avLst/>
+          </a:prstGeom>
+        </p:spPr>
+      </p:pic>
+      <p:sp>
+        <p:nvSpPr>
+          <p:cNvPr id="26" name="Week title 2"/>
           <p:cNvSpPr txBox="1"/>
           <p:nvPr/>
         </p:nvSpPr>
         <p:spPr>
           <a:xfrm>
-            <a:off x="6880860" y="3474720"/>
-            <a:ext cx="1554480" cy="914400"/>
+            <a:off x="2766060" y="3886200"/>
+            <a:ext cx="1554480" cy="548640"/>
           </a:xfrm>
           <a:prstGeom prst="rect">
             <a:avLst/>
@@ -7940,14 +7811,178 @@
               <a:buNone/>
             </a:pPr>
             <a:r>
-              <a:rPr lang="en-US" sz="1200" dirty="0">
-                <a:solidFill>
-                  <a:schemeClr val="tx1"/>
-                </a:solidFill>
-              </a:rPr>
-              <a:t>Analyze results and recommend next steps</a:t>
-            </a:r>
-            <a:endParaRPr lang="en-US" sz="1200" dirty="0"/>
+              <a:rPr lang="en-US" sz="1400" b="1" dirty="0">
+                <a:solidFill>
+                  <a:schemeClr val="tx2"/>
+                </a:solidFill>
+              </a:rPr>
+              <a:t>Content creation</a:t>
+            </a:r>
+            <a:endParaRPr lang="en-US" sz="1400" dirty="0"/>
+          </a:p>
+        </p:txBody>
+      </p:sp>
+      <p:sp>
+        <p:nvSpPr>
+          <p:cNvPr id="27" name="Week card 3"/>
+          <p:cNvSpPr/>
+          <p:nvPr/>
+        </p:nvSpPr>
+        <p:spPr>
+          <a:xfrm>
+            <a:off x="4686300" y="2743200"/>
+            <a:ext cx="1828800" cy="1783080"/>
+          </a:xfrm>
+          <a:prstGeom prst="roundRect">
+            <a:avLst>
+              <a:gd name="adj" fmla="val 6154"/>
+            </a:avLst>
+          </a:prstGeom>
+          <a:solidFill>
+            <a:schemeClr val="bg2"/>
+          </a:solidFill>
+          <a:ln/>
+        </p:spPr>
+      </p:sp>
+      <p:pic>
+        <p:nvPicPr>
+          <p:cNvPr id="28" name="Launch marketing campaigns illustration" descr="Launch marketing campaigns illustration">    </p:cNvPr>
+          <p:cNvPicPr>
+            <a:picLocks noChangeAspect="1"/>
+          </p:cNvPicPr>
+          <p:nvPr/>
+        </p:nvPicPr>
+        <p:blipFill>
+          <a:blip r:embed="rId7"/>
+          <a:stretch>
+            <a:fillRect/>
+          </a:stretch>
+        </p:blipFill>
+        <p:spPr>
+          <a:xfrm>
+            <a:off x="4777740" y="2834640"/>
+            <a:ext cx="1645920" cy="960120"/>
+          </a:xfrm>
+          <a:prstGeom prst="rect">
+            <a:avLst/>
+          </a:prstGeom>
+        </p:spPr>
+      </p:pic>
+      <p:sp>
+        <p:nvSpPr>
+          <p:cNvPr id="29" name="Week title 3"/>
+          <p:cNvSpPr txBox="1"/>
+          <p:nvPr/>
+        </p:nvSpPr>
+        <p:spPr>
+          <a:xfrm>
+            <a:off x="4823460" y="3886200"/>
+            <a:ext cx="1554480" cy="548640"/>
+          </a:xfrm>
+          <a:prstGeom prst="rect">
+            <a:avLst/>
+          </a:prstGeom>
+          <a:noFill/>
+          <a:ln/>
+        </p:spPr>
+        <p:txBody>
+          <a:bodyPr wrap="square" lIns="0" tIns="0" rIns="0" bIns="0" rtlCol="0" anchor="t"/>
+          <a:lstStyle/>
+          <a:p>
+            <a:pPr indent="0" marL="0">
+              <a:buNone/>
+            </a:pPr>
+            <a:r>
+              <a:rPr lang="en-US" sz="1400" b="1" dirty="0">
+                <a:solidFill>
+                  <a:schemeClr val="tx2"/>
+                </a:solidFill>
+              </a:rPr>
+              <a:t>Launch marketing campaigns</a:t>
+            </a:r>
+            <a:endParaRPr lang="en-US" sz="1400" dirty="0"/>
+          </a:p>
+        </p:txBody>
+      </p:sp>
+      <p:sp>
+        <p:nvSpPr>
+          <p:cNvPr id="30" name="Week card 4"/>
+          <p:cNvSpPr/>
+          <p:nvPr/>
+        </p:nvSpPr>
+        <p:spPr>
+          <a:xfrm>
+            <a:off x="6743700" y="2743200"/>
+            <a:ext cx="1828800" cy="1783080"/>
+          </a:xfrm>
+          <a:prstGeom prst="roundRect">
+            <a:avLst>
+              <a:gd name="adj" fmla="val 6154"/>
+            </a:avLst>
+          </a:prstGeom>
+          <a:solidFill>
+            <a:schemeClr val="bg2"/>
+          </a:solidFill>
+          <a:ln/>
+        </p:spPr>
+      </p:sp>
+      <p:pic>
+        <p:nvPicPr>
+          <p:cNvPr id="31" name="Measure results and improve illustration" descr="Measure results and improve illustration">    </p:cNvPr>
+          <p:cNvPicPr>
+            <a:picLocks noChangeAspect="1"/>
+          </p:cNvPicPr>
+          <p:nvPr/>
+        </p:nvPicPr>
+        <p:blipFill>
+          <a:blip r:embed="rId8"/>
+          <a:stretch>
+            <a:fillRect/>
+          </a:stretch>
+        </p:blipFill>
+        <p:spPr>
+          <a:xfrm>
+            <a:off x="6835140" y="2834640"/>
+            <a:ext cx="1645920" cy="960120"/>
+          </a:xfrm>
+          <a:prstGeom prst="rect">
+            <a:avLst/>
+          </a:prstGeom>
+        </p:spPr>
+      </p:pic>
+      <p:sp>
+        <p:nvSpPr>
+          <p:cNvPr id="32" name="Week title 4"/>
+          <p:cNvSpPr txBox="1"/>
+          <p:nvPr/>
+        </p:nvSpPr>
+        <p:spPr>
+          <a:xfrm>
+            <a:off x="6880860" y="3886200"/>
+            <a:ext cx="1554480" cy="548640"/>
+          </a:xfrm>
+          <a:prstGeom prst="rect">
+            <a:avLst/>
+          </a:prstGeom>
+          <a:noFill/>
+          <a:ln/>
+        </p:spPr>
+        <p:txBody>
+          <a:bodyPr wrap="square" lIns="0" tIns="0" rIns="0" bIns="0" rtlCol="0" anchor="t"/>
+          <a:lstStyle/>
+          <a:p>
+            <a:pPr indent="0" marL="0">
+              <a:buNone/>
+            </a:pPr>
+            <a:r>
+              <a:rPr lang="en-US" sz="1400" b="1" dirty="0">
+                <a:solidFill>
+                  <a:schemeClr val="tx2"/>
+                </a:solidFill>
+              </a:rPr>
+              <a:t>Measure results and improve</a:t>
+            </a:r>
+            <a:endParaRPr lang="en-US" sz="1400" dirty="0"/>
           </a:p>
         </p:txBody>
       </p:sp>
@@ -8094,7 +8129,7 @@
                 <a:ea typeface="Cambria" pitchFamily="34" charset="-122"/>
                 <a:cs typeface="Cambria" pitchFamily="34" charset="-120"/>
               </a:rPr>
-              <a:t>What the Café Gains</a:t>
+              <a:t>How the Café Benefits</a:t>
             </a:r>
             <a:endParaRPr lang="en-US" sz="3200" dirty="0"/>
           </a:p>
@@ -8126,7 +8161,7 @@
       </p:pic>
       <p:sp>
         <p:nvSpPr>
-          <p:cNvPr id="5" name="More awareness and online visibility circle"/>
+          <p:cNvPr id="5" name="Reach more people circle"/>
           <p:cNvSpPr/>
           <p:nvPr/>
         </p:nvSpPr>
@@ -8139,14 +8174,14 @@
             <a:avLst/>
           </a:prstGeom>
           <a:solidFill>
-            <a:schemeClr val="accent1"/>
+            <a:schemeClr val="accent4"/>
           </a:solidFill>
           <a:ln/>
         </p:spPr>
       </p:sp>
       <p:pic>
         <p:nvPicPr>
-          <p:cNvPr id="6" name="More awareness and online visibility icon" descr="More awareness and online visibility">    </p:cNvPr>
+          <p:cNvPr id="6" name="Reach more people icon" descr="Reach more people">    </p:cNvPr>
           <p:cNvPicPr>
             <a:picLocks noChangeAspect="1"/>
           </p:cNvPicPr>
@@ -8198,7 +8233,7 @@
                   <a:schemeClr val="tx2"/>
                 </a:solidFill>
               </a:rPr>
-              <a:t>More awareness and online visibility</a:t>
+              <a:t>Reach more people</a:t>
             </a:r>
             <a:endParaRPr lang="en-US" sz="1600" dirty="0"/>
           </a:p>
@@ -8206,7 +8241,7 @@
       </p:sp>
       <p:sp>
         <p:nvSpPr>
-          <p:cNvPr id="8" name="Reach more potential customers circle"/>
+          <p:cNvPr id="8" name="Attract new customers circle"/>
           <p:cNvSpPr/>
           <p:nvPr/>
         </p:nvSpPr>
@@ -8219,14 +8254,14 @@
             <a:avLst/>
           </a:prstGeom>
           <a:solidFill>
-            <a:schemeClr val="accent1"/>
+            <a:schemeClr val="accent4"/>
           </a:solidFill>
           <a:ln/>
         </p:spPr>
       </p:sp>
       <p:pic>
         <p:nvPicPr>
-          <p:cNvPr id="9" name="Reach more potential customers icon" descr="Reach more potential customers">    </p:cNvPr>
+          <p:cNvPr id="9" name="Attract new customers icon" descr="Attract new customers">    </p:cNvPr>
           <p:cNvPicPr>
             <a:picLocks noChangeAspect="1"/>
           </p:cNvPicPr>
@@ -8278,7 +8313,7 @@
                   <a:schemeClr val="tx2"/>
                 </a:solidFill>
               </a:rPr>
-              <a:t>Reach more potential customers</a:t>
+              <a:t>Attract new customers</a:t>
             </a:r>
             <a:endParaRPr lang="en-US" sz="1600" dirty="0"/>
           </a:p>
@@ -8286,7 +8321,7 @@
       </p:sp>
       <p:sp>
         <p:nvSpPr>
-          <p:cNvPr id="11" name="Stronger customer relationships circle"/>
+          <p:cNvPr id="11" name="Build a strong brand circle"/>
           <p:cNvSpPr/>
           <p:nvPr/>
         </p:nvSpPr>
@@ -8299,14 +8334,14 @@
             <a:avLst/>
           </a:prstGeom>
           <a:solidFill>
-            <a:schemeClr val="accent1"/>
+            <a:schemeClr val="accent4"/>
           </a:solidFill>
           <a:ln/>
         </p:spPr>
       </p:sp>
       <p:pic>
         <p:nvPicPr>
-          <p:cNvPr id="12" name="Stronger customer relationships icon" descr="Stronger customer relationships">    </p:cNvPr>
+          <p:cNvPr id="12" name="Build a strong brand icon" descr="Build a strong brand">    </p:cNvPr>
           <p:cNvPicPr>
             <a:picLocks noChangeAspect="1"/>
           </p:cNvPicPr>
@@ -8358,7 +8393,7 @@
                   <a:schemeClr val="tx2"/>
                 </a:solidFill>
               </a:rPr>
-              <a:t>Stronger customer relationships</a:t>
+              <a:t>Build a strong brand</a:t>
             </a:r>
             <a:endParaRPr lang="en-US" sz="1600" dirty="0"/>
           </a:p>
@@ -8366,7 +8401,7 @@
       </p:sp>
       <p:sp>
         <p:nvSpPr>
-          <p:cNvPr id="14" name="Promote new products and offers circle"/>
+          <p:cNvPr id="14" name="Improve customer engagement circle"/>
           <p:cNvSpPr/>
           <p:nvPr/>
         </p:nvSpPr>
@@ -8379,14 +8414,14 @@
             <a:avLst/>
           </a:prstGeom>
           <a:solidFill>
-            <a:schemeClr val="accent1"/>
+            <a:schemeClr val="accent4"/>
           </a:solidFill>
           <a:ln/>
         </p:spPr>
       </p:sp>
       <p:pic>
         <p:nvPicPr>
-          <p:cNvPr id="15" name="Promote new products and offers icon" descr="Promote new products and offers">    </p:cNvPr>
+          <p:cNvPr id="15" name="Improve customer engagement icon" descr="Improve customer engagement">    </p:cNvPr>
           <p:cNvPicPr>
             <a:picLocks noChangeAspect="1"/>
           </p:cNvPicPr>
@@ -8438,7 +8473,7 @@
                   <a:schemeClr val="tx2"/>
                 </a:solidFill>
               </a:rPr>
-              <a:t>Promote new products and offers</a:t>
+              <a:t>Improve customer engagement</a:t>
             </a:r>
             <a:endParaRPr lang="en-US" sz="1600" dirty="0"/>
           </a:p>
@@ -8446,7 +8481,7 @@
       </p:sp>
       <p:sp>
         <p:nvSpPr>
-          <p:cNvPr id="17" name="Smarter, data-driven decisions circle"/>
+          <p:cNvPr id="17" name="Better chance of higher sales circle"/>
           <p:cNvSpPr/>
           <p:nvPr/>
         </p:nvSpPr>
@@ -8459,14 +8494,14 @@
             <a:avLst/>
           </a:prstGeom>
           <a:solidFill>
-            <a:schemeClr val="accent1"/>
+            <a:schemeClr val="accent4"/>
           </a:solidFill>
           <a:ln/>
         </p:spPr>
       </p:sp>
       <p:pic>
         <p:nvPicPr>
-          <p:cNvPr id="18" name="Smarter, data-driven decisions icon" descr="Smarter, data-driven decisions">    </p:cNvPr>
+          <p:cNvPr id="18" name="Better chance of higher sales icon" descr="Better chance of higher sales">    </p:cNvPr>
           <p:cNvPicPr>
             <a:picLocks noChangeAspect="1"/>
           </p:cNvPicPr>
@@ -8518,7 +8553,7 @@
                   <a:schemeClr val="tx2"/>
                 </a:solidFill>
               </a:rPr>
-              <a:t>Smarter, data-driven decisions</a:t>
+              <a:t>Better chance of higher sales</a:t>
             </a:r>
             <a:endParaRPr lang="en-US" sz="1600" dirty="0"/>
           </a:p>
@@ -8682,11 +8717,11 @@
         <p:spPr>
           <a:xfrm>
             <a:off x="457200" y="1325880"/>
-            <a:ext cx="1920240" cy="1783080"/>
+            <a:ext cx="1517904" cy="1828800"/>
           </a:xfrm>
           <a:prstGeom prst="roundRect">
             <a:avLst>
-              <a:gd name="adj" fmla="val 6154"/>
+              <a:gd name="adj" fmla="val 7229"/>
             </a:avLst>
           </a:prstGeom>
           <a:solidFill>
@@ -8697,14 +8732,14 @@
       </p:sp>
       <p:sp>
         <p:nvSpPr>
-          <p:cNvPr id="5" name="Reach and engagement circle"/>
-          <p:cNvSpPr/>
-          <p:nvPr/>
-        </p:nvSpPr>
-        <p:spPr>
-          <a:xfrm>
-            <a:off x="640080" y="1508760"/>
-            <a:ext cx="566928" cy="566928"/>
+          <p:cNvPr id="5" name="Followers circle"/>
+          <p:cNvSpPr/>
+          <p:nvPr/>
+        </p:nvSpPr>
+        <p:spPr>
+          <a:xfrm>
+            <a:off x="621792" y="1490472"/>
+            <a:ext cx="548640" cy="548640"/>
           </a:xfrm>
           <a:prstGeom prst="ellipse">
             <a:avLst/>
@@ -8717,7 +8752,7 @@
       </p:sp>
       <p:pic>
         <p:nvPicPr>
-          <p:cNvPr id="6" name="Reach and engagement icon" descr="Reach and engagement">    </p:cNvPr>
+          <p:cNvPr id="6" name="Followers icon" descr="Followers">    </p:cNvPr>
           <p:cNvPicPr>
             <a:picLocks noChangeAspect="1"/>
           </p:cNvPicPr>
@@ -8731,8 +8766,8 @@
         </p:blipFill>
         <p:spPr>
           <a:xfrm>
-            <a:off x="793151" y="1661831"/>
-            <a:ext cx="260787" cy="260787"/>
+            <a:off x="769925" y="1638605"/>
+            <a:ext cx="252374" cy="252374"/>
           </a:xfrm>
           <a:prstGeom prst="rect">
             <a:avLst/>
@@ -8747,8 +8782,8 @@
         </p:nvSpPr>
         <p:spPr>
           <a:xfrm>
-            <a:off x="1783080" y="1554480"/>
-            <a:ext cx="411480" cy="411480"/>
+            <a:off x="1426464" y="1536192"/>
+            <a:ext cx="384048" cy="384048"/>
           </a:xfrm>
           <a:prstGeom prst="ellipse">
             <a:avLst/>
@@ -8775,8 +8810,8 @@
         </p:blipFill>
         <p:spPr>
           <a:xfrm>
-            <a:off x="1894180" y="1665580"/>
-            <a:ext cx="189281" cy="189281"/>
+            <a:off x="1530157" y="1639885"/>
+            <a:ext cx="176662" cy="176662"/>
           </a:xfrm>
           <a:prstGeom prst="rect">
             <a:avLst/>
@@ -8791,8 +8826,8 @@
         </p:nvSpPr>
         <p:spPr>
           <a:xfrm>
-            <a:off x="640080" y="2194560"/>
-            <a:ext cx="1600200" cy="822960"/>
+            <a:off x="621792" y="2194560"/>
+            <a:ext cx="1280160" cy="868680"/>
           </a:xfrm>
           <a:prstGeom prst="rect">
             <a:avLst/>
@@ -8813,7 +8848,7 @@
                   <a:schemeClr val="tx2"/>
                 </a:solidFill>
               </a:rPr>
-              <a:t>Reach and engagement</a:t>
+              <a:t>More followers</a:t>
             </a:r>
             <a:endParaRPr lang="en-US" sz="1500" dirty="0"/>
           </a:p>
@@ -8827,7 +8862,7 @@
                   <a:schemeClr val="tx1"/>
                 </a:solidFill>
               </a:rPr>
-              <a:t>on social media</a:t>
+              <a:t>and engagement</a:t>
             </a:r>
             <a:endParaRPr lang="en-US" sz="1500" dirty="0"/>
           </a:p>
@@ -8841,12 +8876,12 @@
         </p:nvSpPr>
         <p:spPr>
           <a:xfrm>
-            <a:off x="2560320" y="1325880"/>
-            <a:ext cx="1920240" cy="1783080"/>
+            <a:off x="2139696" y="1325880"/>
+            <a:ext cx="1517904" cy="1828800"/>
           </a:xfrm>
           <a:prstGeom prst="roundRect">
             <a:avLst>
-              <a:gd name="adj" fmla="val 6154"/>
+              <a:gd name="adj" fmla="val 7229"/>
             </a:avLst>
           </a:prstGeom>
           <a:solidFill>
@@ -8857,14 +8892,14 @@
       </p:sp>
       <p:sp>
         <p:nvSpPr>
-          <p:cNvPr id="11" name="Profile visits circle"/>
-          <p:cNvSpPr/>
-          <p:nvPr/>
-        </p:nvSpPr>
-        <p:spPr>
-          <a:xfrm>
-            <a:off x="2743200" y="1508760"/>
-            <a:ext cx="566928" cy="566928"/>
+          <p:cNvPr id="11" name="Inquiries circle"/>
+          <p:cNvSpPr/>
+          <p:nvPr/>
+        </p:nvSpPr>
+        <p:spPr>
+          <a:xfrm>
+            <a:off x="2304288" y="1490472"/>
+            <a:ext cx="548640" cy="548640"/>
           </a:xfrm>
           <a:prstGeom prst="ellipse">
             <a:avLst/>
@@ -8877,7 +8912,7 @@
       </p:sp>
       <p:pic>
         <p:nvPicPr>
-          <p:cNvPr id="12" name="Profile visits icon" descr="Profile visits">    </p:cNvPr>
+          <p:cNvPr id="12" name="Inquiries icon" descr="Inquiries">    </p:cNvPr>
           <p:cNvPicPr>
             <a:picLocks noChangeAspect="1"/>
           </p:cNvPicPr>
@@ -8891,8 +8926,8 @@
         </p:blipFill>
         <p:spPr>
           <a:xfrm>
-            <a:off x="2896271" y="1661831"/>
-            <a:ext cx="260787" cy="260787"/>
+            <a:off x="2452421" y="1638605"/>
+            <a:ext cx="252374" cy="252374"/>
           </a:xfrm>
           <a:prstGeom prst="rect">
             <a:avLst/>
@@ -8907,8 +8942,8 @@
         </p:nvSpPr>
         <p:spPr>
           <a:xfrm>
-            <a:off x="3886200" y="1554480"/>
-            <a:ext cx="411480" cy="411480"/>
+            <a:off x="3108960" y="1536192"/>
+            <a:ext cx="384048" cy="384048"/>
           </a:xfrm>
           <a:prstGeom prst="ellipse">
             <a:avLst/>
@@ -8935,8 +8970,8 @@
         </p:blipFill>
         <p:spPr>
           <a:xfrm>
-            <a:off x="3997300" y="1665580"/>
-            <a:ext cx="189281" cy="189281"/>
+            <a:off x="3212653" y="1639885"/>
+            <a:ext cx="176662" cy="176662"/>
           </a:xfrm>
           <a:prstGeom prst="rect">
             <a:avLst/>
@@ -8951,8 +8986,8 @@
         </p:nvSpPr>
         <p:spPr>
           <a:xfrm>
-            <a:off x="2743200" y="2194560"/>
-            <a:ext cx="1600200" cy="822960"/>
+            <a:off x="2304288" y="2194560"/>
+            <a:ext cx="1280160" cy="868680"/>
           </a:xfrm>
           <a:prstGeom prst="rect">
             <a:avLst/>
@@ -8973,7 +9008,7 @@
                   <a:schemeClr val="tx2"/>
                 </a:solidFill>
               </a:rPr>
-              <a:t>Profile visits</a:t>
+              <a:t>More inquiries</a:t>
             </a:r>
             <a:endParaRPr lang="en-US" sz="1500" dirty="0"/>
           </a:p>
@@ -8987,7 +9022,7 @@
                   <a:schemeClr val="tx1"/>
                 </a:solidFill>
               </a:rPr>
-              <a:t>inquiries and direction requests</a:t>
+              <a:t>from customers</a:t>
             </a:r>
             <a:endParaRPr lang="en-US" sz="1500" dirty="0"/>
           </a:p>
@@ -9001,12 +9036,12 @@
         </p:nvSpPr>
         <p:spPr>
           <a:xfrm>
-            <a:off x="4663440" y="1325880"/>
-            <a:ext cx="1920240" cy="1783080"/>
+            <a:off x="3822192" y="1325880"/>
+            <a:ext cx="1517904" cy="1828800"/>
           </a:xfrm>
           <a:prstGeom prst="roundRect">
             <a:avLst>
-              <a:gd name="adj" fmla="val 6154"/>
+              <a:gd name="adj" fmla="val 7229"/>
             </a:avLst>
           </a:prstGeom>
           <a:solidFill>
@@ -9023,8 +9058,8 @@
         </p:nvSpPr>
         <p:spPr>
           <a:xfrm>
-            <a:off x="4846320" y="1508760"/>
-            <a:ext cx="566928" cy="566928"/>
+            <a:off x="3986784" y="1490472"/>
+            <a:ext cx="548640" cy="548640"/>
           </a:xfrm>
           <a:prstGeom prst="ellipse">
             <a:avLst/>
@@ -9051,8 +9086,8 @@
         </p:blipFill>
         <p:spPr>
           <a:xfrm>
-            <a:off x="4999391" y="1661831"/>
-            <a:ext cx="260787" cy="260787"/>
+            <a:off x="4134917" y="1638605"/>
+            <a:ext cx="252374" cy="252374"/>
           </a:xfrm>
           <a:prstGeom prst="rect">
             <a:avLst/>
@@ -9067,8 +9102,8 @@
         </p:nvSpPr>
         <p:spPr>
           <a:xfrm>
-            <a:off x="5989320" y="1554480"/>
-            <a:ext cx="411480" cy="411480"/>
+            <a:off x="4791456" y="1536192"/>
+            <a:ext cx="384048" cy="384048"/>
           </a:xfrm>
           <a:prstGeom prst="ellipse">
             <a:avLst/>
@@ -9095,8 +9130,8 @@
         </p:blipFill>
         <p:spPr>
           <a:xfrm>
-            <a:off x="6100420" y="1665580"/>
-            <a:ext cx="189281" cy="189281"/>
+            <a:off x="4895149" y="1639885"/>
+            <a:ext cx="176662" cy="176662"/>
           </a:xfrm>
           <a:prstGeom prst="rect">
             <a:avLst/>
@@ -9111,8 +9146,8 @@
         </p:nvSpPr>
         <p:spPr>
           <a:xfrm>
-            <a:off x="4846320" y="2194560"/>
-            <a:ext cx="1600200" cy="822960"/>
+            <a:off x="3986784" y="2194560"/>
+            <a:ext cx="1280160" cy="868680"/>
           </a:xfrm>
           <a:prstGeom prst="rect">
             <a:avLst/>
@@ -9133,7 +9168,7 @@
                   <a:schemeClr val="tx2"/>
                 </a:solidFill>
               </a:rPr>
-              <a:t>Awareness</a:t>
+              <a:t>More awareness</a:t>
             </a:r>
             <a:endParaRPr lang="en-US" sz="1500" dirty="0"/>
           </a:p>
@@ -9147,7 +9182,7 @@
                   <a:schemeClr val="tx1"/>
                 </a:solidFill>
               </a:rPr>
-              <a:t>of products and offers</a:t>
+              <a:t>of the café</a:t>
             </a:r>
             <a:endParaRPr lang="en-US" sz="1500" dirty="0"/>
           </a:p>
@@ -9161,12 +9196,12 @@
         </p:nvSpPr>
         <p:spPr>
           <a:xfrm>
-            <a:off x="6766560" y="1325880"/>
-            <a:ext cx="1920240" cy="1783080"/>
+            <a:off x="5504688" y="1325880"/>
+            <a:ext cx="1517904" cy="1828800"/>
           </a:xfrm>
           <a:prstGeom prst="roundRect">
             <a:avLst>
-              <a:gd name="adj" fmla="val 6154"/>
+              <a:gd name="adj" fmla="val 7229"/>
             </a:avLst>
           </a:prstGeom>
           <a:solidFill>
@@ -9177,14 +9212,14 @@
       </p:sp>
       <p:sp>
         <p:nvSpPr>
-          <p:cNvPr id="23" name="Visits and sales circle"/>
-          <p:cNvSpPr/>
-          <p:nvPr/>
-        </p:nvSpPr>
-        <p:spPr>
-          <a:xfrm>
-            <a:off x="6949440" y="1508760"/>
-            <a:ext cx="566928" cy="566928"/>
+          <p:cNvPr id="23" name="Visits circle"/>
+          <p:cNvSpPr/>
+          <p:nvPr/>
+        </p:nvSpPr>
+        <p:spPr>
+          <a:xfrm>
+            <a:off x="5669280" y="1490472"/>
+            <a:ext cx="548640" cy="548640"/>
           </a:xfrm>
           <a:prstGeom prst="ellipse">
             <a:avLst/>
@@ -9197,7 +9232,7 @@
       </p:sp>
       <p:pic>
         <p:nvPicPr>
-          <p:cNvPr id="24" name="Visits and sales icon" descr="Visits and sales">    </p:cNvPr>
+          <p:cNvPr id="24" name="Visits icon" descr="Visits">    </p:cNvPr>
           <p:cNvPicPr>
             <a:picLocks noChangeAspect="1"/>
           </p:cNvPicPr>
@@ -9211,8 +9246,8 @@
         </p:blipFill>
         <p:spPr>
           <a:xfrm>
-            <a:off x="7102511" y="1661831"/>
-            <a:ext cx="260787" cy="260787"/>
+            <a:off x="5817413" y="1638605"/>
+            <a:ext cx="252374" cy="252374"/>
           </a:xfrm>
           <a:prstGeom prst="rect">
             <a:avLst/>
@@ -9227,8 +9262,8 @@
         </p:nvSpPr>
         <p:spPr>
           <a:xfrm>
-            <a:off x="8092440" y="1554480"/>
-            <a:ext cx="411480" cy="411480"/>
+            <a:off x="6473952" y="1536192"/>
+            <a:ext cx="384048" cy="384048"/>
           </a:xfrm>
           <a:prstGeom prst="ellipse">
             <a:avLst/>
@@ -9255,8 +9290,8 @@
         </p:blipFill>
         <p:spPr>
           <a:xfrm>
-            <a:off x="8203540" y="1665580"/>
-            <a:ext cx="189281" cy="189281"/>
+            <a:off x="6577645" y="1639885"/>
+            <a:ext cx="176662" cy="176662"/>
           </a:xfrm>
           <a:prstGeom prst="rect">
             <a:avLst/>
@@ -9271,8 +9306,8 @@
         </p:nvSpPr>
         <p:spPr>
           <a:xfrm>
-            <a:off x="6949440" y="2194560"/>
-            <a:ext cx="1600200" cy="822960"/>
+            <a:off x="5669280" y="2194560"/>
+            <a:ext cx="1280160" cy="868680"/>
           </a:xfrm>
           <a:prstGeom prst="rect">
             <a:avLst/>
@@ -9293,7 +9328,7 @@
                   <a:schemeClr val="tx2"/>
                 </a:solidFill>
               </a:rPr>
-              <a:t>Visits and sales</a:t>
+              <a:t>More visits</a:t>
             </a:r>
             <a:endParaRPr lang="en-US" sz="1500" dirty="0"/>
           </a:p>
@@ -9307,7 +9342,7 @@
                   <a:schemeClr val="tx1"/>
                 </a:solidFill>
               </a:rPr>
-              <a:t>linked to the campaign</a:t>
+              <a:t>from new customers</a:t>
             </a:r>
             <a:endParaRPr lang="en-US" sz="1500" dirty="0"/>
           </a:p>
@@ -9315,140 +9350,240 @@
       </p:sp>
       <p:sp>
         <p:nvSpPr>
-          <p:cNvPr id="28" name="Measure heading"/>
-          <p:cNvSpPr txBox="1"/>
-          <p:nvPr/>
-        </p:nvSpPr>
-        <p:spPr>
-          <a:xfrm>
-            <a:off x="457200" y="3310128"/>
-            <a:ext cx="8229600" cy="320040"/>
-          </a:xfrm>
-          <a:prstGeom prst="rect">
-            <a:avLst/>
-          </a:prstGeom>
-          <a:noFill/>
-          <a:ln/>
-        </p:spPr>
-        <p:txBody>
-          <a:bodyPr wrap="square" lIns="0" tIns="0" rIns="0" bIns="0" rtlCol="0" anchor="ctr"/>
-          <a:lstStyle/>
-          <a:p>
-            <a:pPr indent="0" marL="0">
-              <a:buNone/>
-            </a:pPr>
-            <a:r>
-              <a:rPr lang="en-US" sz="1500" b="1" dirty="0">
-                <a:solidFill>
-                  <a:schemeClr val="tx2"/>
-                </a:solidFill>
-              </a:rPr>
-              <a:t>How we measure success</a:t>
-            </a:r>
-            <a:endParaRPr lang="en-US" sz="1500" dirty="0"/>
-          </a:p>
-        </p:txBody>
-      </p:sp>
-      <p:sp>
-        <p:nvSpPr>
-          <p:cNvPr id="29" name="Metric pill 1"/>
-          <p:cNvSpPr/>
-          <p:nvPr/>
-        </p:nvSpPr>
-        <p:spPr>
-          <a:xfrm>
-            <a:off x="457200" y="3703320"/>
-            <a:ext cx="1536192" cy="420624"/>
+          <p:cNvPr id="28" name="Result card 5"/>
+          <p:cNvSpPr/>
+          <p:nvPr/>
+        </p:nvSpPr>
+        <p:spPr>
+          <a:xfrm>
+            <a:off x="7187184" y="1325880"/>
+            <a:ext cx="1517904" cy="1828800"/>
           </a:xfrm>
           <a:prstGeom prst="roundRect">
             <a:avLst>
-              <a:gd name="adj" fmla="val 50000"/>
+              <a:gd name="adj" fmla="val 7229"/>
             </a:avLst>
           </a:prstGeom>
           <a:solidFill>
-            <a:schemeClr val="bg1"/>
+            <a:schemeClr val="bg2"/>
           </a:solidFill>
-          <a:ln w="15875">
-            <a:solidFill>
-              <a:srgbClr val="C27A3A"/>
-            </a:solidFill>
-            <a:prstDash val="solid"/>
-          </a:ln>
-        </p:spPr>
-      </p:sp>
-      <p:sp>
-        <p:nvSpPr>
-          <p:cNvPr id="30" name="Metric 1"/>
+          <a:ln/>
+        </p:spPr>
+      </p:sp>
+      <p:sp>
+        <p:nvSpPr>
+          <p:cNvPr id="29" name="Sales circle"/>
+          <p:cNvSpPr/>
+          <p:nvPr/>
+        </p:nvSpPr>
+        <p:spPr>
+          <a:xfrm>
+            <a:off x="7351776" y="1490472"/>
+            <a:ext cx="548640" cy="548640"/>
+          </a:xfrm>
+          <a:prstGeom prst="ellipse">
+            <a:avLst/>
+          </a:prstGeom>
+          <a:solidFill>
+            <a:schemeClr val="tx2"/>
+          </a:solidFill>
+          <a:ln/>
+        </p:spPr>
+      </p:sp>
+      <p:pic>
+        <p:nvPicPr>
+          <p:cNvPr id="30" name="Sales icon" descr="Sales">    </p:cNvPr>
+          <p:cNvPicPr>
+            <a:picLocks noChangeAspect="1"/>
+          </p:cNvPicPr>
+          <p:nvPr/>
+        </p:nvPicPr>
+        <p:blipFill>
+          <a:blip r:embed="rId9"/>
+          <a:stretch>
+            <a:fillRect/>
+          </a:stretch>
+        </p:blipFill>
+        <p:spPr>
+          <a:xfrm>
+            <a:off x="7499909" y="1638605"/>
+            <a:ext cx="252374" cy="252374"/>
+          </a:xfrm>
+          <a:prstGeom prst="rect">
+            <a:avLst/>
+          </a:prstGeom>
+        </p:spPr>
+      </p:pic>
+      <p:sp>
+        <p:nvSpPr>
+          <p:cNvPr id="31" name="Increase 5 circle"/>
+          <p:cNvSpPr/>
+          <p:nvPr/>
+        </p:nvSpPr>
+        <p:spPr>
+          <a:xfrm>
+            <a:off x="8156448" y="1536192"/>
+            <a:ext cx="384048" cy="384048"/>
+          </a:xfrm>
+          <a:prstGeom prst="ellipse">
+            <a:avLst/>
+          </a:prstGeom>
+          <a:solidFill>
+            <a:schemeClr val="accent4"/>
+          </a:solidFill>
+          <a:ln/>
+        </p:spPr>
+      </p:sp>
+      <p:pic>
+        <p:nvPicPr>
+          <p:cNvPr id="32" name="Increase 5 icon" descr="Increase 5">    </p:cNvPr>
+          <p:cNvPicPr>
+            <a:picLocks noChangeAspect="1"/>
+          </p:cNvPicPr>
+          <p:nvPr/>
+        </p:nvPicPr>
+        <p:blipFill>
+          <a:blip r:embed="rId10"/>
+          <a:stretch>
+            <a:fillRect/>
+          </a:stretch>
+        </p:blipFill>
+        <p:spPr>
+          <a:xfrm>
+            <a:off x="8260141" y="1639885"/>
+            <a:ext cx="176662" cy="176662"/>
+          </a:xfrm>
+          <a:prstGeom prst="rect">
+            <a:avLst/>
+          </a:prstGeom>
+        </p:spPr>
+      </p:pic>
+      <p:sp>
+        <p:nvSpPr>
+          <p:cNvPr id="33" name="Result text 5"/>
           <p:cNvSpPr txBox="1"/>
           <p:nvPr/>
         </p:nvSpPr>
         <p:spPr>
           <a:xfrm>
-            <a:off x="457200" y="3703320"/>
-            <a:ext cx="1536192" cy="420624"/>
-          </a:xfrm>
-          <a:prstGeom prst="rect">
-            <a:avLst/>
-          </a:prstGeom>
-          <a:noFill/>
-          <a:ln/>
-        </p:spPr>
-        <p:txBody>
-          <a:bodyPr wrap="square" lIns="0" tIns="0" rIns="0" bIns="0" rtlCol="0" anchor="ctr"/>
-          <a:lstStyle/>
-          <a:p>
-            <a:pPr algn="ctr" indent="0" marL="0">
-              <a:buNone/>
-            </a:pPr>
-            <a:r>
-              <a:rPr lang="en-US" sz="1300" b="1" dirty="0">
-                <a:solidFill>
-                  <a:schemeClr val="accent1"/>
-                </a:solidFill>
-              </a:rPr>
-              <a:t>Reach</a:t>
-            </a:r>
-            <a:endParaRPr lang="en-US" sz="1300" dirty="0"/>
-          </a:p>
-        </p:txBody>
-      </p:sp>
-      <p:sp>
-        <p:nvSpPr>
-          <p:cNvPr id="31" name="Metric pill 2"/>
-          <p:cNvSpPr/>
-          <p:nvPr/>
-        </p:nvSpPr>
-        <p:spPr>
-          <a:xfrm>
-            <a:off x="2130552" y="3703320"/>
-            <a:ext cx="1536192" cy="420624"/>
+            <a:off x="7351776" y="2194560"/>
+            <a:ext cx="1280160" cy="868680"/>
+          </a:xfrm>
+          <a:prstGeom prst="rect">
+            <a:avLst/>
+          </a:prstGeom>
+          <a:noFill/>
+          <a:ln/>
+        </p:spPr>
+        <p:txBody>
+          <a:bodyPr wrap="square" lIns="0" tIns="0" rIns="0" bIns="0" rtlCol="0" anchor="t"/>
+          <a:lstStyle/>
+          <a:p>
+            <a:pPr indent="0" marL="0">
+              <a:buNone/>
+            </a:pPr>
+            <a:r>
+              <a:rPr lang="en-US" sz="1500" b="1" dirty="0">
+                <a:solidFill>
+                  <a:schemeClr val="tx2"/>
+                </a:solidFill>
+              </a:rPr>
+              <a:t>More sales</a:t>
+            </a:r>
+            <a:endParaRPr lang="en-US" sz="1500" dirty="0"/>
+          </a:p>
+          <a:p>
+            <a:pPr indent="0" marL="0">
+              <a:buNone/>
+            </a:pPr>
+            <a:r>
+              <a:rPr lang="en-US" sz="1200" dirty="0">
+                <a:solidFill>
+                  <a:schemeClr val="tx1"/>
+                </a:solidFill>
+              </a:rPr>
+              <a:t>performance</a:t>
+            </a:r>
+            <a:endParaRPr lang="en-US" sz="1500" dirty="0"/>
+          </a:p>
+        </p:txBody>
+      </p:sp>
+      <p:sp>
+        <p:nvSpPr>
+          <p:cNvPr id="34" name="Tracking box"/>
+          <p:cNvSpPr/>
+          <p:nvPr/>
+        </p:nvSpPr>
+        <p:spPr>
+          <a:xfrm>
+            <a:off x="457200" y="3429000"/>
+            <a:ext cx="8229600" cy="1097280"/>
           </a:xfrm>
           <a:prstGeom prst="roundRect">
             <a:avLst>
-              <a:gd name="adj" fmla="val 50000"/>
+              <a:gd name="adj" fmla="val 10000"/>
             </a:avLst>
           </a:prstGeom>
           <a:solidFill>
-            <a:schemeClr val="bg1"/>
+            <a:schemeClr val="tx2"/>
           </a:solidFill>
-          <a:ln w="15875">
-            <a:solidFill>
-              <a:srgbClr val="C27A3A"/>
-            </a:solidFill>
-            <a:prstDash val="solid"/>
-          </a:ln>
-        </p:spPr>
-      </p:sp>
-      <p:sp>
-        <p:nvSpPr>
-          <p:cNvPr id="32" name="Metric 2"/>
+          <a:ln/>
+        </p:spPr>
+      </p:sp>
+      <p:sp>
+        <p:nvSpPr>
+          <p:cNvPr id="35" name="Tracking circle"/>
+          <p:cNvSpPr/>
+          <p:nvPr/>
+        </p:nvSpPr>
+        <p:spPr>
+          <a:xfrm>
+            <a:off x="731520" y="3657600"/>
+            <a:ext cx="640080" cy="640080"/>
+          </a:xfrm>
+          <a:prstGeom prst="ellipse">
+            <a:avLst/>
+          </a:prstGeom>
+          <a:solidFill>
+            <a:schemeClr val="accent4"/>
+          </a:solidFill>
+          <a:ln/>
+        </p:spPr>
+      </p:sp>
+      <p:pic>
+        <p:nvPicPr>
+          <p:cNvPr id="36" name="Tracking icon" descr="Tracking">    </p:cNvPr>
+          <p:cNvPicPr>
+            <a:picLocks noChangeAspect="1"/>
+          </p:cNvPicPr>
+          <p:nvPr/>
+        </p:nvPicPr>
+        <p:blipFill>
+          <a:blip r:embed="rId11"/>
+          <a:stretch>
+            <a:fillRect/>
+          </a:stretch>
+        </p:blipFill>
+        <p:spPr>
+          <a:xfrm>
+            <a:off x="904342" y="3830422"/>
+            <a:ext cx="294437" cy="294437"/>
+          </a:xfrm>
+          <a:prstGeom prst="rect">
+            <a:avLst/>
+          </a:prstGeom>
+        </p:spPr>
+      </p:pic>
+      <p:sp>
+        <p:nvSpPr>
+          <p:cNvPr id="37" name="Tracking text"/>
           <p:cNvSpPr txBox="1"/>
           <p:nvPr/>
         </p:nvSpPr>
         <p:spPr>
           <a:xfrm>
-            <a:off x="2130552" y="3703320"/>
-            <a:ext cx="1536192" cy="420624"/>
+            <a:off x="1600200" y="3429000"/>
+            <a:ext cx="6858000" cy="1097280"/>
           </a:xfrm>
           <a:prstGeom prst="rect">
             <a:avLst/>
@@ -9460,243 +9595,32 @@
           <a:bodyPr wrap="square" lIns="0" tIns="0" rIns="0" bIns="0" rtlCol="0" anchor="ctr"/>
           <a:lstStyle/>
           <a:p>
-            <a:pPr algn="ctr" indent="0" marL="0">
-              <a:buNone/>
-            </a:pPr>
-            <a:r>
-              <a:rPr lang="en-US" sz="1300" b="1" dirty="0">
-                <a:solidFill>
-                  <a:schemeClr val="accent1"/>
-                </a:solidFill>
-              </a:rPr>
-              <a:t>Engagement rate</a:t>
-            </a:r>
-            <a:endParaRPr lang="en-US" sz="1300" dirty="0"/>
-          </a:p>
-        </p:txBody>
-      </p:sp>
-      <p:sp>
-        <p:nvSpPr>
-          <p:cNvPr id="33" name="Metric pill 3"/>
-          <p:cNvSpPr/>
-          <p:nvPr/>
-        </p:nvSpPr>
-        <p:spPr>
-          <a:xfrm>
-            <a:off x="3803904" y="3703320"/>
-            <a:ext cx="1536192" cy="420624"/>
-          </a:xfrm>
-          <a:prstGeom prst="roundRect">
-            <a:avLst>
-              <a:gd name="adj" fmla="val 50000"/>
-            </a:avLst>
-          </a:prstGeom>
-          <a:solidFill>
-            <a:schemeClr val="bg1"/>
-          </a:solidFill>
-          <a:ln w="15875">
-            <a:solidFill>
-              <a:srgbClr val="C27A3A"/>
-            </a:solidFill>
-            <a:prstDash val="solid"/>
-          </a:ln>
-        </p:spPr>
-      </p:sp>
-      <p:sp>
-        <p:nvSpPr>
-          <p:cNvPr id="34" name="Metric 3"/>
-          <p:cNvSpPr txBox="1"/>
-          <p:nvPr/>
-        </p:nvSpPr>
-        <p:spPr>
-          <a:xfrm>
-            <a:off x="3803904" y="3703320"/>
-            <a:ext cx="1536192" cy="420624"/>
-          </a:xfrm>
-          <a:prstGeom prst="rect">
-            <a:avLst/>
-          </a:prstGeom>
-          <a:noFill/>
-          <a:ln/>
-        </p:spPr>
-        <p:txBody>
-          <a:bodyPr wrap="square" lIns="0" tIns="0" rIns="0" bIns="0" rtlCol="0" anchor="ctr"/>
-          <a:lstStyle/>
-          <a:p>
-            <a:pPr algn="ctr" indent="0" marL="0">
-              <a:buNone/>
-            </a:pPr>
-            <a:r>
-              <a:rPr lang="en-US" sz="1300" b="1" dirty="0">
-                <a:solidFill>
-                  <a:schemeClr val="accent1"/>
-                </a:solidFill>
-              </a:rPr>
-              <a:t>Cost per inquiry</a:t>
-            </a:r>
-            <a:endParaRPr lang="en-US" sz="1300" dirty="0"/>
-          </a:p>
-        </p:txBody>
-      </p:sp>
-      <p:sp>
-        <p:nvSpPr>
-          <p:cNvPr id="35" name="Metric pill 4"/>
-          <p:cNvSpPr/>
-          <p:nvPr/>
-        </p:nvSpPr>
-        <p:spPr>
-          <a:xfrm>
-            <a:off x="5477256" y="3703320"/>
-            <a:ext cx="1536192" cy="420624"/>
-          </a:xfrm>
-          <a:prstGeom prst="roundRect">
-            <a:avLst>
-              <a:gd name="adj" fmla="val 50000"/>
-            </a:avLst>
-          </a:prstGeom>
-          <a:solidFill>
-            <a:schemeClr val="bg1"/>
-          </a:solidFill>
-          <a:ln w="15875">
-            <a:solidFill>
-              <a:srgbClr val="C27A3A"/>
-            </a:solidFill>
-            <a:prstDash val="solid"/>
-          </a:ln>
-        </p:spPr>
-      </p:sp>
-      <p:sp>
-        <p:nvSpPr>
-          <p:cNvPr id="36" name="Metric 4"/>
-          <p:cNvSpPr txBox="1"/>
-          <p:nvPr/>
-        </p:nvSpPr>
-        <p:spPr>
-          <a:xfrm>
-            <a:off x="5477256" y="3703320"/>
-            <a:ext cx="1536192" cy="420624"/>
-          </a:xfrm>
-          <a:prstGeom prst="rect">
-            <a:avLst/>
-          </a:prstGeom>
-          <a:noFill/>
-          <a:ln/>
-        </p:spPr>
-        <p:txBody>
-          <a:bodyPr wrap="square" lIns="0" tIns="0" rIns="0" bIns="0" rtlCol="0" anchor="ctr"/>
-          <a:lstStyle/>
-          <a:p>
-            <a:pPr algn="ctr" indent="0" marL="0">
-              <a:buNone/>
-            </a:pPr>
-            <a:r>
-              <a:rPr lang="en-US" sz="1300" b="1" dirty="0">
-                <a:solidFill>
-                  <a:schemeClr val="accent1"/>
-                </a:solidFill>
-              </a:rPr>
-              <a:t>Customer visits</a:t>
-            </a:r>
-            <a:endParaRPr lang="en-US" sz="1300" dirty="0"/>
-          </a:p>
-        </p:txBody>
-      </p:sp>
-      <p:sp>
-        <p:nvSpPr>
-          <p:cNvPr id="37" name="Metric pill 5"/>
-          <p:cNvSpPr/>
-          <p:nvPr/>
-        </p:nvSpPr>
-        <p:spPr>
-          <a:xfrm>
-            <a:off x="7150608" y="3703320"/>
-            <a:ext cx="1536192" cy="420624"/>
-          </a:xfrm>
-          <a:prstGeom prst="roundRect">
-            <a:avLst>
-              <a:gd name="adj" fmla="val 50000"/>
-            </a:avLst>
-          </a:prstGeom>
-          <a:solidFill>
-            <a:schemeClr val="bg1"/>
-          </a:solidFill>
-          <a:ln w="15875">
-            <a:solidFill>
-              <a:srgbClr val="C27A3A"/>
-            </a:solidFill>
-            <a:prstDash val="solid"/>
-          </a:ln>
-        </p:spPr>
-      </p:sp>
-      <p:sp>
-        <p:nvSpPr>
-          <p:cNvPr id="38" name="Metric 5"/>
-          <p:cNvSpPr txBox="1"/>
-          <p:nvPr/>
-        </p:nvSpPr>
-        <p:spPr>
-          <a:xfrm>
-            <a:off x="7150608" y="3703320"/>
-            <a:ext cx="1536192" cy="420624"/>
-          </a:xfrm>
-          <a:prstGeom prst="rect">
-            <a:avLst/>
-          </a:prstGeom>
-          <a:noFill/>
-          <a:ln/>
-        </p:spPr>
-        <p:txBody>
-          <a:bodyPr wrap="square" lIns="0" tIns="0" rIns="0" bIns="0" rtlCol="0" anchor="ctr"/>
-          <a:lstStyle/>
-          <a:p>
-            <a:pPr algn="ctr" indent="0" marL="0">
-              <a:buNone/>
-            </a:pPr>
-            <a:r>
-              <a:rPr lang="en-US" sz="1300" b="1" dirty="0">
-                <a:solidFill>
-                  <a:schemeClr val="accent1"/>
-                </a:solidFill>
-              </a:rPr>
-              <a:t>Sales</a:t>
-            </a:r>
-            <a:endParaRPr lang="en-US" sz="1300" dirty="0"/>
-          </a:p>
-        </p:txBody>
-      </p:sp>
-      <p:sp>
-        <p:nvSpPr>
-          <p:cNvPr id="39" name="Results disclaimer"/>
-          <p:cNvSpPr txBox="1"/>
-          <p:nvPr/>
-        </p:nvSpPr>
-        <p:spPr>
-          <a:xfrm>
-            <a:off x="457200" y="4279392"/>
-            <a:ext cx="8229600" cy="274320"/>
-          </a:xfrm>
-          <a:prstGeom prst="rect">
-            <a:avLst/>
-          </a:prstGeom>
-          <a:noFill/>
-          <a:ln/>
-        </p:spPr>
-        <p:txBody>
-          <a:bodyPr wrap="square" lIns="0" tIns="0" rIns="0" bIns="0" rtlCol="0" anchor="ctr"/>
-          <a:lstStyle/>
-          <a:p>
             <a:pPr indent="0" marL="0">
               <a:buNone/>
             </a:pPr>
             <a:r>
-              <a:rPr lang="en-US" sz="1000" dirty="0">
-                <a:solidFill>
-                  <a:schemeClr val="accent5"/>
-                </a:solidFill>
-              </a:rPr>
-              <a:t>Targets are set after reviewing the café's current performance. Results are not guaranteed.</a:t>
-            </a:r>
-            <a:endParaRPr lang="en-US" sz="1000" dirty="0"/>
+              <a:rPr lang="en-US" sz="1800" b="1" dirty="0">
+                <a:solidFill>
+                  <a:schemeClr val="bg1"/>
+                </a:solidFill>
+              </a:rPr>
+              <a:t>We track the results</a:t>
+            </a:r>
+            <a:endParaRPr lang="en-US" sz="1800" dirty="0"/>
+          </a:p>
+          <a:p>
+            <a:pPr indent="0" marL="0">
+              <a:buNone/>
+            </a:pPr>
+            <a:r>
+              <a:rPr lang="en-US" sz="1400" dirty="0">
+                <a:solidFill>
+                  <a:schemeClr val="accent2"/>
+                </a:solidFill>
+              </a:rPr>
+              <a:t>to understand what works best</a:t>
+            </a:r>
+            <a:endParaRPr lang="en-US" sz="1800" dirty="0"/>
           </a:p>
         </p:txBody>
       </p:sp>
@@ -9779,7 +9703,7 @@
         <a:srgbClr val="6F4E37"/>
       </a:accent3>
       <a:accent4>
-        <a:srgbClr val="7A9A7E"/>
+        <a:srgbClr val="5B7F5E"/>
       </a:accent4>
       <a:accent5>
         <a:srgbClr val="8C7F76"/>

</xml_diff>

<commit_message>
Make café proposal more persuasive
Add concrete month-one targets, a return-on-investment slide, a
why-choose-us slide with risk reversals, concrete monthly deliverables,
and a stronger call to action with a start-this-month bonus.

Co-Authored-By: Claude Opus 5.5 <noreply@anthropic.com>
Claude-Session: https://claude.ai/code/session_01FBuHsgfNN7NePtiYw7LpVx
</commit_message>
<xml_diff>
--- a/Cafe_Marketing_Proposal.pptx
+++ b/Cafe_Marketing_Proposal.pptx
@@ -16,9 +16,11 @@
     <p:sldId id="264" r:id="rId10"/>
     <p:sldId id="265" r:id="rId11"/>
     <p:sldId id="266" r:id="rId12"/>
+    <p:sldId id="267" r:id="rId13"/>
+    <p:sldId id="268" r:id="rId14"/>
   </p:sldIdLst>
   <p:notesMasterIdLst>
-    <p:notesMasterId r:id="rId13"/>
+    <p:notesMasterId r:id="rId15"/>
   </p:notesMasterIdLst>
   <p:sldSz cx="9144000" cy="5143500"/>
   <p:notesSz cx="5143500" cy="9144000"/>
@@ -117,39 +119,45 @@
   <p:extLst>
     <p:ext uri="{521415D9-36F7-43E2-AB2F-B90AF26B5E84}">
       <p14:sectionLst xmlns:p14="http://schemas.microsoft.com/office/powerpoint/2010/main">
-        <p14:section name="Introduction" id="{e2b1dd3d-62ba-4e62-df16-e882d4886722}">
+        <p14:section name="Introduction" id="{5bdd043f-870c-001b-56d1-4f9a39e0baaa}">
           <p14:sldIdLst>
             <p14:sldId id="256"/>
             <p14:sldId id="257"/>
           </p14:sldIdLst>
         </p14:section>
-        <p14:section name="Problem" id="{49f65fef-79c9-ef57-eb77-9c9846c35fab}">
+        <p14:section name="Problem" id="{057a16e2-1dc4-0da3-83e4-3b2bf742f064}">
           <p14:sldIdLst>
             <p14:sldId id="258"/>
           </p14:sldIdLst>
         </p14:section>
-        <p14:section name="Solution" id="{1dd3e3ab-358d-cdff-2b0c-54b83b9ab916}">
+        <p14:section name="Solution" id="{8df52afd-9d71-7ab7-b465-7a541c8ca3f4}">
           <p14:sldIdLst>
             <p14:sldId id="259"/>
             <p14:sldId id="260"/>
           </p14:sldIdLst>
         </p14:section>
-        <p14:section name="Budget and Timeline" id="{da5e3706-3aa2-8250-fd5d-62c22d81ef7c}">
+        <p14:section name="Budget and Timeline" id="{2856a4ab-21f2-bd0d-858c-a26653fdd40c}">
           <p14:sldIdLst>
             <p14:sldId id="261"/>
             <p14:sldId id="262"/>
           </p14:sldIdLst>
         </p14:section>
-        <p14:section name="Results" id="{acff62f4-050c-9ce2-49a1-737b1cc3ff45}">
+        <p14:section name="Results" id="{313db6e8-18c3-467d-971e-c40fbfb32d21}">
           <p14:sldIdLst>
             <p14:sldId id="263"/>
             <p14:sldId id="264"/>
             <p14:sldId id="265"/>
+            <p14:sldId id="266"/>
           </p14:sldIdLst>
         </p14:section>
-        <p14:section name="Conclusion" id="{79dde2e4-27d2-468c-c1c0-15917b20f069}">
+        <p14:section name="Why Us" id="{5037e329-baf9-e1bc-c8fa-db23593521ba}">
           <p14:sldIdLst>
-            <p14:sldId id="266"/>
+            <p14:sldId id="267"/>
+          </p14:sldIdLst>
+        </p14:section>
+        <p14:section name="Conclusion" id="{c088e8e0-617b-067e-7990-23dda1b90d8a}">
+          <p14:sldIdLst>
+            <p14:sldId id="268"/>
           </p14:sldIdLst>
         </p14:section>
       </p14:sectionLst>
@@ -458,6 +466,279 @@
 </c:chartSpace>
 </file>
 
+<file path=ppt/charts/chart2.xml><?xml version="1.0" encoding="utf-8"?>
+<c:chartSpace xmlns:c="http://schemas.openxmlformats.org/drawingml/2006/chart" xmlns:a="http://schemas.openxmlformats.org/drawingml/2006/main" xmlns:r="http://schemas.openxmlformats.org/officeDocument/2006/relationships">
+  <c:date1904 val="0"/>
+  <c:roundedCorners val="1"/>
+  <c:chart>
+    <c:title>
+      <c:tx>
+        <c:rich>
+          <a:bodyPr/>
+          <a:lstStyle/>
+          <a:p>
+            <a:pPr>
+              <a:defRPr sz="1200" b="0" i="0" u="none" strike="noStrike">
+                <a:solidFill>
+                  <a:srgbClr val="2E1F17"/>
+                </a:solidFill>
+                <a:latin typeface="+mn-lt"/>
+              </a:defRPr>
+            </a:pPr>
+            <a:r>
+              <a:rPr sz="1200" b="0" i="0" u="none" strike="noStrike">
+                <a:solidFill>
+                  <a:srgbClr val="2E1F17"/>
+                </a:solidFill>
+                <a:latin typeface="+mn-lt"/>
+              </a:rPr>
+              <a:t>Monthly profit vs. cost (EGP)</a:t>
+            </a:r>
+          </a:p>
+        </c:rich>
+      </c:tx>
+      <c:layout/>
+      <c:overlay val="0"/>
+    </c:title>
+    <c:autoTitleDeleted val="0"/>
+    <c:plotArea>
+      <c:layout/>
+      <c:barChart>
+        <c:barDir val="bar"/>
+        <c:grouping val="clustered"/>
+        <c:varyColors val="0"/>
+        <c:ser>
+          <c:idx val="0"/>
+          <c:order val="0"/>
+          <c:tx>
+            <c:strRef>
+              <c:f>Sheet1!$B$1</c:f>
+              <c:strCache>
+                <c:ptCount val="1"/>
+                <c:pt idx="0">
+                  <c:v>EGP per month</c:v>
+                </c:pt>
+              </c:strCache>
+            </c:strRef>
+          </c:tx>
+          <c:spPr>
+            <a:solidFill>
+              <a:srgbClr val="C27A3A"/>
+            </a:solidFill>
+            <a:effectLst/>
+          </c:spPr>
+          <c:invertIfNegative val="0"/>
+          <c:dLbls>
+            <c:numFmt formatCode="#,##0" sourceLinked="0"/>
+            <c:txPr>
+              <a:bodyPr/>
+              <a:lstStyle/>
+              <a:p>
+                <a:pPr>
+                  <a:defRPr b="1" i="0" strike="noStrike" sz="1200" u="none">
+                    <a:solidFill>
+                      <a:srgbClr val="2E1F17"/>
+                    </a:solidFill>
+                    <a:latin typeface="+mn-lt"/>
+                  </a:defRPr>
+                </a:pPr>
+              </a:p>
+            </c:txPr>
+            <c:showLegendKey val="0"/>
+            <c:showVal val="1"/>
+            <c:showCatName val="0"/>
+            <c:showSerName val="0"/>
+            <c:showPercent val="0"/>
+            <c:showBubbleSize val="0"/>
+            <c:showLeaderLines val="0"/>
+          </c:dLbls>
+          <c:dPt>
+            <c:idx val="0"/>
+            <c:invertIfNegative val="0"/>
+            <c:bubble3D val="0"/>
+            <c:spPr>
+              <a:solidFill>
+                <a:srgbClr val="C27A3A"/>
+              </a:solidFill>
+              <a:effectLst/>
+            </c:spPr>
+          </c:dPt>
+          <c:dPt>
+            <c:idx val="1"/>
+            <c:invertIfNegative val="0"/>
+            <c:bubble3D val="0"/>
+            <c:spPr>
+              <a:solidFill>
+                <a:srgbClr val="8C7F76"/>
+              </a:solidFill>
+              <a:effectLst/>
+            </c:spPr>
+          </c:dPt>
+          <c:cat>
+            <c:multiLvlStrRef>
+              <c:f>Sheet1!$A$2:$A$3</c:f>
+              <c:multiLvlStrCache>
+                <c:ptCount val="2"/>
+                <c:lvl>
+                  <c:pt idx="0">
+                    <c:v>You gain at target</c:v>
+                  </c:pt>
+                  <c:pt idx="1">
+                    <c:v>You invest</c:v>
+                  </c:pt>
+                </c:lvl>
+              </c:multiLvlStrCache>
+            </c:multiLvlStrRef>
+          </c:cat>
+          <c:val>
+            <c:numRef>
+              <c:f>Sheet1!$B$2:$B$3</c:f>
+              <c:numCache>
+                <c:formatCode>General</c:formatCode>
+                <c:ptCount val="2"/>
+                <c:pt idx="0">
+                  <c:v>30000</c:v>
+                </c:pt>
+                <c:pt idx="1">
+                  <c:v>13000</c:v>
+                </c:pt>
+              </c:numCache>
+            </c:numRef>
+          </c:val>
+        </c:ser>
+        <c:dLbls>
+          <c:numFmt formatCode="#,##0" sourceLinked="0"/>
+          <c:txPr>
+            <a:bodyPr/>
+            <a:lstStyle/>
+            <a:p>
+              <a:pPr>
+                <a:defRPr b="1" i="0" strike="noStrike" sz="1200" u="none">
+                  <a:solidFill>
+                    <a:srgbClr val="2E1F17"/>
+                  </a:solidFill>
+                  <a:latin typeface="+mn-lt"/>
+                </a:defRPr>
+              </a:pPr>
+            </a:p>
+          </c:txPr>
+          <c:showLegendKey val="0"/>
+          <c:showVal val="1"/>
+          <c:showCatName val="0"/>
+          <c:showSerName val="0"/>
+          <c:showPercent val="0"/>
+          <c:showBubbleSize val="0"/>
+          <c:showLeaderLines val="0"/>
+        </c:dLbls>
+        <c:gapWidth val="45"/>
+        <c:overlap val="0"/>
+        <c:axId val="2094734554"/>
+        <c:axId val="2094734552"/>
+        <c:axId val="2094734556"/>
+      </c:barChart>
+      <c:catAx>
+        <c:axId val="2094734554"/>
+        <c:scaling>
+          <c:orientation val="minMax"/>
+        </c:scaling>
+        <c:delete val="0"/>
+        <c:axPos val="l"/>
+        <c:numFmt formatCode="General" sourceLinked="1"/>
+        <c:majorTickMark val="out"/>
+        <c:minorTickMark val="none"/>
+        <c:tickLblPos val="nextTo"/>
+        <c:spPr>
+          <a:ln w="12700" cap="flat">
+            <a:noFill/>
+            <a:prstDash val="solid"/>
+            <a:round/>
+          </a:ln>
+        </c:spPr>
+        <c:txPr>
+          <a:bodyPr/>
+          <a:lstStyle/>
+          <a:p>
+            <a:pPr>
+              <a:defRPr sz="1200" b="0" i="0" u="none" strike="noStrike">
+                <a:solidFill>
+                  <a:srgbClr val="2E1F17"/>
+                </a:solidFill>
+                <a:latin typeface="+mn-lt"/>
+              </a:defRPr>
+            </a:pPr>
+            <a:endParaRPr lang="en-US"/>
+          </a:p>
+        </c:txPr>
+        <c:crossAx val="2094734552"/>
+        <c:crosses val="autoZero"/>
+        <c:auto val="1"/>
+        <c:lblAlgn val="ctr"/>
+        <c:noMultiLvlLbl val="1"/>
+      </c:catAx>
+      <c:valAx>
+        <c:axId val="2094734552"/>
+        <c:scaling>
+          <c:orientation val="minMax"/>
+          <c:max val="36000"/>
+        </c:scaling>
+        <c:delete val="1"/>
+        <c:axPos val="b"/>
+        <c:numFmt formatCode="General" sourceLinked="0"/>
+        <c:majorTickMark val="out"/>
+        <c:minorTickMark val="none"/>
+        <c:tickLblPos val="low"/>
+        <c:spPr>
+          <a:ln w="12700" cap="flat">
+            <a:solidFill>
+              <a:srgbClr val="888888"/>
+            </a:solidFill>
+            <a:prstDash val="solid"/>
+            <a:round/>
+          </a:ln>
+        </c:spPr>
+        <c:txPr>
+          <a:bodyPr/>
+          <a:lstStyle/>
+          <a:p>
+            <a:pPr>
+              <a:defRPr sz="1200" b="0" i="0" u="none" strike="noStrike">
+                <a:solidFill>
+                  <a:srgbClr val="000000"/>
+                </a:solidFill>
+                <a:latin typeface="Arial"/>
+              </a:defRPr>
+            </a:pPr>
+            <a:endParaRPr lang="en-US"/>
+          </a:p>
+        </c:txPr>
+        <c:crossAx val="2094734554"/>
+        <c:crosses val="autoZero"/>
+        <c:crossBetween val="between"/>
+      </c:valAx>
+      <c:spPr>
+        <a:noFill/>
+        <a:ln>
+          <a:noFill/>
+        </a:ln>
+        <a:effectLst/>
+      </c:spPr>
+    </c:plotArea>
+    <c:plotVisOnly val="1"/>
+    <c:dispBlanksAs val="span"/>
+  </c:chart>
+  <c:spPr>
+    <a:noFill/>
+    <a:ln>
+      <a:noFill/>
+    </a:ln>
+    <a:effectLst/>
+  </c:spPr>
+  <c:externalData r:id="rId1">
+    <c:autoUpdate val="0"/>
+  </c:externalData>
+</c:chartSpace>
+</file>
+
 <file path=ppt/notesMasters/notesMaster1.xml><?xml version="1.0" encoding="utf-8"?>
 <p:notesMaster xmlns:a="http://schemas.openxmlformats.org/drawingml/2006/main" xmlns:r="http://schemas.openxmlformats.org/officeDocument/2006/relationships" xmlns:p="http://schemas.openxmlformats.org/presentationml/2006/main">
   <p:cSld>
@@ -942,12 +1223,11 @@
           <a:p>
             <a:r>
               <a:rPr lang="en-US" dirty="0"/>
-              <a:t>After the first month, we plan to:
-- Work with local food influencers.
-- Launch loyalty programs for regular customers.
-- Create seasonal offers.
-- Expand successful advertising campaigns.
-- Develop a long-term marketing strategy.</a:t>
+              <a:t>This is the most important slide for the owner: the plan pays for itself.
+- Each customer spends about 150 EGP. After ingredients, the café keeps about 100 EGP.
+- 13,000 EGP divided by 100 EGP = 130 customers a month, which is less than 5 extra customers a day.
+- Our target is 10 extra customers a day: 10 × 30 days × 100 EGP = about 30,000 EGP extra profit per month, more than double the cost.
+Ask the owner: "Do you think 5 more customers a day is possible with better marketing?"</a:t>
             </a:r>
             <a:endParaRPr lang="en-US" dirty="0"/>
           </a:p>
@@ -1035,9 +1315,12 @@
           <a:p>
             <a:r>
               <a:rPr lang="en-US" dirty="0"/>
-              <a:t>Our agency is ready to help The Daily Cup grow and reach more customers.
-We believe that a good marketing strategy can improve the café's online presence and support its business growth.
-Let's grow together! Then thank the owner and open for questions.</a:t>
+              <a:t>After the first month, we plan to:
+- Work with local food influencers.
+- Launch loyalty programs for regular customers.
+- Create seasonal offers.
+- Expand successful advertising campaigns.
+- Develop a long-term marketing strategy.</a:t>
             </a:r>
             <a:endParaRPr lang="en-US" dirty="0"/>
           </a:p>
@@ -1061,6 +1344,196 @@
             <a:fld id="{F7021451-1387-4CA6-816F-3879F97B5CBC}" type="slidenum">
               <a:rPr lang="en-US"/>
               <a:t>11</a:t>
+            </a:fld>
+            <a:endParaRPr lang="en-US"/>
+          </a:p>
+        </p:txBody>
+      </p:sp>
+    </p:spTree>
+    <p:extLst>
+      <p:ext uri="{BB962C8B-B14F-4D97-AF65-F5344CB8AC3E}">
+        <p14:creationId xmlns:p14="http://schemas.microsoft.com/office/powerpoint/2010/main" val="1024086991"/>
+      </p:ext>
+    </p:extLst>
+  </p:cSld>
+  <p:clrMapOvr>
+    <a:masterClrMapping/>
+  </p:clrMapOvr>
+</p:notes>
+</file>
+
+<file path=ppt/notesSlides/notesSlide12.xml><?xml version="1.0" encoding="utf-8"?>
+<p:notes xmlns:a="http://schemas.openxmlformats.org/drawingml/2006/main" xmlns:r="http://schemas.openxmlformats.org/officeDocument/2006/relationships" xmlns:p="http://schemas.openxmlformats.org/presentationml/2006/main">
+  <p:cSld>
+    <p:spTree>
+      <p:nvGrpSpPr>
+        <p:cNvPr id="1" name=""/>
+        <p:cNvGrpSpPr/>
+        <p:nvPr/>
+      </p:nvGrpSpPr>
+      <p:grpSpPr>
+        <a:xfrm>
+          <a:off x="0" y="0"/>
+          <a:ext cx="0" cy="0"/>
+          <a:chOff x="0" y="0"/>
+          <a:chExt cx="0" cy="0"/>
+        </a:xfrm>
+      </p:grpSpPr>
+      <p:sp>
+        <p:nvSpPr>
+          <p:cNvPr id="2" name="Slide Image Placeholder 1"/>
+          <p:cNvSpPr>
+            <a:spLocks noGrp="1" noRot="1" noChangeAspect="1"/>
+          </p:cNvSpPr>
+          <p:nvPr>
+            <p:ph type="sldImg"/>
+          </p:nvPr>
+        </p:nvSpPr>
+        <p:spPr/>
+      </p:sp>
+      <p:sp>
+        <p:nvSpPr>
+          <p:cNvPr id="3" name="Notes Placeholder 2"/>
+          <p:cNvSpPr>
+            <a:spLocks noGrp="1"/>
+          </p:cNvSpPr>
+          <p:nvPr>
+            <p:ph type="body" idx="1"/>
+          </p:nvPr>
+        </p:nvSpPr>
+        <p:spPr/>
+        <p:txBody>
+          <a:bodyPr/>
+          <a:lstStyle/>
+          <a:p>
+            <a:r>
+              <a:rPr lang="en-US" dirty="0"/>
+              <a:t>Why the owner should choose us:
+- Café specialists: we focus on cafés and restaurants, so we know what brings people in.
+- Your own team: one dedicated account manager for The Daily Cup.
+- Weekly reports: the owner sees exactly what their money does.
+The bottom row removes the risk for the owner:
+- No long-term contract: month to month, they stay because it works.
+- Free audit: we review their pages for free in week 1.
+- Reach guarantee: if we miss the reach target, we run the ads for an extra week at no fee.</a:t>
+            </a:r>
+            <a:endParaRPr lang="en-US" dirty="0"/>
+          </a:p>
+        </p:txBody>
+      </p:sp>
+      <p:sp>
+        <p:nvSpPr>
+          <p:cNvPr id="4" name="Slide Number Placeholder 3"/>
+          <p:cNvSpPr>
+            <a:spLocks noGrp="1"/>
+          </p:cNvSpPr>
+          <p:nvPr>
+            <p:ph type="sldNum" sz="quarter" idx="10"/>
+          </p:nvPr>
+        </p:nvSpPr>
+        <p:spPr/>
+        <p:txBody>
+          <a:bodyPr/>
+          <a:lstStyle/>
+          <a:p>
+            <a:fld id="{F7021451-1387-4CA6-816F-3879F97B5CBC}" type="slidenum">
+              <a:rPr lang="en-US"/>
+              <a:t>12</a:t>
+            </a:fld>
+            <a:endParaRPr lang="en-US"/>
+          </a:p>
+        </p:txBody>
+      </p:sp>
+    </p:spTree>
+    <p:extLst>
+      <p:ext uri="{BB962C8B-B14F-4D97-AF65-F5344CB8AC3E}">
+        <p14:creationId xmlns:p14="http://schemas.microsoft.com/office/powerpoint/2010/main" val="1024086991"/>
+      </p:ext>
+    </p:extLst>
+  </p:cSld>
+  <p:clrMapOvr>
+    <a:masterClrMapping/>
+  </p:clrMapOvr>
+</p:notes>
+</file>
+
+<file path=ppt/notesSlides/notesSlide13.xml><?xml version="1.0" encoding="utf-8"?>
+<p:notes xmlns:a="http://schemas.openxmlformats.org/drawingml/2006/main" xmlns:r="http://schemas.openxmlformats.org/officeDocument/2006/relationships" xmlns:p="http://schemas.openxmlformats.org/presentationml/2006/main">
+  <p:cSld>
+    <p:spTree>
+      <p:nvGrpSpPr>
+        <p:cNvPr id="1" name=""/>
+        <p:cNvGrpSpPr/>
+        <p:nvPr/>
+      </p:nvGrpSpPr>
+      <p:grpSpPr>
+        <a:xfrm>
+          <a:off x="0" y="0"/>
+          <a:ext cx="0" cy="0"/>
+          <a:chOff x="0" y="0"/>
+          <a:chExt cx="0" cy="0"/>
+        </a:xfrm>
+      </p:grpSpPr>
+      <p:sp>
+        <p:nvSpPr>
+          <p:cNvPr id="2" name="Slide Image Placeholder 1"/>
+          <p:cNvSpPr>
+            <a:spLocks noGrp="1" noRot="1" noChangeAspect="1"/>
+          </p:cNvSpPr>
+          <p:nvPr>
+            <p:ph type="sldImg"/>
+          </p:nvPr>
+        </p:nvSpPr>
+        <p:spPr/>
+      </p:sp>
+      <p:sp>
+        <p:nvSpPr>
+          <p:cNvPr id="3" name="Notes Placeholder 2"/>
+          <p:cNvSpPr>
+            <a:spLocks noGrp="1"/>
+          </p:cNvSpPr>
+          <p:nvPr>
+            <p:ph type="body" idx="1"/>
+          </p:nvPr>
+        </p:nvSpPr>
+        <p:spPr/>
+        <p:txBody>
+          <a:bodyPr/>
+          <a:lstStyle/>
+          <a:p>
+            <a:r>
+              <a:rPr lang="en-US" dirty="0"/>
+              <a:t>Summary: The Daily Cup gets more visibility, more customers and more sales, and the plan pays for itself with less than 5 extra customers a day.
+Clear next steps (shown on the right):
+1. Approve the proposal today.
+2. We do a free audit of the café's pages in week 1.
+3. The first content and ads go live in week 2.
+Bonus: if they start this month, they get a free professional photo shoot of the menu.
+Our agency is ready to help The Daily Cup grow and reach more customers. Let's grow together!
+Thank the owner and open for questions.</a:t>
+            </a:r>
+            <a:endParaRPr lang="en-US" dirty="0"/>
+          </a:p>
+        </p:txBody>
+      </p:sp>
+      <p:sp>
+        <p:nvSpPr>
+          <p:cNvPr id="4" name="Slide Number Placeholder 3"/>
+          <p:cNvSpPr>
+            <a:spLocks noGrp="1"/>
+          </p:cNvSpPr>
+          <p:nvPr>
+            <p:ph type="sldNum" sz="quarter" idx="10"/>
+          </p:nvPr>
+        </p:nvSpPr>
+        <p:spPr/>
+        <p:txBody>
+          <a:bodyPr/>
+          <a:lstStyle/>
+          <a:p>
+            <a:fld id="{F7021451-1387-4CA6-816F-3879F97B5CBC}" type="slidenum">
+              <a:rPr lang="en-US"/>
+              <a:t>13</a:t>
             </a:fld>
             <a:endParaRPr lang="en-US"/>
           </a:p>
@@ -1775,13 +2248,13 @@
           <a:p>
             <a:r>
               <a:rPr lang="en-US" dirty="0"/>
-              <a:t>During the first month, we aim to achieve:
-- More social media followers and engagement.
-- More customer inquiries.
-- Greater awareness of the café.
-- More visits from potential customers.
-- Improved sales performance.
-We will track the results to understand what works best.</a:t>
+              <a:t>These are our targets for the first month:
+- 40,000+ people in the area see The Daily Cup through ads and content.
+- 500+ new Instagram followers.
+- 100+ messages, calls and direction requests.
+- 10 extra customers every day by the end of the month.
+We don't hide anything: every week the owner receives a simple report with reach, followers, messages, visits and sales.
+Targets are based on a 4,000 EGP monthly ad budget and are confirmed after we review the café's current numbers in week 1.</a:t>
             </a:r>
             <a:endParaRPr lang="en-US" dirty="0"/>
           </a:p>
@@ -2738,7 +3211,7 @@
                   <a:schemeClr val="accent1"/>
                 </a:solidFill>
               </a:rPr>
-              <a:t>09  FUTURE WORK</a:t>
+              <a:t>09  RETURN ON INVESTMENT</a:t>
             </a:r>
             <a:endParaRPr lang="en-US" sz="1100" dirty="0"/>
           </a:p>
@@ -2779,7 +3252,7 @@
                 <a:ea typeface="Cambria" pitchFamily="34" charset="-122"/>
                 <a:cs typeface="Cambria" pitchFamily="34" charset="-120"/>
               </a:rPr>
-              <a:t>After the First Month</a:t>
+              <a:t>The Plan Pays for Itself</a:t>
             </a:r>
             <a:endParaRPr lang="en-US" sz="3200" dirty="0"/>
           </a:p>
@@ -2787,18 +3260,18 @@
       </p:sp>
       <p:sp>
         <p:nvSpPr>
-          <p:cNvPr id="4" name="Growth step 1"/>
+          <p:cNvPr id="4" name="Equation box 1"/>
           <p:cNvSpPr/>
           <p:nvPr/>
         </p:nvSpPr>
         <p:spPr>
           <a:xfrm>
-            <a:off x="457200" y="3383280"/>
-            <a:ext cx="1517904" cy="1143000"/>
+            <a:off x="457200" y="1325880"/>
+            <a:ext cx="2438430" cy="1143000"/>
           </a:xfrm>
           <a:prstGeom prst="roundRect">
             <a:avLst>
-              <a:gd name="adj" fmla="val 8000"/>
+              <a:gd name="adj" fmla="val 9600"/>
             </a:avLst>
           </a:prstGeom>
           <a:solidFill>
@@ -2809,200 +3282,293 @@
       </p:sp>
       <p:sp>
         <p:nvSpPr>
-          <p:cNvPr id="5" name="Food influencers circle"/>
+          <p:cNvPr id="5" name="Equation text 1"/>
+          <p:cNvSpPr txBox="1"/>
+          <p:nvPr/>
+        </p:nvSpPr>
+        <p:spPr>
+          <a:xfrm>
+            <a:off x="640080" y="1325880"/>
+            <a:ext cx="2072670" cy="1143000"/>
+          </a:xfrm>
+          <a:prstGeom prst="rect">
+            <a:avLst/>
+          </a:prstGeom>
+          <a:noFill/>
+          <a:ln/>
+        </p:spPr>
+        <p:txBody>
+          <a:bodyPr wrap="square" lIns="0" tIns="0" rIns="0" bIns="0" rtlCol="0" anchor="ctr"/>
+          <a:lstStyle/>
+          <a:p>
+            <a:pPr algn="ctr" indent="0" marL="0">
+              <a:buNone/>
+            </a:pPr>
+            <a:r>
+              <a:rPr lang="en-US" sz="2800" b="1" dirty="0">
+                <a:solidFill>
+                  <a:schemeClr val="tx2"/>
+                </a:solidFill>
+                <a:latin typeface="Cambria" pitchFamily="34" charset="0"/>
+                <a:ea typeface="Cambria" pitchFamily="34" charset="-122"/>
+                <a:cs typeface="Cambria" pitchFamily="34" charset="-120"/>
+              </a:rPr>
+              <a:t>13,000 EGP</a:t>
+            </a:r>
+            <a:endParaRPr lang="en-US" sz="2800" dirty="0"/>
+          </a:p>
+          <a:p>
+            <a:pPr algn="ctr" indent="0" marL="0">
+              <a:buNone/>
+            </a:pPr>
+            <a:r>
+              <a:rPr lang="en-US" sz="1300" dirty="0">
+                <a:solidFill>
+                  <a:schemeClr val="accent5"/>
+                </a:solidFill>
+              </a:rPr>
+              <a:t>monthly investment</a:t>
+            </a:r>
+            <a:endParaRPr lang="en-US" sz="2800" dirty="0"/>
+          </a:p>
+        </p:txBody>
+      </p:sp>
+      <p:sp>
+        <p:nvSpPr>
+          <p:cNvPr id="6" name="Operator 1"/>
+          <p:cNvSpPr txBox="1"/>
+          <p:nvPr/>
+        </p:nvSpPr>
+        <p:spPr>
+          <a:xfrm>
+            <a:off x="2895630" y="1325880"/>
+            <a:ext cx="457200" cy="1143000"/>
+          </a:xfrm>
+          <a:prstGeom prst="rect">
+            <a:avLst/>
+          </a:prstGeom>
+          <a:noFill/>
+          <a:ln/>
+        </p:spPr>
+        <p:txBody>
+          <a:bodyPr wrap="square" lIns="0" tIns="0" rIns="0" bIns="0" rtlCol="0" anchor="ctr"/>
+          <a:lstStyle/>
+          <a:p>
+            <a:pPr algn="ctr" indent="0" marL="0">
+              <a:buNone/>
+            </a:pPr>
+            <a:r>
+              <a:rPr lang="en-US" sz="3000" b="1" dirty="0">
+                <a:solidFill>
+                  <a:schemeClr val="accent1"/>
+                </a:solidFill>
+              </a:rPr>
+              <a:t>÷</a:t>
+            </a:r>
+            <a:endParaRPr lang="en-US" sz="3000" dirty="0"/>
+          </a:p>
+        </p:txBody>
+      </p:sp>
+      <p:sp>
+        <p:nvSpPr>
+          <p:cNvPr id="7" name="Equation box 2"/>
           <p:cNvSpPr/>
           <p:nvPr/>
         </p:nvSpPr>
         <p:spPr>
           <a:xfrm>
-            <a:off x="941832" y="2724912"/>
-            <a:ext cx="548640" cy="548640"/>
-          </a:xfrm>
-          <a:prstGeom prst="ellipse">
-            <a:avLst/>
-          </a:prstGeom>
-          <a:solidFill>
-            <a:schemeClr val="accent1"/>
-          </a:solidFill>
-          <a:ln/>
-        </p:spPr>
-      </p:sp>
-      <p:pic>
-        <p:nvPicPr>
-          <p:cNvPr id="6" name="Food influencers icon" descr="Food influencers">    </p:cNvPr>
-          <p:cNvPicPr>
-            <a:picLocks noChangeAspect="1"/>
-          </p:cNvPicPr>
-          <p:nvPr/>
-        </p:nvPicPr>
-        <p:blipFill>
-          <a:blip r:embed="rId1"/>
-          <a:stretch>
-            <a:fillRect/>
-          </a:stretch>
-        </p:blipFill>
-        <p:spPr>
-          <a:xfrm>
-            <a:off x="1089965" y="2873045"/>
-            <a:ext cx="252374" cy="252374"/>
-          </a:xfrm>
-          <a:prstGeom prst="rect">
-            <a:avLst/>
-          </a:prstGeom>
-        </p:spPr>
-      </p:pic>
-      <p:sp>
-        <p:nvSpPr>
-          <p:cNvPr id="7" name="Growth text 1"/>
-          <p:cNvSpPr txBox="1"/>
-          <p:nvPr/>
-        </p:nvSpPr>
-        <p:spPr>
-          <a:xfrm>
-            <a:off x="566928" y="3493008"/>
-            <a:ext cx="1298448" cy="685800"/>
-          </a:xfrm>
-          <a:prstGeom prst="rect">
-            <a:avLst/>
-          </a:prstGeom>
-          <a:noFill/>
-          <a:ln/>
-        </p:spPr>
-        <p:txBody>
-          <a:bodyPr wrap="square" lIns="0" tIns="0" rIns="0" bIns="0" rtlCol="0" anchor="t"/>
-          <a:lstStyle/>
-          <a:p>
-            <a:pPr indent="0" marL="0">
-              <a:buNone/>
-            </a:pPr>
-            <a:r>
-              <a:rPr lang="en-US" sz="1400" b="1" dirty="0">
-                <a:solidFill>
-                  <a:schemeClr val="tx2"/>
-                </a:solidFill>
-              </a:rPr>
-              <a:t>Food influencers</a:t>
-            </a:r>
-            <a:endParaRPr lang="en-US" sz="1400" dirty="0"/>
-          </a:p>
-        </p:txBody>
-      </p:sp>
-      <p:sp>
-        <p:nvSpPr>
-          <p:cNvPr id="8" name="Growth step 2"/>
-          <p:cNvSpPr/>
-          <p:nvPr/>
-        </p:nvSpPr>
-        <p:spPr>
-          <a:xfrm>
-            <a:off x="2139696" y="3090672"/>
-            <a:ext cx="1517904" cy="1435608"/>
+            <a:off x="3352830" y="1325880"/>
+            <a:ext cx="2438430" cy="1143000"/>
           </a:xfrm>
           <a:prstGeom prst="roundRect">
             <a:avLst>
-              <a:gd name="adj" fmla="val 6369"/>
+              <a:gd name="adj" fmla="val 9600"/>
             </a:avLst>
           </a:prstGeom>
           <a:solidFill>
-            <a:schemeClr val="accent2"/>
+            <a:schemeClr val="bg2"/>
           </a:solidFill>
           <a:ln/>
         </p:spPr>
       </p:sp>
       <p:sp>
         <p:nvSpPr>
-          <p:cNvPr id="9" name="Loyalty programs circle"/>
+          <p:cNvPr id="8" name="Equation text 2"/>
+          <p:cNvSpPr txBox="1"/>
+          <p:nvPr/>
+        </p:nvSpPr>
+        <p:spPr>
+          <a:xfrm>
+            <a:off x="3535710" y="1325880"/>
+            <a:ext cx="2072670" cy="1143000"/>
+          </a:xfrm>
+          <a:prstGeom prst="rect">
+            <a:avLst/>
+          </a:prstGeom>
+          <a:noFill/>
+          <a:ln/>
+        </p:spPr>
+        <p:txBody>
+          <a:bodyPr wrap="square" lIns="0" tIns="0" rIns="0" bIns="0" rtlCol="0" anchor="ctr"/>
+          <a:lstStyle/>
+          <a:p>
+            <a:pPr algn="ctr" indent="0" marL="0">
+              <a:buNone/>
+            </a:pPr>
+            <a:r>
+              <a:rPr lang="en-US" sz="2800" b="1" dirty="0">
+                <a:solidFill>
+                  <a:schemeClr val="tx2"/>
+                </a:solidFill>
+                <a:latin typeface="Cambria" pitchFamily="34" charset="0"/>
+                <a:ea typeface="Cambria" pitchFamily="34" charset="-122"/>
+                <a:cs typeface="Cambria" pitchFamily="34" charset="-120"/>
+              </a:rPr>
+              <a:t>100 EGP</a:t>
+            </a:r>
+            <a:endParaRPr lang="en-US" sz="2800" dirty="0"/>
+          </a:p>
+          <a:p>
+            <a:pPr algn="ctr" indent="0" marL="0">
+              <a:buNone/>
+            </a:pPr>
+            <a:r>
+              <a:rPr lang="en-US" sz="1300" dirty="0">
+                <a:solidFill>
+                  <a:schemeClr val="accent5"/>
+                </a:solidFill>
+              </a:rPr>
+              <a:t>profit per customer*</a:t>
+            </a:r>
+            <a:endParaRPr lang="en-US" sz="2800" dirty="0"/>
+          </a:p>
+        </p:txBody>
+      </p:sp>
+      <p:sp>
+        <p:nvSpPr>
+          <p:cNvPr id="9" name="Operator 2"/>
+          <p:cNvSpPr txBox="1"/>
+          <p:nvPr/>
+        </p:nvSpPr>
+        <p:spPr>
+          <a:xfrm>
+            <a:off x="5791261" y="1325880"/>
+            <a:ext cx="457200" cy="1143000"/>
+          </a:xfrm>
+          <a:prstGeom prst="rect">
+            <a:avLst/>
+          </a:prstGeom>
+          <a:noFill/>
+          <a:ln/>
+        </p:spPr>
+        <p:txBody>
+          <a:bodyPr wrap="square" lIns="0" tIns="0" rIns="0" bIns="0" rtlCol="0" anchor="ctr"/>
+          <a:lstStyle/>
+          <a:p>
+            <a:pPr algn="ctr" indent="0" marL="0">
+              <a:buNone/>
+            </a:pPr>
+            <a:r>
+              <a:rPr lang="en-US" sz="3000" b="1" dirty="0">
+                <a:solidFill>
+                  <a:schemeClr val="accent1"/>
+                </a:solidFill>
+              </a:rPr>
+              <a:t>=</a:t>
+            </a:r>
+            <a:endParaRPr lang="en-US" sz="3000" dirty="0"/>
+          </a:p>
+        </p:txBody>
+      </p:sp>
+      <p:sp>
+        <p:nvSpPr>
+          <p:cNvPr id="10" name="Equation box 3"/>
           <p:cNvSpPr/>
           <p:nvPr/>
         </p:nvSpPr>
         <p:spPr>
           <a:xfrm>
-            <a:off x="2624328" y="2432304"/>
-            <a:ext cx="548640" cy="548640"/>
-          </a:xfrm>
-          <a:prstGeom prst="ellipse">
-            <a:avLst/>
-          </a:prstGeom>
-          <a:solidFill>
-            <a:schemeClr val="accent1"/>
-          </a:solidFill>
-          <a:ln/>
-        </p:spPr>
-      </p:sp>
-      <p:pic>
-        <p:nvPicPr>
-          <p:cNvPr id="10" name="Loyalty programs icon" descr="Loyalty programs">    </p:cNvPr>
-          <p:cNvPicPr>
-            <a:picLocks noChangeAspect="1"/>
-          </p:cNvPicPr>
-          <p:nvPr/>
-        </p:nvPicPr>
-        <p:blipFill>
-          <a:blip r:embed="rId2"/>
-          <a:stretch>
-            <a:fillRect/>
-          </a:stretch>
-        </p:blipFill>
-        <p:spPr>
-          <a:xfrm>
-            <a:off x="2772461" y="2580437"/>
-            <a:ext cx="252374" cy="252374"/>
-          </a:xfrm>
-          <a:prstGeom prst="rect">
-            <a:avLst/>
-          </a:prstGeom>
-        </p:spPr>
-      </p:pic>
-      <p:sp>
-        <p:nvSpPr>
-          <p:cNvPr id="11" name="Growth text 2"/>
-          <p:cNvSpPr txBox="1"/>
-          <p:nvPr/>
-        </p:nvSpPr>
-        <p:spPr>
-          <a:xfrm>
-            <a:off x="2249424" y="3200400"/>
-            <a:ext cx="1298448" cy="685800"/>
-          </a:xfrm>
-          <a:prstGeom prst="rect">
-            <a:avLst/>
-          </a:prstGeom>
-          <a:noFill/>
-          <a:ln/>
-        </p:spPr>
-        <p:txBody>
-          <a:bodyPr wrap="square" lIns="0" tIns="0" rIns="0" bIns="0" rtlCol="0" anchor="t"/>
-          <a:lstStyle/>
-          <a:p>
-            <a:pPr indent="0" marL="0">
-              <a:buNone/>
-            </a:pPr>
-            <a:r>
-              <a:rPr lang="en-US" sz="1400" b="1" dirty="0">
-                <a:solidFill>
-                  <a:schemeClr val="tx2"/>
-                </a:solidFill>
-              </a:rPr>
-              <a:t>Loyalty programs</a:t>
-            </a:r>
-            <a:endParaRPr lang="en-US" sz="1400" dirty="0"/>
-          </a:p>
-        </p:txBody>
-      </p:sp>
-      <p:sp>
-        <p:nvSpPr>
-          <p:cNvPr id="12" name="Growth step 3"/>
-          <p:cNvSpPr/>
-          <p:nvPr/>
-        </p:nvSpPr>
-        <p:spPr>
-          <a:xfrm>
-            <a:off x="3822192" y="2798064"/>
-            <a:ext cx="1517904" cy="1728216"/>
+            <a:off x="6248461" y="1325880"/>
+            <a:ext cx="2438430" cy="1143000"/>
           </a:xfrm>
           <a:prstGeom prst="roundRect">
             <a:avLst>
-              <a:gd name="adj" fmla="val 6024"/>
+              <a:gd name="adj" fmla="val 9600"/>
+            </a:avLst>
+          </a:prstGeom>
+          <a:solidFill>
+            <a:schemeClr val="tx2"/>
+          </a:solidFill>
+          <a:ln/>
+        </p:spPr>
+      </p:sp>
+      <p:sp>
+        <p:nvSpPr>
+          <p:cNvPr id="11" name="Equation text 3"/>
+          <p:cNvSpPr txBox="1"/>
+          <p:nvPr/>
+        </p:nvSpPr>
+        <p:spPr>
+          <a:xfrm>
+            <a:off x="6431341" y="1325880"/>
+            <a:ext cx="2072670" cy="1143000"/>
+          </a:xfrm>
+          <a:prstGeom prst="rect">
+            <a:avLst/>
+          </a:prstGeom>
+          <a:noFill/>
+          <a:ln/>
+        </p:spPr>
+        <p:txBody>
+          <a:bodyPr wrap="square" lIns="0" tIns="0" rIns="0" bIns="0" rtlCol="0" anchor="ctr"/>
+          <a:lstStyle/>
+          <a:p>
+            <a:pPr algn="ctr" indent="0" marL="0">
+              <a:buNone/>
+            </a:pPr>
+            <a:r>
+              <a:rPr lang="en-US" sz="2800" b="1" dirty="0">
+                <a:solidFill>
+                  <a:schemeClr val="bg1"/>
+                </a:solidFill>
+                <a:latin typeface="Cambria" pitchFamily="34" charset="0"/>
+                <a:ea typeface="Cambria" pitchFamily="34" charset="-122"/>
+                <a:cs typeface="Cambria" pitchFamily="34" charset="-120"/>
+              </a:rPr>
+              <a:t>130</a:t>
+            </a:r>
+            <a:endParaRPr lang="en-US" sz="2800" dirty="0"/>
+          </a:p>
+          <a:p>
+            <a:pPr algn="ctr" indent="0" marL="0">
+              <a:buNone/>
+            </a:pPr>
+            <a:r>
+              <a:rPr lang="en-US" sz="1300" dirty="0">
+                <a:solidFill>
+                  <a:schemeClr val="accent2"/>
+                </a:solidFill>
+              </a:rPr>
+              <a:t>customers a month</a:t>
+            </a:r>
+            <a:endParaRPr lang="en-US" sz="2800" dirty="0"/>
+          </a:p>
+        </p:txBody>
+      </p:sp>
+      <p:sp>
+        <p:nvSpPr>
+          <p:cNvPr id="12" name="Break-even callout"/>
+          <p:cNvSpPr/>
+          <p:nvPr/>
+        </p:nvSpPr>
+        <p:spPr>
+          <a:xfrm>
+            <a:off x="457200" y="2697480"/>
+            <a:ext cx="3840480" cy="1600200"/>
+          </a:xfrm>
+          <a:prstGeom prst="roundRect">
+            <a:avLst>
+              <a:gd name="adj" fmla="val 6857"/>
             </a:avLst>
           </a:prstGeom>
           <a:solidFill>
@@ -3013,285 +3579,106 @@
       </p:sp>
       <p:sp>
         <p:nvSpPr>
-          <p:cNvPr id="13" name="Seasonal offers circle"/>
-          <p:cNvSpPr/>
-          <p:nvPr/>
-        </p:nvSpPr>
-        <p:spPr>
-          <a:xfrm>
-            <a:off x="4306824" y="2139696"/>
-            <a:ext cx="548640" cy="548640"/>
-          </a:xfrm>
-          <a:prstGeom prst="ellipse">
-            <a:avLst/>
-          </a:prstGeom>
-          <a:solidFill>
-            <a:schemeClr val="accent1"/>
-          </a:solidFill>
-          <a:ln/>
-        </p:spPr>
-      </p:sp>
-      <p:pic>
-        <p:nvPicPr>
-          <p:cNvPr id="14" name="Seasonal offers icon" descr="Seasonal offers">    </p:cNvPr>
-          <p:cNvPicPr>
-            <a:picLocks noChangeAspect="1"/>
-          </p:cNvPicPr>
-          <p:nvPr/>
-        </p:nvPicPr>
-        <p:blipFill>
-          <a:blip r:embed="rId3"/>
-          <a:stretch>
-            <a:fillRect/>
-          </a:stretch>
-        </p:blipFill>
-        <p:spPr>
-          <a:xfrm>
-            <a:off x="4454957" y="2287829"/>
-            <a:ext cx="252374" cy="252374"/>
-          </a:xfrm>
-          <a:prstGeom prst="rect">
-            <a:avLst/>
-          </a:prstGeom>
-        </p:spPr>
-      </p:pic>
-      <p:sp>
-        <p:nvSpPr>
-          <p:cNvPr id="15" name="Growth text 3"/>
+          <p:cNvPr id="13" name="Break-even text"/>
           <p:cNvSpPr txBox="1"/>
           <p:nvPr/>
         </p:nvSpPr>
         <p:spPr>
           <a:xfrm>
-            <a:off x="3931920" y="2907792"/>
-            <a:ext cx="1298448" cy="685800"/>
-          </a:xfrm>
-          <a:prstGeom prst="rect">
-            <a:avLst/>
-          </a:prstGeom>
-          <a:noFill/>
-          <a:ln/>
-        </p:spPr>
-        <p:txBody>
-          <a:bodyPr wrap="square" lIns="0" tIns="0" rIns="0" bIns="0" rtlCol="0" anchor="t"/>
+            <a:off x="685800" y="2697480"/>
+            <a:ext cx="3429000" cy="1600200"/>
+          </a:xfrm>
+          <a:prstGeom prst="rect">
+            <a:avLst/>
+          </a:prstGeom>
+          <a:noFill/>
+          <a:ln/>
+        </p:spPr>
+        <p:txBody>
+          <a:bodyPr wrap="square" lIns="0" tIns="0" rIns="0" bIns="0" rtlCol="0" anchor="ctr"/>
           <a:lstStyle/>
           <a:p>
             <a:pPr indent="0" marL="0">
               <a:buNone/>
             </a:pPr>
             <a:r>
-              <a:rPr lang="en-US" sz="1400" b="1" dirty="0">
+              <a:rPr lang="en-US" sz="3200" b="1" dirty="0">
                 <a:solidFill>
                   <a:schemeClr val="bg1"/>
                 </a:solidFill>
-              </a:rPr>
-              <a:t>Seasonal offers</a:t>
-            </a:r>
-            <a:endParaRPr lang="en-US" sz="1400" dirty="0"/>
-          </a:p>
-        </p:txBody>
-      </p:sp>
-      <p:sp>
-        <p:nvSpPr>
-          <p:cNvPr id="16" name="Growth step 4"/>
-          <p:cNvSpPr/>
-          <p:nvPr/>
-        </p:nvSpPr>
-        <p:spPr>
-          <a:xfrm>
-            <a:off x="5504688" y="2505456"/>
-            <a:ext cx="1517904" cy="2020824"/>
-          </a:xfrm>
-          <a:prstGeom prst="roundRect">
-            <a:avLst>
-              <a:gd name="adj" fmla="val 6024"/>
-            </a:avLst>
-          </a:prstGeom>
-          <a:solidFill>
-            <a:schemeClr val="accent3"/>
-          </a:solidFill>
-          <a:ln/>
-        </p:spPr>
-      </p:sp>
-      <p:sp>
-        <p:nvSpPr>
-          <p:cNvPr id="17" name="Expand the best ads circle"/>
-          <p:cNvSpPr/>
-          <p:nvPr/>
-        </p:nvSpPr>
-        <p:spPr>
-          <a:xfrm>
-            <a:off x="5989320" y="1847088"/>
-            <a:ext cx="548640" cy="548640"/>
-          </a:xfrm>
-          <a:prstGeom prst="ellipse">
-            <a:avLst/>
-          </a:prstGeom>
-          <a:solidFill>
-            <a:schemeClr val="accent1"/>
-          </a:solidFill>
-          <a:ln/>
-        </p:spPr>
-      </p:sp>
-      <p:pic>
-        <p:nvPicPr>
-          <p:cNvPr id="18" name="Expand the best ads icon" descr="Expand the best ads">    </p:cNvPr>
-          <p:cNvPicPr>
-            <a:picLocks noChangeAspect="1"/>
-          </p:cNvPicPr>
-          <p:nvPr/>
-        </p:nvPicPr>
-        <p:blipFill>
-          <a:blip r:embed="rId4"/>
-          <a:stretch>
-            <a:fillRect/>
-          </a:stretch>
-        </p:blipFill>
-        <p:spPr>
-          <a:xfrm>
-            <a:off x="6137453" y="1995221"/>
-            <a:ext cx="252374" cy="252374"/>
-          </a:xfrm>
-          <a:prstGeom prst="rect">
-            <a:avLst/>
-          </a:prstGeom>
-        </p:spPr>
-      </p:pic>
-      <p:sp>
-        <p:nvSpPr>
-          <p:cNvPr id="19" name="Growth text 4"/>
+                <a:latin typeface="Cambria" pitchFamily="34" charset="0"/>
+                <a:ea typeface="Cambria" pitchFamily="34" charset="-122"/>
+                <a:cs typeface="Cambria" pitchFamily="34" charset="-120"/>
+              </a:rPr>
+              <a:t>Less than 5</a:t>
+            </a:r>
+            <a:endParaRPr lang="en-US" sz="3200" dirty="0"/>
+          </a:p>
+          <a:p>
+            <a:pPr indent="0" marL="0">
+              <a:buNone/>
+            </a:pPr>
+            <a:r>
+              <a:rPr lang="en-US" sz="1500" dirty="0">
+                <a:solidFill>
+                  <a:schemeClr val="bg1"/>
+                </a:solidFill>
+              </a:rPr>
+              <a:t>extra customers a day covers the full cost. Our target is 10.</a:t>
+            </a:r>
+            <a:endParaRPr lang="en-US" sz="3200" dirty="0"/>
+          </a:p>
+        </p:txBody>
+      </p:sp>
+      <p:graphicFrame>
+        <p:nvGraphicFramePr>
+          <p:cNvPr id="14" name="Investment vs gain chart" descr=""/>
+          <p:cNvGraphicFramePr/>
+          <p:nvPr/>
+        </p:nvGraphicFramePr>
+        <p:xfrm>
+          <a:off x="4526280" y="2606040"/>
+          <a:ext cx="4160520" cy="1783080"/>
+        </p:xfrm>
+        <a:graphic xmlns:a="http://schemas.openxmlformats.org/drawingml/2006/main">
+          <a:graphicData uri="http://schemas.openxmlformats.org/drawingml/2006/chart">
+            <c:chart xmlns:c="http://schemas.openxmlformats.org/drawingml/2006/chart" r:id="rId1"/>
+          </a:graphicData>
+        </a:graphic>
+      </p:graphicFrame>
+      <p:sp>
+        <p:nvSpPr>
+          <p:cNvPr id="15" name="ROI footnote"/>
           <p:cNvSpPr txBox="1"/>
           <p:nvPr/>
         </p:nvSpPr>
         <p:spPr>
           <a:xfrm>
-            <a:off x="5614416" y="2615184"/>
-            <a:ext cx="1298448" cy="685800"/>
-          </a:xfrm>
-          <a:prstGeom prst="rect">
-            <a:avLst/>
-          </a:prstGeom>
-          <a:noFill/>
-          <a:ln/>
-        </p:spPr>
-        <p:txBody>
-          <a:bodyPr wrap="square" lIns="0" tIns="0" rIns="0" bIns="0" rtlCol="0" anchor="t"/>
+            <a:off x="457200" y="4389120"/>
+            <a:ext cx="8229600" cy="274320"/>
+          </a:xfrm>
+          <a:prstGeom prst="rect">
+            <a:avLst/>
+          </a:prstGeom>
+          <a:noFill/>
+          <a:ln/>
+        </p:spPr>
+        <p:txBody>
+          <a:bodyPr wrap="square" lIns="0" tIns="0" rIns="0" bIns="0" rtlCol="0" anchor="ctr"/>
           <a:lstStyle/>
           <a:p>
             <a:pPr indent="0" marL="0">
               <a:buNone/>
             </a:pPr>
             <a:r>
-              <a:rPr lang="en-US" sz="1400" b="1" dirty="0">
-                <a:solidFill>
-                  <a:schemeClr val="bg1"/>
-                </a:solidFill>
-              </a:rPr>
-              <a:t>Expand the best ads</a:t>
-            </a:r>
-            <a:endParaRPr lang="en-US" sz="1400" dirty="0"/>
-          </a:p>
-        </p:txBody>
-      </p:sp>
-      <p:sp>
-        <p:nvSpPr>
-          <p:cNvPr id="20" name="Growth step 5"/>
-          <p:cNvSpPr/>
-          <p:nvPr/>
-        </p:nvSpPr>
-        <p:spPr>
-          <a:xfrm>
-            <a:off x="7187184" y="2212848"/>
-            <a:ext cx="1517904" cy="2313432"/>
-          </a:xfrm>
-          <a:prstGeom prst="roundRect">
-            <a:avLst>
-              <a:gd name="adj" fmla="val 6024"/>
-            </a:avLst>
-          </a:prstGeom>
-          <a:solidFill>
-            <a:schemeClr val="tx2"/>
-          </a:solidFill>
-          <a:ln/>
-        </p:spPr>
-      </p:sp>
-      <p:sp>
-        <p:nvSpPr>
-          <p:cNvPr id="21" name="Long-term strategy circle"/>
-          <p:cNvSpPr/>
-          <p:nvPr/>
-        </p:nvSpPr>
-        <p:spPr>
-          <a:xfrm>
-            <a:off x="7671816" y="1554480"/>
-            <a:ext cx="548640" cy="548640"/>
-          </a:xfrm>
-          <a:prstGeom prst="ellipse">
-            <a:avLst/>
-          </a:prstGeom>
-          <a:solidFill>
-            <a:schemeClr val="accent1"/>
-          </a:solidFill>
-          <a:ln/>
-        </p:spPr>
-      </p:sp>
-      <p:pic>
-        <p:nvPicPr>
-          <p:cNvPr id="22" name="Long-term strategy icon" descr="Long-term strategy">    </p:cNvPr>
-          <p:cNvPicPr>
-            <a:picLocks noChangeAspect="1"/>
-          </p:cNvPicPr>
-          <p:nvPr/>
-        </p:nvPicPr>
-        <p:blipFill>
-          <a:blip r:embed="rId5"/>
-          <a:stretch>
-            <a:fillRect/>
-          </a:stretch>
-        </p:blipFill>
-        <p:spPr>
-          <a:xfrm>
-            <a:off x="7819949" y="1702613"/>
-            <a:ext cx="252374" cy="252374"/>
-          </a:xfrm>
-          <a:prstGeom prst="rect">
-            <a:avLst/>
-          </a:prstGeom>
-        </p:spPr>
-      </p:pic>
-      <p:sp>
-        <p:nvSpPr>
-          <p:cNvPr id="23" name="Growth text 5"/>
-          <p:cNvSpPr txBox="1"/>
-          <p:nvPr/>
-        </p:nvSpPr>
-        <p:spPr>
-          <a:xfrm>
-            <a:off x="7296912" y="2322576"/>
-            <a:ext cx="1298448" cy="685800"/>
-          </a:xfrm>
-          <a:prstGeom prst="rect">
-            <a:avLst/>
-          </a:prstGeom>
-          <a:noFill/>
-          <a:ln/>
-        </p:spPr>
-        <p:txBody>
-          <a:bodyPr wrap="square" lIns="0" tIns="0" rIns="0" bIns="0" rtlCol="0" anchor="t"/>
-          <a:lstStyle/>
-          <a:p>
-            <a:pPr indent="0" marL="0">
-              <a:buNone/>
-            </a:pPr>
-            <a:r>
-              <a:rPr lang="en-US" sz="1400" b="1" dirty="0">
-                <a:solidFill>
-                  <a:schemeClr val="bg1"/>
-                </a:solidFill>
-              </a:rPr>
-              <a:t>Long-term strategy</a:t>
-            </a:r>
-            <a:endParaRPr lang="en-US" sz="1400" dirty="0"/>
+              <a:rPr lang="en-US" sz="1000" dirty="0">
+                <a:solidFill>
+                  <a:schemeClr val="accent5"/>
+                </a:solidFill>
+              </a:rPr>
+              <a:t>*Assumes an average bill of 150 EGP and about 65% margin after ingredients. At target: 10 customers × 30 days × 100 EGP = 30,000 EGP.</a:t>
+            </a:r>
+            <a:endParaRPr lang="en-US" sz="1000" dirty="0"/>
           </a:p>
         </p:txBody>
       </p:sp>
@@ -3375,8 +3762,8 @@
         </p:nvSpPr>
         <p:spPr>
           <a:xfrm>
-            <a:off x="548640" y="914400"/>
-            <a:ext cx="4389120" cy="320040"/>
+            <a:off x="457200" y="274320"/>
+            <a:ext cx="8229600" cy="274320"/>
           </a:xfrm>
           <a:prstGeom prst="rect">
             <a:avLst/>
@@ -3392,14 +3779,14 @@
               <a:buNone/>
             </a:pPr>
             <a:r>
-              <a:rPr lang="en-US" sz="1200" b="1" spc="300" kern="0" dirty="0">
-                <a:solidFill>
-                  <a:schemeClr val="accent2"/>
-                </a:solidFill>
-              </a:rPr>
-              <a:t>10  CONCLUSION</a:t>
-            </a:r>
-            <a:endParaRPr lang="en-US" sz="1200" dirty="0"/>
+              <a:rPr lang="en-US" sz="1100" b="1" spc="200" kern="0" dirty="0">
+                <a:solidFill>
+                  <a:schemeClr val="accent1"/>
+                </a:solidFill>
+              </a:rPr>
+              <a:t>10  FUTURE WORK</a:t>
+            </a:r>
+            <a:endParaRPr lang="en-US" sz="1100" dirty="0"/>
           </a:p>
         </p:txBody>
       </p:sp>
@@ -3413,6 +3800,1642 @@
         </p:nvSpPr>
         <p:spPr>
           <a:xfrm>
+            <a:off x="457200" y="530352"/>
+            <a:ext cx="8229600" cy="640080"/>
+          </a:xfrm>
+          <a:prstGeom prst="rect">
+            <a:avLst/>
+          </a:prstGeom>
+          <a:noFill/>
+          <a:ln/>
+        </p:spPr>
+        <p:txBody>
+          <a:bodyPr wrap="square" lIns="0" tIns="0" rIns="0" bIns="0" rtlCol="0" anchor="t"/>
+          <a:lstStyle/>
+          <a:p>
+            <a:pPr algn="l" indent="0" marL="0">
+              <a:buNone/>
+            </a:pPr>
+            <a:r>
+              <a:rPr lang="en-US" sz="3200" b="1" dirty="0">
+                <a:solidFill>
+                  <a:schemeClr val="tx2"/>
+                </a:solidFill>
+                <a:latin typeface="Cambria" pitchFamily="34" charset="0"/>
+                <a:ea typeface="Cambria" pitchFamily="34" charset="-122"/>
+                <a:cs typeface="Cambria" pitchFamily="34" charset="-120"/>
+              </a:rPr>
+              <a:t>After the First Month</a:t>
+            </a:r>
+            <a:endParaRPr lang="en-US" sz="3200" dirty="0"/>
+          </a:p>
+        </p:txBody>
+      </p:sp>
+      <p:sp>
+        <p:nvSpPr>
+          <p:cNvPr id="4" name="Growth step 1"/>
+          <p:cNvSpPr/>
+          <p:nvPr/>
+        </p:nvSpPr>
+        <p:spPr>
+          <a:xfrm>
+            <a:off x="457200" y="3383280"/>
+            <a:ext cx="1517904" cy="1143000"/>
+          </a:xfrm>
+          <a:prstGeom prst="roundRect">
+            <a:avLst>
+              <a:gd name="adj" fmla="val 8000"/>
+            </a:avLst>
+          </a:prstGeom>
+          <a:solidFill>
+            <a:schemeClr val="bg2"/>
+          </a:solidFill>
+          <a:ln/>
+        </p:spPr>
+      </p:sp>
+      <p:sp>
+        <p:nvSpPr>
+          <p:cNvPr id="5" name="Food influencers circle"/>
+          <p:cNvSpPr/>
+          <p:nvPr/>
+        </p:nvSpPr>
+        <p:spPr>
+          <a:xfrm>
+            <a:off x="941832" y="2724912"/>
+            <a:ext cx="548640" cy="548640"/>
+          </a:xfrm>
+          <a:prstGeom prst="ellipse">
+            <a:avLst/>
+          </a:prstGeom>
+          <a:solidFill>
+            <a:schemeClr val="accent1"/>
+          </a:solidFill>
+          <a:ln/>
+        </p:spPr>
+      </p:sp>
+      <p:pic>
+        <p:nvPicPr>
+          <p:cNvPr id="6" name="Food influencers icon" descr="Food influencers">    </p:cNvPr>
+          <p:cNvPicPr>
+            <a:picLocks noChangeAspect="1"/>
+          </p:cNvPicPr>
+          <p:nvPr/>
+        </p:nvPicPr>
+        <p:blipFill>
+          <a:blip r:embed="rId1"/>
+          <a:stretch>
+            <a:fillRect/>
+          </a:stretch>
+        </p:blipFill>
+        <p:spPr>
+          <a:xfrm>
+            <a:off x="1089965" y="2873045"/>
+            <a:ext cx="252374" cy="252374"/>
+          </a:xfrm>
+          <a:prstGeom prst="rect">
+            <a:avLst/>
+          </a:prstGeom>
+        </p:spPr>
+      </p:pic>
+      <p:sp>
+        <p:nvSpPr>
+          <p:cNvPr id="7" name="Growth text 1"/>
+          <p:cNvSpPr txBox="1"/>
+          <p:nvPr/>
+        </p:nvSpPr>
+        <p:spPr>
+          <a:xfrm>
+            <a:off x="566928" y="3493008"/>
+            <a:ext cx="1298448" cy="685800"/>
+          </a:xfrm>
+          <a:prstGeom prst="rect">
+            <a:avLst/>
+          </a:prstGeom>
+          <a:noFill/>
+          <a:ln/>
+        </p:spPr>
+        <p:txBody>
+          <a:bodyPr wrap="square" lIns="0" tIns="0" rIns="0" bIns="0" rtlCol="0" anchor="t"/>
+          <a:lstStyle/>
+          <a:p>
+            <a:pPr indent="0" marL="0">
+              <a:buNone/>
+            </a:pPr>
+            <a:r>
+              <a:rPr lang="en-US" sz="1400" b="1" dirty="0">
+                <a:solidFill>
+                  <a:schemeClr val="tx2"/>
+                </a:solidFill>
+              </a:rPr>
+              <a:t>Food influencers</a:t>
+            </a:r>
+            <a:endParaRPr lang="en-US" sz="1400" dirty="0"/>
+          </a:p>
+        </p:txBody>
+      </p:sp>
+      <p:sp>
+        <p:nvSpPr>
+          <p:cNvPr id="8" name="Growth step 2"/>
+          <p:cNvSpPr/>
+          <p:nvPr/>
+        </p:nvSpPr>
+        <p:spPr>
+          <a:xfrm>
+            <a:off x="2139696" y="3090672"/>
+            <a:ext cx="1517904" cy="1435608"/>
+          </a:xfrm>
+          <a:prstGeom prst="roundRect">
+            <a:avLst>
+              <a:gd name="adj" fmla="val 6369"/>
+            </a:avLst>
+          </a:prstGeom>
+          <a:solidFill>
+            <a:schemeClr val="accent2"/>
+          </a:solidFill>
+          <a:ln/>
+        </p:spPr>
+      </p:sp>
+      <p:sp>
+        <p:nvSpPr>
+          <p:cNvPr id="9" name="Loyalty programs circle"/>
+          <p:cNvSpPr/>
+          <p:nvPr/>
+        </p:nvSpPr>
+        <p:spPr>
+          <a:xfrm>
+            <a:off x="2624328" y="2432304"/>
+            <a:ext cx="548640" cy="548640"/>
+          </a:xfrm>
+          <a:prstGeom prst="ellipse">
+            <a:avLst/>
+          </a:prstGeom>
+          <a:solidFill>
+            <a:schemeClr val="accent1"/>
+          </a:solidFill>
+          <a:ln/>
+        </p:spPr>
+      </p:sp>
+      <p:pic>
+        <p:nvPicPr>
+          <p:cNvPr id="10" name="Loyalty programs icon" descr="Loyalty programs">    </p:cNvPr>
+          <p:cNvPicPr>
+            <a:picLocks noChangeAspect="1"/>
+          </p:cNvPicPr>
+          <p:nvPr/>
+        </p:nvPicPr>
+        <p:blipFill>
+          <a:blip r:embed="rId2"/>
+          <a:stretch>
+            <a:fillRect/>
+          </a:stretch>
+        </p:blipFill>
+        <p:spPr>
+          <a:xfrm>
+            <a:off x="2772461" y="2580437"/>
+            <a:ext cx="252374" cy="252374"/>
+          </a:xfrm>
+          <a:prstGeom prst="rect">
+            <a:avLst/>
+          </a:prstGeom>
+        </p:spPr>
+      </p:pic>
+      <p:sp>
+        <p:nvSpPr>
+          <p:cNvPr id="11" name="Growth text 2"/>
+          <p:cNvSpPr txBox="1"/>
+          <p:nvPr/>
+        </p:nvSpPr>
+        <p:spPr>
+          <a:xfrm>
+            <a:off x="2249424" y="3200400"/>
+            <a:ext cx="1298448" cy="685800"/>
+          </a:xfrm>
+          <a:prstGeom prst="rect">
+            <a:avLst/>
+          </a:prstGeom>
+          <a:noFill/>
+          <a:ln/>
+        </p:spPr>
+        <p:txBody>
+          <a:bodyPr wrap="square" lIns="0" tIns="0" rIns="0" bIns="0" rtlCol="0" anchor="t"/>
+          <a:lstStyle/>
+          <a:p>
+            <a:pPr indent="0" marL="0">
+              <a:buNone/>
+            </a:pPr>
+            <a:r>
+              <a:rPr lang="en-US" sz="1400" b="1" dirty="0">
+                <a:solidFill>
+                  <a:schemeClr val="tx2"/>
+                </a:solidFill>
+              </a:rPr>
+              <a:t>Loyalty programs</a:t>
+            </a:r>
+            <a:endParaRPr lang="en-US" sz="1400" dirty="0"/>
+          </a:p>
+        </p:txBody>
+      </p:sp>
+      <p:sp>
+        <p:nvSpPr>
+          <p:cNvPr id="12" name="Growth step 3"/>
+          <p:cNvSpPr/>
+          <p:nvPr/>
+        </p:nvSpPr>
+        <p:spPr>
+          <a:xfrm>
+            <a:off x="3822192" y="2798064"/>
+            <a:ext cx="1517904" cy="1728216"/>
+          </a:xfrm>
+          <a:prstGeom prst="roundRect">
+            <a:avLst>
+              <a:gd name="adj" fmla="val 6024"/>
+            </a:avLst>
+          </a:prstGeom>
+          <a:solidFill>
+            <a:schemeClr val="accent4"/>
+          </a:solidFill>
+          <a:ln/>
+        </p:spPr>
+      </p:sp>
+      <p:sp>
+        <p:nvSpPr>
+          <p:cNvPr id="13" name="Seasonal offers circle"/>
+          <p:cNvSpPr/>
+          <p:nvPr/>
+        </p:nvSpPr>
+        <p:spPr>
+          <a:xfrm>
+            <a:off x="4306824" y="2139696"/>
+            <a:ext cx="548640" cy="548640"/>
+          </a:xfrm>
+          <a:prstGeom prst="ellipse">
+            <a:avLst/>
+          </a:prstGeom>
+          <a:solidFill>
+            <a:schemeClr val="accent1"/>
+          </a:solidFill>
+          <a:ln/>
+        </p:spPr>
+      </p:sp>
+      <p:pic>
+        <p:nvPicPr>
+          <p:cNvPr id="14" name="Seasonal offers icon" descr="Seasonal offers">    </p:cNvPr>
+          <p:cNvPicPr>
+            <a:picLocks noChangeAspect="1"/>
+          </p:cNvPicPr>
+          <p:nvPr/>
+        </p:nvPicPr>
+        <p:blipFill>
+          <a:blip r:embed="rId3"/>
+          <a:stretch>
+            <a:fillRect/>
+          </a:stretch>
+        </p:blipFill>
+        <p:spPr>
+          <a:xfrm>
+            <a:off x="4454957" y="2287829"/>
+            <a:ext cx="252374" cy="252374"/>
+          </a:xfrm>
+          <a:prstGeom prst="rect">
+            <a:avLst/>
+          </a:prstGeom>
+        </p:spPr>
+      </p:pic>
+      <p:sp>
+        <p:nvSpPr>
+          <p:cNvPr id="15" name="Growth text 3"/>
+          <p:cNvSpPr txBox="1"/>
+          <p:nvPr/>
+        </p:nvSpPr>
+        <p:spPr>
+          <a:xfrm>
+            <a:off x="3931920" y="2907792"/>
+            <a:ext cx="1298448" cy="685800"/>
+          </a:xfrm>
+          <a:prstGeom prst="rect">
+            <a:avLst/>
+          </a:prstGeom>
+          <a:noFill/>
+          <a:ln/>
+        </p:spPr>
+        <p:txBody>
+          <a:bodyPr wrap="square" lIns="0" tIns="0" rIns="0" bIns="0" rtlCol="0" anchor="t"/>
+          <a:lstStyle/>
+          <a:p>
+            <a:pPr indent="0" marL="0">
+              <a:buNone/>
+            </a:pPr>
+            <a:r>
+              <a:rPr lang="en-US" sz="1400" b="1" dirty="0">
+                <a:solidFill>
+                  <a:schemeClr val="bg1"/>
+                </a:solidFill>
+              </a:rPr>
+              <a:t>Seasonal offers</a:t>
+            </a:r>
+            <a:endParaRPr lang="en-US" sz="1400" dirty="0"/>
+          </a:p>
+        </p:txBody>
+      </p:sp>
+      <p:sp>
+        <p:nvSpPr>
+          <p:cNvPr id="16" name="Growth step 4"/>
+          <p:cNvSpPr/>
+          <p:nvPr/>
+        </p:nvSpPr>
+        <p:spPr>
+          <a:xfrm>
+            <a:off x="5504688" y="2505456"/>
+            <a:ext cx="1517904" cy="2020824"/>
+          </a:xfrm>
+          <a:prstGeom prst="roundRect">
+            <a:avLst>
+              <a:gd name="adj" fmla="val 6024"/>
+            </a:avLst>
+          </a:prstGeom>
+          <a:solidFill>
+            <a:schemeClr val="accent3"/>
+          </a:solidFill>
+          <a:ln/>
+        </p:spPr>
+      </p:sp>
+      <p:sp>
+        <p:nvSpPr>
+          <p:cNvPr id="17" name="Expand the best ads circle"/>
+          <p:cNvSpPr/>
+          <p:nvPr/>
+        </p:nvSpPr>
+        <p:spPr>
+          <a:xfrm>
+            <a:off x="5989320" y="1847088"/>
+            <a:ext cx="548640" cy="548640"/>
+          </a:xfrm>
+          <a:prstGeom prst="ellipse">
+            <a:avLst/>
+          </a:prstGeom>
+          <a:solidFill>
+            <a:schemeClr val="accent1"/>
+          </a:solidFill>
+          <a:ln/>
+        </p:spPr>
+      </p:sp>
+      <p:pic>
+        <p:nvPicPr>
+          <p:cNvPr id="18" name="Expand the best ads icon" descr="Expand the best ads">    </p:cNvPr>
+          <p:cNvPicPr>
+            <a:picLocks noChangeAspect="1"/>
+          </p:cNvPicPr>
+          <p:nvPr/>
+        </p:nvPicPr>
+        <p:blipFill>
+          <a:blip r:embed="rId4"/>
+          <a:stretch>
+            <a:fillRect/>
+          </a:stretch>
+        </p:blipFill>
+        <p:spPr>
+          <a:xfrm>
+            <a:off x="6137453" y="1995221"/>
+            <a:ext cx="252374" cy="252374"/>
+          </a:xfrm>
+          <a:prstGeom prst="rect">
+            <a:avLst/>
+          </a:prstGeom>
+        </p:spPr>
+      </p:pic>
+      <p:sp>
+        <p:nvSpPr>
+          <p:cNvPr id="19" name="Growth text 4"/>
+          <p:cNvSpPr txBox="1"/>
+          <p:nvPr/>
+        </p:nvSpPr>
+        <p:spPr>
+          <a:xfrm>
+            <a:off x="5614416" y="2615184"/>
+            <a:ext cx="1298448" cy="685800"/>
+          </a:xfrm>
+          <a:prstGeom prst="rect">
+            <a:avLst/>
+          </a:prstGeom>
+          <a:noFill/>
+          <a:ln/>
+        </p:spPr>
+        <p:txBody>
+          <a:bodyPr wrap="square" lIns="0" tIns="0" rIns="0" bIns="0" rtlCol="0" anchor="t"/>
+          <a:lstStyle/>
+          <a:p>
+            <a:pPr indent="0" marL="0">
+              <a:buNone/>
+            </a:pPr>
+            <a:r>
+              <a:rPr lang="en-US" sz="1400" b="1" dirty="0">
+                <a:solidFill>
+                  <a:schemeClr val="bg1"/>
+                </a:solidFill>
+              </a:rPr>
+              <a:t>Expand the best ads</a:t>
+            </a:r>
+            <a:endParaRPr lang="en-US" sz="1400" dirty="0"/>
+          </a:p>
+        </p:txBody>
+      </p:sp>
+      <p:sp>
+        <p:nvSpPr>
+          <p:cNvPr id="20" name="Growth step 5"/>
+          <p:cNvSpPr/>
+          <p:nvPr/>
+        </p:nvSpPr>
+        <p:spPr>
+          <a:xfrm>
+            <a:off x="7187184" y="2212848"/>
+            <a:ext cx="1517904" cy="2313432"/>
+          </a:xfrm>
+          <a:prstGeom prst="roundRect">
+            <a:avLst>
+              <a:gd name="adj" fmla="val 6024"/>
+            </a:avLst>
+          </a:prstGeom>
+          <a:solidFill>
+            <a:schemeClr val="tx2"/>
+          </a:solidFill>
+          <a:ln/>
+        </p:spPr>
+      </p:sp>
+      <p:sp>
+        <p:nvSpPr>
+          <p:cNvPr id="21" name="Long-term strategy circle"/>
+          <p:cNvSpPr/>
+          <p:nvPr/>
+        </p:nvSpPr>
+        <p:spPr>
+          <a:xfrm>
+            <a:off x="7671816" y="1554480"/>
+            <a:ext cx="548640" cy="548640"/>
+          </a:xfrm>
+          <a:prstGeom prst="ellipse">
+            <a:avLst/>
+          </a:prstGeom>
+          <a:solidFill>
+            <a:schemeClr val="accent1"/>
+          </a:solidFill>
+          <a:ln/>
+        </p:spPr>
+      </p:sp>
+      <p:pic>
+        <p:nvPicPr>
+          <p:cNvPr id="22" name="Long-term strategy icon" descr="Long-term strategy">    </p:cNvPr>
+          <p:cNvPicPr>
+            <a:picLocks noChangeAspect="1"/>
+          </p:cNvPicPr>
+          <p:nvPr/>
+        </p:nvPicPr>
+        <p:blipFill>
+          <a:blip r:embed="rId5"/>
+          <a:stretch>
+            <a:fillRect/>
+          </a:stretch>
+        </p:blipFill>
+        <p:spPr>
+          <a:xfrm>
+            <a:off x="7819949" y="1702613"/>
+            <a:ext cx="252374" cy="252374"/>
+          </a:xfrm>
+          <a:prstGeom prst="rect">
+            <a:avLst/>
+          </a:prstGeom>
+        </p:spPr>
+      </p:pic>
+      <p:sp>
+        <p:nvSpPr>
+          <p:cNvPr id="23" name="Growth text 5"/>
+          <p:cNvSpPr txBox="1"/>
+          <p:nvPr/>
+        </p:nvSpPr>
+        <p:spPr>
+          <a:xfrm>
+            <a:off x="7296912" y="2322576"/>
+            <a:ext cx="1298448" cy="685800"/>
+          </a:xfrm>
+          <a:prstGeom prst="rect">
+            <a:avLst/>
+          </a:prstGeom>
+          <a:noFill/>
+          <a:ln/>
+        </p:spPr>
+        <p:txBody>
+          <a:bodyPr wrap="square" lIns="0" tIns="0" rIns="0" bIns="0" rtlCol="0" anchor="t"/>
+          <a:lstStyle/>
+          <a:p>
+            <a:pPr indent="0" marL="0">
+              <a:buNone/>
+            </a:pPr>
+            <a:r>
+              <a:rPr lang="en-US" sz="1400" b="1" dirty="0">
+                <a:solidFill>
+                  <a:schemeClr val="bg1"/>
+                </a:solidFill>
+              </a:rPr>
+              <a:t>Long-term strategy</a:t>
+            </a:r>
+            <a:endParaRPr lang="en-US" sz="1400" dirty="0"/>
+          </a:p>
+        </p:txBody>
+      </p:sp>
+      <p:sp>
+        <p:nvSpPr>
+          <p:cNvPr id="25" name="Slide Number Placeholder 0"/>
+          <p:cNvSpPr>
+            <a:spLocks noGrp="1"/>
+          </p:cNvSpPr>
+          <p:nvPr>
+            <p:ph type="sldNum" sz="quarter" idx="4294967295"/>
+          </p:nvPr>
+        </p:nvSpPr>
+        <p:spPr>
+          <a:xfrm>
+            <a:off x="8229600" y="4800600"/>
+            <a:ext cx="457200" cy="228600"/>
+          </a:xfrm>
+          <a:prstGeom prst="rect">
+            <a:avLst/>
+          </a:prstGeom>
+          <a:extLst>
+            <a:ext uri="{C572A759-6A51-4108-AA02-DFA0A04FC94B}">
+              <ma14:wrappingTextBoxFlag xmlns:ma14="http://schemas.microsoft.com/office/mac/drawingml/2011/main" val="0"/>
+            </a:ext>
+          </a:extLst>
+        </p:spPr>
+        <p:txBody>
+          <a:bodyPr lIns="0" tIns="0" rIns="0" bIns="0" anchor="ctr"/>
+          <a:lstStyle>
+            <a:lvl1pPr>
+              <a:defRPr sz="1000">
+                <a:solidFill>
+                  <a:schemeClr val="accent5"/>
+                </a:solidFill>
+              </a:defRPr>
+            </a:lvl1pPr>
+          </a:lstStyle>
+          <a:p>
+            <a:pPr algn="r"/>
+            <a:fld id="{F7021451-1387-4CA6-816F-3879F97B5CBC}" type="slidenum">
+              <a:rPr b="0" lang="en-US"/>
+              <a:t>11</a:t>
+            </a:fld>
+            <a:endParaRPr lang="en-US"/>
+          </a:p>
+        </p:txBody>
+      </p:sp>
+    </p:spTree>
+  </p:cSld>
+  <p:clrMapOvr>
+    <a:masterClrMapping/>
+  </p:clrMapOvr>
+</p:sld>
+</file>
+
+<file path=ppt/slides/slide12.xml><?xml version="1.0" encoding="utf-8"?>
+<p:sld xmlns:a="http://schemas.openxmlformats.org/drawingml/2006/main" xmlns:r="http://schemas.openxmlformats.org/officeDocument/2006/relationships" xmlns:p="http://schemas.openxmlformats.org/presentationml/2006/main">
+  <p:cSld name="Slide 12">
+    <p:spTree>
+      <p:nvGrpSpPr>
+        <p:cNvPr id="1" name=""/>
+        <p:cNvGrpSpPr/>
+        <p:nvPr/>
+      </p:nvGrpSpPr>
+      <p:grpSpPr>
+        <a:xfrm>
+          <a:off x="0" y="0"/>
+          <a:ext cx="0" cy="0"/>
+          <a:chOff x="0" y="0"/>
+          <a:chExt cx="0" cy="0"/>
+        </a:xfrm>
+      </p:grpSpPr>
+      <p:sp>
+        <p:nvSpPr>
+          <p:cNvPr id="2" name="Text 0"/>
+          <p:cNvSpPr/>
+          <p:nvPr>
+            <p:ph idx="100" type="body" hasCustomPrompt="1"/>
+          </p:nvPr>
+        </p:nvSpPr>
+        <p:spPr>
+          <a:xfrm>
+            <a:off x="457200" y="274320"/>
+            <a:ext cx="8229600" cy="274320"/>
+          </a:xfrm>
+          <a:prstGeom prst="rect">
+            <a:avLst/>
+          </a:prstGeom>
+          <a:noFill/>
+          <a:ln/>
+        </p:spPr>
+        <p:txBody>
+          <a:bodyPr wrap="square" lIns="0" tIns="0" rIns="0" bIns="0" rtlCol="0"/>
+          <a:lstStyle/>
+          <a:p>
+            <a:pPr indent="0" marL="0">
+              <a:buNone/>
+            </a:pPr>
+            <a:r>
+              <a:rPr lang="en-US" sz="1100" b="1" spc="200" kern="0" dirty="0">
+                <a:solidFill>
+                  <a:schemeClr val="accent1"/>
+                </a:solidFill>
+              </a:rPr>
+              <a:t>11  WHY CHOOSE US</a:t>
+            </a:r>
+            <a:endParaRPr lang="en-US" sz="1100" dirty="0"/>
+          </a:p>
+        </p:txBody>
+      </p:sp>
+      <p:sp>
+        <p:nvSpPr>
+          <p:cNvPr id="3" name="Text 0"/>
+          <p:cNvSpPr/>
+          <p:nvPr>
+            <p:ph idx="101" type="title" hasCustomPrompt="1"/>
+          </p:nvPr>
+        </p:nvSpPr>
+        <p:spPr>
+          <a:xfrm>
+            <a:off x="457200" y="530352"/>
+            <a:ext cx="8229600" cy="640080"/>
+          </a:xfrm>
+          <a:prstGeom prst="rect">
+            <a:avLst/>
+          </a:prstGeom>
+          <a:noFill/>
+          <a:ln/>
+        </p:spPr>
+        <p:txBody>
+          <a:bodyPr wrap="square" lIns="0" tIns="0" rIns="0" bIns="0" rtlCol="0" anchor="t"/>
+          <a:lstStyle/>
+          <a:p>
+            <a:pPr algn="l" indent="0" marL="0">
+              <a:buNone/>
+            </a:pPr>
+            <a:r>
+              <a:rPr lang="en-US" sz="3200" b="1" dirty="0">
+                <a:solidFill>
+                  <a:schemeClr val="tx2"/>
+                </a:solidFill>
+                <a:latin typeface="Cambria" pitchFamily="34" charset="0"/>
+                <a:ea typeface="Cambria" pitchFamily="34" charset="-122"/>
+                <a:cs typeface="Cambria" pitchFamily="34" charset="-120"/>
+              </a:rPr>
+              <a:t>Why BrandBrew Marketing</a:t>
+            </a:r>
+            <a:endParaRPr lang="en-US" sz="3200" dirty="0"/>
+          </a:p>
+        </p:txBody>
+      </p:sp>
+      <p:sp>
+        <p:nvSpPr>
+          <p:cNvPr id="4" name="Reason card 1"/>
+          <p:cNvSpPr/>
+          <p:nvPr/>
+        </p:nvSpPr>
+        <p:spPr>
+          <a:xfrm>
+            <a:off x="457200" y="1325880"/>
+            <a:ext cx="2606040" cy="1463040"/>
+          </a:xfrm>
+          <a:prstGeom prst="roundRect">
+            <a:avLst>
+              <a:gd name="adj" fmla="val 7500"/>
+            </a:avLst>
+          </a:prstGeom>
+          <a:solidFill>
+            <a:schemeClr val="bg2"/>
+          </a:solidFill>
+          <a:ln/>
+        </p:spPr>
+      </p:sp>
+      <p:sp>
+        <p:nvSpPr>
+          <p:cNvPr id="5" name="Café specialists circle"/>
+          <p:cNvSpPr/>
+          <p:nvPr/>
+        </p:nvSpPr>
+        <p:spPr>
+          <a:xfrm>
+            <a:off x="640080" y="1527048"/>
+            <a:ext cx="502920" cy="502920"/>
+          </a:xfrm>
+          <a:prstGeom prst="ellipse">
+            <a:avLst/>
+          </a:prstGeom>
+          <a:solidFill>
+            <a:schemeClr val="accent1"/>
+          </a:solidFill>
+          <a:ln/>
+        </p:spPr>
+      </p:sp>
+      <p:pic>
+        <p:nvPicPr>
+          <p:cNvPr id="6" name="Café specialists icon" descr="Café specialists">    </p:cNvPr>
+          <p:cNvPicPr>
+            <a:picLocks noChangeAspect="1"/>
+          </p:cNvPicPr>
+          <p:nvPr/>
+        </p:nvPicPr>
+        <p:blipFill>
+          <a:blip r:embed="rId1"/>
+          <a:stretch>
+            <a:fillRect/>
+          </a:stretch>
+        </p:blipFill>
+        <p:spPr>
+          <a:xfrm>
+            <a:off x="775868" y="1662836"/>
+            <a:ext cx="231343" cy="231343"/>
+          </a:xfrm>
+          <a:prstGeom prst="rect">
+            <a:avLst/>
+          </a:prstGeom>
+        </p:spPr>
+      </p:pic>
+      <p:sp>
+        <p:nvSpPr>
+          <p:cNvPr id="7" name="Reason title 1"/>
+          <p:cNvSpPr txBox="1"/>
+          <p:nvPr/>
+        </p:nvSpPr>
+        <p:spPr>
+          <a:xfrm>
+            <a:off x="1280160" y="1527048"/>
+            <a:ext cx="1691640" cy="502920"/>
+          </a:xfrm>
+          <a:prstGeom prst="rect">
+            <a:avLst/>
+          </a:prstGeom>
+          <a:noFill/>
+          <a:ln/>
+        </p:spPr>
+        <p:txBody>
+          <a:bodyPr wrap="square" lIns="0" tIns="0" rIns="0" bIns="0" rtlCol="0" anchor="ctr"/>
+          <a:lstStyle/>
+          <a:p>
+            <a:pPr indent="0" marL="0">
+              <a:buNone/>
+            </a:pPr>
+            <a:r>
+              <a:rPr lang="en-US" sz="1500" b="1" dirty="0">
+                <a:solidFill>
+                  <a:schemeClr val="tx2"/>
+                </a:solidFill>
+              </a:rPr>
+              <a:t>Café specialists</a:t>
+            </a:r>
+            <a:endParaRPr lang="en-US" sz="1500" dirty="0"/>
+          </a:p>
+        </p:txBody>
+      </p:sp>
+      <p:sp>
+        <p:nvSpPr>
+          <p:cNvPr id="8" name="Reason text 1"/>
+          <p:cNvSpPr txBox="1"/>
+          <p:nvPr/>
+        </p:nvSpPr>
+        <p:spPr>
+          <a:xfrm>
+            <a:off x="640080" y="2148840"/>
+            <a:ext cx="2286000" cy="566928"/>
+          </a:xfrm>
+          <a:prstGeom prst="rect">
+            <a:avLst/>
+          </a:prstGeom>
+          <a:noFill/>
+          <a:ln/>
+        </p:spPr>
+        <p:txBody>
+          <a:bodyPr wrap="square" lIns="0" tIns="0" rIns="0" bIns="0" rtlCol="0" anchor="t"/>
+          <a:lstStyle/>
+          <a:p>
+            <a:pPr indent="0" marL="0">
+              <a:buNone/>
+            </a:pPr>
+            <a:r>
+              <a:rPr lang="en-US" sz="1300" dirty="0">
+                <a:solidFill>
+                  <a:schemeClr val="tx1"/>
+                </a:solidFill>
+              </a:rPr>
+              <a:t>We know what brings people into a café</a:t>
+            </a:r>
+            <a:endParaRPr lang="en-US" sz="1300" dirty="0"/>
+          </a:p>
+        </p:txBody>
+      </p:sp>
+      <p:sp>
+        <p:nvSpPr>
+          <p:cNvPr id="9" name="Reason card 2"/>
+          <p:cNvSpPr/>
+          <p:nvPr/>
+        </p:nvSpPr>
+        <p:spPr>
+          <a:xfrm>
+            <a:off x="3268980" y="1325880"/>
+            <a:ext cx="2606040" cy="1463040"/>
+          </a:xfrm>
+          <a:prstGeom prst="roundRect">
+            <a:avLst>
+              <a:gd name="adj" fmla="val 7500"/>
+            </a:avLst>
+          </a:prstGeom>
+          <a:solidFill>
+            <a:schemeClr val="bg2"/>
+          </a:solidFill>
+          <a:ln/>
+        </p:spPr>
+      </p:sp>
+      <p:sp>
+        <p:nvSpPr>
+          <p:cNvPr id="10" name="Your own team circle"/>
+          <p:cNvSpPr/>
+          <p:nvPr/>
+        </p:nvSpPr>
+        <p:spPr>
+          <a:xfrm>
+            <a:off x="3451860" y="1527048"/>
+            <a:ext cx="502920" cy="502920"/>
+          </a:xfrm>
+          <a:prstGeom prst="ellipse">
+            <a:avLst/>
+          </a:prstGeom>
+          <a:solidFill>
+            <a:schemeClr val="accent1"/>
+          </a:solidFill>
+          <a:ln/>
+        </p:spPr>
+      </p:sp>
+      <p:pic>
+        <p:nvPicPr>
+          <p:cNvPr id="11" name="Your own team icon" descr="Your own team">    </p:cNvPr>
+          <p:cNvPicPr>
+            <a:picLocks noChangeAspect="1"/>
+          </p:cNvPicPr>
+          <p:nvPr/>
+        </p:nvPicPr>
+        <p:blipFill>
+          <a:blip r:embed="rId2"/>
+          <a:stretch>
+            <a:fillRect/>
+          </a:stretch>
+        </p:blipFill>
+        <p:spPr>
+          <a:xfrm>
+            <a:off x="3587648" y="1662836"/>
+            <a:ext cx="231343" cy="231343"/>
+          </a:xfrm>
+          <a:prstGeom prst="rect">
+            <a:avLst/>
+          </a:prstGeom>
+        </p:spPr>
+      </p:pic>
+      <p:sp>
+        <p:nvSpPr>
+          <p:cNvPr id="12" name="Reason title 2"/>
+          <p:cNvSpPr txBox="1"/>
+          <p:nvPr/>
+        </p:nvSpPr>
+        <p:spPr>
+          <a:xfrm>
+            <a:off x="4091940" y="1527048"/>
+            <a:ext cx="1691640" cy="502920"/>
+          </a:xfrm>
+          <a:prstGeom prst="rect">
+            <a:avLst/>
+          </a:prstGeom>
+          <a:noFill/>
+          <a:ln/>
+        </p:spPr>
+        <p:txBody>
+          <a:bodyPr wrap="square" lIns="0" tIns="0" rIns="0" bIns="0" rtlCol="0" anchor="ctr"/>
+          <a:lstStyle/>
+          <a:p>
+            <a:pPr indent="0" marL="0">
+              <a:buNone/>
+            </a:pPr>
+            <a:r>
+              <a:rPr lang="en-US" sz="1500" b="1" dirty="0">
+                <a:solidFill>
+                  <a:schemeClr val="tx2"/>
+                </a:solidFill>
+              </a:rPr>
+              <a:t>Your own team</a:t>
+            </a:r>
+            <a:endParaRPr lang="en-US" sz="1500" dirty="0"/>
+          </a:p>
+        </p:txBody>
+      </p:sp>
+      <p:sp>
+        <p:nvSpPr>
+          <p:cNvPr id="13" name="Reason text 2"/>
+          <p:cNvSpPr txBox="1"/>
+          <p:nvPr/>
+        </p:nvSpPr>
+        <p:spPr>
+          <a:xfrm>
+            <a:off x="3451860" y="2148840"/>
+            <a:ext cx="2286000" cy="566928"/>
+          </a:xfrm>
+          <a:prstGeom prst="rect">
+            <a:avLst/>
+          </a:prstGeom>
+          <a:noFill/>
+          <a:ln/>
+        </p:spPr>
+        <p:txBody>
+          <a:bodyPr wrap="square" lIns="0" tIns="0" rIns="0" bIns="0" rtlCol="0" anchor="t"/>
+          <a:lstStyle/>
+          <a:p>
+            <a:pPr indent="0" marL="0">
+              <a:buNone/>
+            </a:pPr>
+            <a:r>
+              <a:rPr lang="en-US" sz="1300" dirty="0">
+                <a:solidFill>
+                  <a:schemeClr val="tx1"/>
+                </a:solidFill>
+              </a:rPr>
+              <a:t>A dedicated manager for The Daily Cup</a:t>
+            </a:r>
+            <a:endParaRPr lang="en-US" sz="1300" dirty="0"/>
+          </a:p>
+        </p:txBody>
+      </p:sp>
+      <p:sp>
+        <p:nvSpPr>
+          <p:cNvPr id="14" name="Reason card 3"/>
+          <p:cNvSpPr/>
+          <p:nvPr/>
+        </p:nvSpPr>
+        <p:spPr>
+          <a:xfrm>
+            <a:off x="6080760" y="1325880"/>
+            <a:ext cx="2606040" cy="1463040"/>
+          </a:xfrm>
+          <a:prstGeom prst="roundRect">
+            <a:avLst>
+              <a:gd name="adj" fmla="val 7500"/>
+            </a:avLst>
+          </a:prstGeom>
+          <a:solidFill>
+            <a:schemeClr val="bg2"/>
+          </a:solidFill>
+          <a:ln/>
+        </p:spPr>
+      </p:sp>
+      <p:sp>
+        <p:nvSpPr>
+          <p:cNvPr id="15" name="Weekly reports circle"/>
+          <p:cNvSpPr/>
+          <p:nvPr/>
+        </p:nvSpPr>
+        <p:spPr>
+          <a:xfrm>
+            <a:off x="6263640" y="1527048"/>
+            <a:ext cx="502920" cy="502920"/>
+          </a:xfrm>
+          <a:prstGeom prst="ellipse">
+            <a:avLst/>
+          </a:prstGeom>
+          <a:solidFill>
+            <a:schemeClr val="accent1"/>
+          </a:solidFill>
+          <a:ln/>
+        </p:spPr>
+      </p:sp>
+      <p:pic>
+        <p:nvPicPr>
+          <p:cNvPr id="16" name="Weekly reports icon" descr="Weekly reports">    </p:cNvPr>
+          <p:cNvPicPr>
+            <a:picLocks noChangeAspect="1"/>
+          </p:cNvPicPr>
+          <p:nvPr/>
+        </p:nvPicPr>
+        <p:blipFill>
+          <a:blip r:embed="rId3"/>
+          <a:stretch>
+            <a:fillRect/>
+          </a:stretch>
+        </p:blipFill>
+        <p:spPr>
+          <a:xfrm>
+            <a:off x="6399428" y="1662836"/>
+            <a:ext cx="231343" cy="231343"/>
+          </a:xfrm>
+          <a:prstGeom prst="rect">
+            <a:avLst/>
+          </a:prstGeom>
+        </p:spPr>
+      </p:pic>
+      <p:sp>
+        <p:nvSpPr>
+          <p:cNvPr id="17" name="Reason title 3"/>
+          <p:cNvSpPr txBox="1"/>
+          <p:nvPr/>
+        </p:nvSpPr>
+        <p:spPr>
+          <a:xfrm>
+            <a:off x="6903720" y="1527048"/>
+            <a:ext cx="1691640" cy="502920"/>
+          </a:xfrm>
+          <a:prstGeom prst="rect">
+            <a:avLst/>
+          </a:prstGeom>
+          <a:noFill/>
+          <a:ln/>
+        </p:spPr>
+        <p:txBody>
+          <a:bodyPr wrap="square" lIns="0" tIns="0" rIns="0" bIns="0" rtlCol="0" anchor="ctr"/>
+          <a:lstStyle/>
+          <a:p>
+            <a:pPr indent="0" marL="0">
+              <a:buNone/>
+            </a:pPr>
+            <a:r>
+              <a:rPr lang="en-US" sz="1500" b="1" dirty="0">
+                <a:solidFill>
+                  <a:schemeClr val="tx2"/>
+                </a:solidFill>
+              </a:rPr>
+              <a:t>Weekly reports</a:t>
+            </a:r>
+            <a:endParaRPr lang="en-US" sz="1500" dirty="0"/>
+          </a:p>
+        </p:txBody>
+      </p:sp>
+      <p:sp>
+        <p:nvSpPr>
+          <p:cNvPr id="18" name="Reason text 3"/>
+          <p:cNvSpPr txBox="1"/>
+          <p:nvPr/>
+        </p:nvSpPr>
+        <p:spPr>
+          <a:xfrm>
+            <a:off x="6263640" y="2148840"/>
+            <a:ext cx="2286000" cy="566928"/>
+          </a:xfrm>
+          <a:prstGeom prst="rect">
+            <a:avLst/>
+          </a:prstGeom>
+          <a:noFill/>
+          <a:ln/>
+        </p:spPr>
+        <p:txBody>
+          <a:bodyPr wrap="square" lIns="0" tIns="0" rIns="0" bIns="0" rtlCol="0" anchor="t"/>
+          <a:lstStyle/>
+          <a:p>
+            <a:pPr indent="0" marL="0">
+              <a:buNone/>
+            </a:pPr>
+            <a:r>
+              <a:rPr lang="en-US" sz="1300" dirty="0">
+                <a:solidFill>
+                  <a:schemeClr val="tx1"/>
+                </a:solidFill>
+              </a:rPr>
+              <a:t>See exactly what your money does</a:t>
+            </a:r>
+            <a:endParaRPr lang="en-US" sz="1300" dirty="0"/>
+          </a:p>
+        </p:txBody>
+      </p:sp>
+      <p:sp>
+        <p:nvSpPr>
+          <p:cNvPr id="19" name="Reason card 4"/>
+          <p:cNvSpPr/>
+          <p:nvPr/>
+        </p:nvSpPr>
+        <p:spPr>
+          <a:xfrm>
+            <a:off x="457200" y="2971800"/>
+            <a:ext cx="2606040" cy="1463040"/>
+          </a:xfrm>
+          <a:prstGeom prst="roundRect">
+            <a:avLst>
+              <a:gd name="adj" fmla="val 7500"/>
+            </a:avLst>
+          </a:prstGeom>
+          <a:solidFill>
+            <a:schemeClr val="tx2"/>
+          </a:solidFill>
+          <a:ln/>
+        </p:spPr>
+      </p:sp>
+      <p:sp>
+        <p:nvSpPr>
+          <p:cNvPr id="20" name="No long-term contract circle"/>
+          <p:cNvSpPr/>
+          <p:nvPr/>
+        </p:nvSpPr>
+        <p:spPr>
+          <a:xfrm>
+            <a:off x="640080" y="3172968"/>
+            <a:ext cx="502920" cy="502920"/>
+          </a:xfrm>
+          <a:prstGeom prst="ellipse">
+            <a:avLst/>
+          </a:prstGeom>
+          <a:solidFill>
+            <a:schemeClr val="accent4"/>
+          </a:solidFill>
+          <a:ln/>
+        </p:spPr>
+      </p:sp>
+      <p:pic>
+        <p:nvPicPr>
+          <p:cNvPr id="21" name="No long-term contract icon" descr="No long-term contract">    </p:cNvPr>
+          <p:cNvPicPr>
+            <a:picLocks noChangeAspect="1"/>
+          </p:cNvPicPr>
+          <p:nvPr/>
+        </p:nvPicPr>
+        <p:blipFill>
+          <a:blip r:embed="rId4"/>
+          <a:stretch>
+            <a:fillRect/>
+          </a:stretch>
+        </p:blipFill>
+        <p:spPr>
+          <a:xfrm>
+            <a:off x="775868" y="3308756"/>
+            <a:ext cx="231343" cy="231343"/>
+          </a:xfrm>
+          <a:prstGeom prst="rect">
+            <a:avLst/>
+          </a:prstGeom>
+        </p:spPr>
+      </p:pic>
+      <p:sp>
+        <p:nvSpPr>
+          <p:cNvPr id="22" name="Reason title 4"/>
+          <p:cNvSpPr txBox="1"/>
+          <p:nvPr/>
+        </p:nvSpPr>
+        <p:spPr>
+          <a:xfrm>
+            <a:off x="1280160" y="3172968"/>
+            <a:ext cx="1691640" cy="502920"/>
+          </a:xfrm>
+          <a:prstGeom prst="rect">
+            <a:avLst/>
+          </a:prstGeom>
+          <a:noFill/>
+          <a:ln/>
+        </p:spPr>
+        <p:txBody>
+          <a:bodyPr wrap="square" lIns="0" tIns="0" rIns="0" bIns="0" rtlCol="0" anchor="ctr"/>
+          <a:lstStyle/>
+          <a:p>
+            <a:pPr indent="0" marL="0">
+              <a:buNone/>
+            </a:pPr>
+            <a:r>
+              <a:rPr lang="en-US" sz="1500" b="1" dirty="0">
+                <a:solidFill>
+                  <a:schemeClr val="bg1"/>
+                </a:solidFill>
+              </a:rPr>
+              <a:t>No long-term contract</a:t>
+            </a:r>
+            <a:endParaRPr lang="en-US" sz="1500" dirty="0"/>
+          </a:p>
+        </p:txBody>
+      </p:sp>
+      <p:sp>
+        <p:nvSpPr>
+          <p:cNvPr id="23" name="Reason text 4"/>
+          <p:cNvSpPr txBox="1"/>
+          <p:nvPr/>
+        </p:nvSpPr>
+        <p:spPr>
+          <a:xfrm>
+            <a:off x="640080" y="3794760"/>
+            <a:ext cx="2286000" cy="566928"/>
+          </a:xfrm>
+          <a:prstGeom prst="rect">
+            <a:avLst/>
+          </a:prstGeom>
+          <a:noFill/>
+          <a:ln/>
+        </p:spPr>
+        <p:txBody>
+          <a:bodyPr wrap="square" lIns="0" tIns="0" rIns="0" bIns="0" rtlCol="0" anchor="t"/>
+          <a:lstStyle/>
+          <a:p>
+            <a:pPr indent="0" marL="0">
+              <a:buNone/>
+            </a:pPr>
+            <a:r>
+              <a:rPr lang="en-US" sz="1300" dirty="0">
+                <a:solidFill>
+                  <a:schemeClr val="accent2"/>
+                </a:solidFill>
+              </a:rPr>
+              <a:t>Month to month: stay because it works</a:t>
+            </a:r>
+            <a:endParaRPr lang="en-US" sz="1300" dirty="0"/>
+          </a:p>
+        </p:txBody>
+      </p:sp>
+      <p:sp>
+        <p:nvSpPr>
+          <p:cNvPr id="24" name="Reason card 5"/>
+          <p:cNvSpPr/>
+          <p:nvPr/>
+        </p:nvSpPr>
+        <p:spPr>
+          <a:xfrm>
+            <a:off x="3268980" y="2971800"/>
+            <a:ext cx="2606040" cy="1463040"/>
+          </a:xfrm>
+          <a:prstGeom prst="roundRect">
+            <a:avLst>
+              <a:gd name="adj" fmla="val 7500"/>
+            </a:avLst>
+          </a:prstGeom>
+          <a:solidFill>
+            <a:schemeClr val="tx2"/>
+          </a:solidFill>
+          <a:ln/>
+        </p:spPr>
+      </p:sp>
+      <p:sp>
+        <p:nvSpPr>
+          <p:cNvPr id="25" name="Free audit circle"/>
+          <p:cNvSpPr/>
+          <p:nvPr/>
+        </p:nvSpPr>
+        <p:spPr>
+          <a:xfrm>
+            <a:off x="3451860" y="3172968"/>
+            <a:ext cx="502920" cy="502920"/>
+          </a:xfrm>
+          <a:prstGeom prst="ellipse">
+            <a:avLst/>
+          </a:prstGeom>
+          <a:solidFill>
+            <a:schemeClr val="accent4"/>
+          </a:solidFill>
+          <a:ln/>
+        </p:spPr>
+      </p:sp>
+      <p:pic>
+        <p:nvPicPr>
+          <p:cNvPr id="26" name="Free audit icon" descr="Free audit">    </p:cNvPr>
+          <p:cNvPicPr>
+            <a:picLocks noChangeAspect="1"/>
+          </p:cNvPicPr>
+          <p:nvPr/>
+        </p:nvPicPr>
+        <p:blipFill>
+          <a:blip r:embed="rId5"/>
+          <a:stretch>
+            <a:fillRect/>
+          </a:stretch>
+        </p:blipFill>
+        <p:spPr>
+          <a:xfrm>
+            <a:off x="3587648" y="3308756"/>
+            <a:ext cx="231343" cy="231343"/>
+          </a:xfrm>
+          <a:prstGeom prst="rect">
+            <a:avLst/>
+          </a:prstGeom>
+        </p:spPr>
+      </p:pic>
+      <p:sp>
+        <p:nvSpPr>
+          <p:cNvPr id="27" name="Reason title 5"/>
+          <p:cNvSpPr txBox="1"/>
+          <p:nvPr/>
+        </p:nvSpPr>
+        <p:spPr>
+          <a:xfrm>
+            <a:off x="4091940" y="3172968"/>
+            <a:ext cx="1691640" cy="502920"/>
+          </a:xfrm>
+          <a:prstGeom prst="rect">
+            <a:avLst/>
+          </a:prstGeom>
+          <a:noFill/>
+          <a:ln/>
+        </p:spPr>
+        <p:txBody>
+          <a:bodyPr wrap="square" lIns="0" tIns="0" rIns="0" bIns="0" rtlCol="0" anchor="ctr"/>
+          <a:lstStyle/>
+          <a:p>
+            <a:pPr indent="0" marL="0">
+              <a:buNone/>
+            </a:pPr>
+            <a:r>
+              <a:rPr lang="en-US" sz="1500" b="1" dirty="0">
+                <a:solidFill>
+                  <a:schemeClr val="bg1"/>
+                </a:solidFill>
+              </a:rPr>
+              <a:t>Free audit</a:t>
+            </a:r>
+            <a:endParaRPr lang="en-US" sz="1500" dirty="0"/>
+          </a:p>
+        </p:txBody>
+      </p:sp>
+      <p:sp>
+        <p:nvSpPr>
+          <p:cNvPr id="28" name="Reason text 5"/>
+          <p:cNvSpPr txBox="1"/>
+          <p:nvPr/>
+        </p:nvSpPr>
+        <p:spPr>
+          <a:xfrm>
+            <a:off x="3451860" y="3794760"/>
+            <a:ext cx="2286000" cy="566928"/>
+          </a:xfrm>
+          <a:prstGeom prst="rect">
+            <a:avLst/>
+          </a:prstGeom>
+          <a:noFill/>
+          <a:ln/>
+        </p:spPr>
+        <p:txBody>
+          <a:bodyPr wrap="square" lIns="0" tIns="0" rIns="0" bIns="0" rtlCol="0" anchor="t"/>
+          <a:lstStyle/>
+          <a:p>
+            <a:pPr indent="0" marL="0">
+              <a:buNone/>
+            </a:pPr>
+            <a:r>
+              <a:rPr lang="en-US" sz="1300" dirty="0">
+                <a:solidFill>
+                  <a:schemeClr val="accent2"/>
+                </a:solidFill>
+              </a:rPr>
+              <a:t>A free review of your pages in week 1</a:t>
+            </a:r>
+            <a:endParaRPr lang="en-US" sz="1300" dirty="0"/>
+          </a:p>
+        </p:txBody>
+      </p:sp>
+      <p:sp>
+        <p:nvSpPr>
+          <p:cNvPr id="29" name="Reason card 6"/>
+          <p:cNvSpPr/>
+          <p:nvPr/>
+        </p:nvSpPr>
+        <p:spPr>
+          <a:xfrm>
+            <a:off x="6080760" y="2971800"/>
+            <a:ext cx="2606040" cy="1463040"/>
+          </a:xfrm>
+          <a:prstGeom prst="roundRect">
+            <a:avLst>
+              <a:gd name="adj" fmla="val 7500"/>
+            </a:avLst>
+          </a:prstGeom>
+          <a:solidFill>
+            <a:schemeClr val="tx2"/>
+          </a:solidFill>
+          <a:ln/>
+        </p:spPr>
+      </p:sp>
+      <p:sp>
+        <p:nvSpPr>
+          <p:cNvPr id="30" name="Reach guarantee circle"/>
+          <p:cNvSpPr/>
+          <p:nvPr/>
+        </p:nvSpPr>
+        <p:spPr>
+          <a:xfrm>
+            <a:off x="6263640" y="3172968"/>
+            <a:ext cx="502920" cy="502920"/>
+          </a:xfrm>
+          <a:prstGeom prst="ellipse">
+            <a:avLst/>
+          </a:prstGeom>
+          <a:solidFill>
+            <a:schemeClr val="accent4"/>
+          </a:solidFill>
+          <a:ln/>
+        </p:spPr>
+      </p:sp>
+      <p:pic>
+        <p:nvPicPr>
+          <p:cNvPr id="31" name="Reach guarantee icon" descr="Reach guarantee">    </p:cNvPr>
+          <p:cNvPicPr>
+            <a:picLocks noChangeAspect="1"/>
+          </p:cNvPicPr>
+          <p:nvPr/>
+        </p:nvPicPr>
+        <p:blipFill>
+          <a:blip r:embed="rId6"/>
+          <a:stretch>
+            <a:fillRect/>
+          </a:stretch>
+        </p:blipFill>
+        <p:spPr>
+          <a:xfrm>
+            <a:off x="6399428" y="3308756"/>
+            <a:ext cx="231343" cy="231343"/>
+          </a:xfrm>
+          <a:prstGeom prst="rect">
+            <a:avLst/>
+          </a:prstGeom>
+        </p:spPr>
+      </p:pic>
+      <p:sp>
+        <p:nvSpPr>
+          <p:cNvPr id="32" name="Reason title 6"/>
+          <p:cNvSpPr txBox="1"/>
+          <p:nvPr/>
+        </p:nvSpPr>
+        <p:spPr>
+          <a:xfrm>
+            <a:off x="6903720" y="3172968"/>
+            <a:ext cx="1691640" cy="502920"/>
+          </a:xfrm>
+          <a:prstGeom prst="rect">
+            <a:avLst/>
+          </a:prstGeom>
+          <a:noFill/>
+          <a:ln/>
+        </p:spPr>
+        <p:txBody>
+          <a:bodyPr wrap="square" lIns="0" tIns="0" rIns="0" bIns="0" rtlCol="0" anchor="ctr"/>
+          <a:lstStyle/>
+          <a:p>
+            <a:pPr indent="0" marL="0">
+              <a:buNone/>
+            </a:pPr>
+            <a:r>
+              <a:rPr lang="en-US" sz="1500" b="1" dirty="0">
+                <a:solidFill>
+                  <a:schemeClr val="bg1"/>
+                </a:solidFill>
+              </a:rPr>
+              <a:t>Reach guarantee</a:t>
+            </a:r>
+            <a:endParaRPr lang="en-US" sz="1500" dirty="0"/>
+          </a:p>
+        </p:txBody>
+      </p:sp>
+      <p:sp>
+        <p:nvSpPr>
+          <p:cNvPr id="33" name="Reason text 6"/>
+          <p:cNvSpPr txBox="1"/>
+          <p:nvPr/>
+        </p:nvSpPr>
+        <p:spPr>
+          <a:xfrm>
+            <a:off x="6263640" y="3794760"/>
+            <a:ext cx="2286000" cy="566928"/>
+          </a:xfrm>
+          <a:prstGeom prst="rect">
+            <a:avLst/>
+          </a:prstGeom>
+          <a:noFill/>
+          <a:ln/>
+        </p:spPr>
+        <p:txBody>
+          <a:bodyPr wrap="square" lIns="0" tIns="0" rIns="0" bIns="0" rtlCol="0" anchor="t"/>
+          <a:lstStyle/>
+          <a:p>
+            <a:pPr indent="0" marL="0">
+              <a:buNone/>
+            </a:pPr>
+            <a:r>
+              <a:rPr lang="en-US" sz="1300" dirty="0">
+                <a:solidFill>
+                  <a:schemeClr val="accent2"/>
+                </a:solidFill>
+              </a:rPr>
+              <a:t>Miss the reach target? An extra week of ads at no fee</a:t>
+            </a:r>
+            <a:endParaRPr lang="en-US" sz="1300" dirty="0"/>
+          </a:p>
+        </p:txBody>
+      </p:sp>
+      <p:sp>
+        <p:nvSpPr>
+          <p:cNvPr id="25" name="Slide Number Placeholder 0"/>
+          <p:cNvSpPr>
+            <a:spLocks noGrp="1"/>
+          </p:cNvSpPr>
+          <p:nvPr>
+            <p:ph type="sldNum" sz="quarter" idx="4294967295"/>
+          </p:nvPr>
+        </p:nvSpPr>
+        <p:spPr>
+          <a:xfrm>
+            <a:off x="8229600" y="4800600"/>
+            <a:ext cx="457200" cy="228600"/>
+          </a:xfrm>
+          <a:prstGeom prst="rect">
+            <a:avLst/>
+          </a:prstGeom>
+          <a:extLst>
+            <a:ext uri="{C572A759-6A51-4108-AA02-DFA0A04FC94B}">
+              <ma14:wrappingTextBoxFlag xmlns:ma14="http://schemas.microsoft.com/office/mac/drawingml/2011/main" val="0"/>
+            </a:ext>
+          </a:extLst>
+        </p:spPr>
+        <p:txBody>
+          <a:bodyPr lIns="0" tIns="0" rIns="0" bIns="0" anchor="ctr"/>
+          <a:lstStyle>
+            <a:lvl1pPr>
+              <a:defRPr sz="1000">
+                <a:solidFill>
+                  <a:schemeClr val="accent5"/>
+                </a:solidFill>
+              </a:defRPr>
+            </a:lvl1pPr>
+          </a:lstStyle>
+          <a:p>
+            <a:pPr algn="r"/>
+            <a:fld id="{F7021451-1387-4CA6-816F-3879F97B5CBC}" type="slidenum">
+              <a:rPr b="0" lang="en-US"/>
+              <a:t>12</a:t>
+            </a:fld>
+            <a:endParaRPr lang="en-US"/>
+          </a:p>
+        </p:txBody>
+      </p:sp>
+    </p:spTree>
+  </p:cSld>
+  <p:clrMapOvr>
+    <a:masterClrMapping/>
+  </p:clrMapOvr>
+</p:sld>
+</file>
+
+<file path=ppt/slides/slide13.xml><?xml version="1.0" encoding="utf-8"?>
+<p:sld xmlns:a="http://schemas.openxmlformats.org/drawingml/2006/main" xmlns:r="http://schemas.openxmlformats.org/officeDocument/2006/relationships" xmlns:p="http://schemas.openxmlformats.org/presentationml/2006/main">
+  <p:cSld name="Slide 13">
+    <p:spTree>
+      <p:nvGrpSpPr>
+        <p:cNvPr id="1" name=""/>
+        <p:cNvGrpSpPr/>
+        <p:nvPr/>
+      </p:nvGrpSpPr>
+      <p:grpSpPr>
+        <a:xfrm>
+          <a:off x="0" y="0"/>
+          <a:ext cx="0" cy="0"/>
+          <a:chOff x="0" y="0"/>
+          <a:chExt cx="0" cy="0"/>
+        </a:xfrm>
+      </p:grpSpPr>
+      <p:sp>
+        <p:nvSpPr>
+          <p:cNvPr id="2" name="Text 0"/>
+          <p:cNvSpPr/>
+          <p:nvPr>
+            <p:ph idx="100" type="body" hasCustomPrompt="1"/>
+          </p:nvPr>
+        </p:nvSpPr>
+        <p:spPr>
+          <a:xfrm>
+            <a:off x="548640" y="914400"/>
+            <a:ext cx="4389120" cy="320040"/>
+          </a:xfrm>
+          <a:prstGeom prst="rect">
+            <a:avLst/>
+          </a:prstGeom>
+          <a:noFill/>
+          <a:ln/>
+        </p:spPr>
+        <p:txBody>
+          <a:bodyPr wrap="square" lIns="0" tIns="0" rIns="0" bIns="0" rtlCol="0"/>
+          <a:lstStyle/>
+          <a:p>
+            <a:pPr indent="0" marL="0">
+              <a:buNone/>
+            </a:pPr>
+            <a:r>
+              <a:rPr lang="en-US" sz="1200" b="1" spc="300" kern="0" dirty="0">
+                <a:solidFill>
+                  <a:schemeClr val="accent2"/>
+                </a:solidFill>
+              </a:rPr>
+              <a:t>12  CONCLUSION</a:t>
+            </a:r>
+            <a:endParaRPr lang="en-US" sz="1200" dirty="0"/>
+          </a:p>
+        </p:txBody>
+      </p:sp>
+      <p:sp>
+        <p:nvSpPr>
+          <p:cNvPr id="3" name="Text 0"/>
+          <p:cNvSpPr/>
+          <p:nvPr>
+            <p:ph idx="101" type="title" hasCustomPrompt="1"/>
+          </p:nvPr>
+        </p:nvSpPr>
+        <p:spPr>
+          <a:xfrm>
             <a:off x="548640" y="1325880"/>
             <a:ext cx="4389120" cy="1463040"/>
           </a:xfrm>
@@ -3476,7 +5499,7 @@
                   <a:schemeClr val="accent2"/>
                 </a:solidFill>
               </a:rPr>
-              <a:t>We're ready to help The Daily Cup grow and reach more customers.</a:t>
+              <a:t>Start this month and see results within 30 days.</a:t>
             </a:r>
             <a:endParaRPr lang="en-US" sz="1500" dirty="0"/>
           </a:p>
@@ -3484,43 +5507,29 @@
       </p:sp>
       <p:sp>
         <p:nvSpPr>
-          <p:cNvPr id="5" name="Contact details"/>
-          <p:cNvSpPr txBox="1"/>
-          <p:nvPr/>
-        </p:nvSpPr>
-        <p:spPr>
-          <a:xfrm>
-            <a:off x="548640" y="4069080"/>
-            <a:ext cx="4389120" cy="320040"/>
-          </a:xfrm>
-          <a:prstGeom prst="rect">
-            <a:avLst/>
-          </a:prstGeom>
-          <a:noFill/>
-          <a:ln/>
-        </p:spPr>
-        <p:txBody>
-          <a:bodyPr wrap="square" lIns="0" tIns="0" rIns="0" bIns="0" rtlCol="0" anchor="ctr"/>
-          <a:lstStyle/>
-          <a:p>
-            <a:pPr indent="0" marL="0">
-              <a:buNone/>
-            </a:pPr>
-            <a:r>
-              <a:rPr lang="en-US" sz="1300" dirty="0">
-                <a:solidFill>
-                  <a:schemeClr val="accent2"/>
-                </a:solidFill>
-              </a:rPr>
-              <a:t>BrandBrew Marketing   |   [Phone]   |   [Email]</a:t>
-            </a:r>
-            <a:endParaRPr lang="en-US" sz="1300" dirty="0"/>
-          </a:p>
-        </p:txBody>
+          <p:cNvPr id="5" name="Offer badge"/>
+          <p:cNvSpPr/>
+          <p:nvPr/>
+        </p:nvSpPr>
+        <p:spPr>
+          <a:xfrm>
+            <a:off x="548640" y="3429000"/>
+            <a:ext cx="4206240" cy="548640"/>
+          </a:xfrm>
+          <a:prstGeom prst="roundRect">
+            <a:avLst>
+              <a:gd name="adj" fmla="val 50000"/>
+            </a:avLst>
+          </a:prstGeom>
+          <a:solidFill>
+            <a:schemeClr val="accent1"/>
+          </a:solidFill>
+          <a:ln/>
+        </p:spPr>
       </p:sp>
       <p:pic>
         <p:nvPicPr>
-          <p:cNvPr id="6" name="Partnership illustration" descr="Partnership illustration">    </p:cNvPr>
+          <p:cNvPr id="6" name="Offer icon" descr="preencoded.png">    </p:cNvPr>
           <p:cNvPicPr>
             <a:picLocks noChangeAspect="1"/>
           </p:cNvPicPr>
@@ -3528,6 +5537,102 @@
         </p:nvPicPr>
         <p:blipFill>
           <a:blip r:embed="rId1"/>
+          <a:stretch>
+            <a:fillRect/>
+          </a:stretch>
+        </p:blipFill>
+        <p:spPr>
+          <a:xfrm>
+            <a:off x="731520" y="3547872"/>
+            <a:ext cx="310896" cy="310896"/>
+          </a:xfrm>
+          <a:prstGeom prst="rect">
+            <a:avLst/>
+          </a:prstGeom>
+        </p:spPr>
+      </p:pic>
+      <p:sp>
+        <p:nvSpPr>
+          <p:cNvPr id="7" name="Offer text"/>
+          <p:cNvSpPr txBox="1"/>
+          <p:nvPr/>
+        </p:nvSpPr>
+        <p:spPr>
+          <a:xfrm>
+            <a:off x="1188720" y="3429000"/>
+            <a:ext cx="3474720" cy="548640"/>
+          </a:xfrm>
+          <a:prstGeom prst="rect">
+            <a:avLst/>
+          </a:prstGeom>
+          <a:noFill/>
+          <a:ln/>
+        </p:spPr>
+        <p:txBody>
+          <a:bodyPr wrap="square" lIns="0" tIns="0" rIns="0" bIns="0" rtlCol="0" anchor="ctr"/>
+          <a:lstStyle/>
+          <a:p>
+            <a:pPr indent="0" marL="0">
+              <a:buNone/>
+            </a:pPr>
+            <a:r>
+              <a:rPr lang="en-US" sz="1400" b="1" dirty="0">
+                <a:solidFill>
+                  <a:schemeClr val="bg1"/>
+                </a:solidFill>
+              </a:rPr>
+              <a:t>Start this month: free menu photo shoot</a:t>
+            </a:r>
+            <a:endParaRPr lang="en-US" sz="1400" dirty="0"/>
+          </a:p>
+        </p:txBody>
+      </p:sp>
+      <p:sp>
+        <p:nvSpPr>
+          <p:cNvPr id="8" name="Contact details"/>
+          <p:cNvSpPr txBox="1"/>
+          <p:nvPr/>
+        </p:nvSpPr>
+        <p:spPr>
+          <a:xfrm>
+            <a:off x="548640" y="4206240"/>
+            <a:ext cx="4389120" cy="320040"/>
+          </a:xfrm>
+          <a:prstGeom prst="rect">
+            <a:avLst/>
+          </a:prstGeom>
+          <a:noFill/>
+          <a:ln/>
+        </p:spPr>
+        <p:txBody>
+          <a:bodyPr wrap="square" lIns="0" tIns="0" rIns="0" bIns="0" rtlCol="0" anchor="ctr"/>
+          <a:lstStyle/>
+          <a:p>
+            <a:pPr indent="0" marL="0">
+              <a:buNone/>
+            </a:pPr>
+            <a:r>
+              <a:rPr lang="en-US" sz="1300" dirty="0">
+                <a:solidFill>
+                  <a:schemeClr val="accent2"/>
+                </a:solidFill>
+              </a:rPr>
+              <a:t>BrandBrew Marketing   |   [Phone]   |   [Email]</a:t>
+            </a:r>
+            <a:endParaRPr lang="en-US" sz="1300" dirty="0"/>
+          </a:p>
+        </p:txBody>
+      </p:sp>
+      <p:pic>
+        <p:nvPicPr>
+          <p:cNvPr id="9" name="Next steps illustration" descr="Next steps illustration">    </p:cNvPr>
+          <p:cNvPicPr>
+            <a:picLocks noChangeAspect="1"/>
+          </p:cNvPicPr>
+          <p:nvPr/>
+        </p:nvPicPr>
+        <p:blipFill>
+          <a:blip r:embed="rId2"/>
           <a:stretch>
             <a:fillRect/>
           </a:stretch>
@@ -4863,7 +6968,7 @@
                   <a:schemeClr val="tx1"/>
                 </a:solidFill>
               </a:rPr>
-              <a:t>Regular posts, reels and stories</a:t>
+              <a:t>12 posts, 8 reels and daily stories a month</a:t>
             </a:r>
             <a:endParaRPr lang="en-US" sz="1300" dirty="0"/>
           </a:p>
@@ -4981,7 +7086,7 @@
                   <a:schemeClr val="tx1"/>
                 </a:solidFill>
               </a:rPr>
-              <a:t>Facebook and Instagram ads</a:t>
+              <a:t>Targeted Facebook and Instagram ads near the café</a:t>
             </a:r>
             <a:endParaRPr lang="en-US" sz="1300" dirty="0"/>
           </a:p>
@@ -5099,7 +7204,7 @@
                   <a:schemeClr val="tx1"/>
                 </a:solidFill>
               </a:rPr>
-              <a:t>Attractive photos and videos of products</a:t>
+              <a:t>A professional photo and video shoot every month</a:t>
             </a:r>
             <a:endParaRPr lang="en-US" sz="1300" dirty="0"/>
           </a:p>
@@ -5217,7 +7322,7 @@
                   <a:schemeClr val="tx1"/>
                 </a:solidFill>
               </a:rPr>
-              <a:t>Discounts and special deals</a:t>
+              <a:t>2 special offers a month to bring people in</a:t>
             </a:r>
             <a:endParaRPr lang="en-US" sz="1300" dirty="0"/>
           </a:p>
@@ -8702,7 +10807,7 @@
                 <a:ea typeface="Cambria" pitchFamily="34" charset="-122"/>
                 <a:cs typeface="Cambria" pitchFamily="34" charset="-120"/>
               </a:rPr>
-              <a:t>What We Aim for in Month One</a:t>
+              <a:t>Our Month-One Targets</a:t>
             </a:r>
             <a:endParaRPr lang="en-US" sz="3200" dirty="0"/>
           </a:p>
@@ -8710,18 +10815,18 @@
       </p:sp>
       <p:sp>
         <p:nvSpPr>
-          <p:cNvPr id="4" name="Result card 1"/>
+          <p:cNvPr id="4" name="Target card 1"/>
           <p:cNvSpPr/>
           <p:nvPr/>
         </p:nvSpPr>
         <p:spPr>
           <a:xfrm>
             <a:off x="457200" y="1325880"/>
-            <a:ext cx="1517904" cy="1828800"/>
+            <a:ext cx="1920240" cy="1874520"/>
           </a:xfrm>
           <a:prstGeom prst="roundRect">
             <a:avLst>
-              <a:gd name="adj" fmla="val 7229"/>
+              <a:gd name="adj" fmla="val 5854"/>
             </a:avLst>
           </a:prstGeom>
           <a:solidFill>
@@ -8732,14 +10837,14 @@
       </p:sp>
       <p:sp>
         <p:nvSpPr>
-          <p:cNvPr id="5" name="Followers circle"/>
+          <p:cNvPr id="5" name="Target 1 circle"/>
           <p:cNvSpPr/>
           <p:nvPr/>
         </p:nvSpPr>
         <p:spPr>
           <a:xfrm>
-            <a:off x="621792" y="1490472"/>
-            <a:ext cx="548640" cy="548640"/>
+            <a:off x="640080" y="1481328"/>
+            <a:ext cx="475488" cy="475488"/>
           </a:xfrm>
           <a:prstGeom prst="ellipse">
             <a:avLst/>
@@ -8752,7 +10857,7 @@
       </p:sp>
       <p:pic>
         <p:nvPicPr>
-          <p:cNvPr id="6" name="Followers icon" descr="Followers">    </p:cNvPr>
+          <p:cNvPr id="6" name="Target 1 icon" descr="Target 1">    </p:cNvPr>
           <p:cNvPicPr>
             <a:picLocks noChangeAspect="1"/>
           </p:cNvPicPr>
@@ -8766,8 +10871,8 @@
         </p:blipFill>
         <p:spPr>
           <a:xfrm>
-            <a:off x="769925" y="1638605"/>
-            <a:ext cx="252374" cy="252374"/>
+            <a:off x="768462" y="1609710"/>
+            <a:ext cx="218724" cy="218724"/>
           </a:xfrm>
           <a:prstGeom prst="rect">
             <a:avLst/>
@@ -8776,27 +10881,124 @@
       </p:pic>
       <p:sp>
         <p:nvSpPr>
-          <p:cNvPr id="7" name="Increase 1 circle"/>
+          <p:cNvPr id="7" name="Target value 1"/>
+          <p:cNvSpPr txBox="1"/>
+          <p:nvPr/>
+        </p:nvSpPr>
+        <p:spPr>
+          <a:xfrm>
+            <a:off x="640080" y="2057400"/>
+            <a:ext cx="1600200" cy="548640"/>
+          </a:xfrm>
+          <a:prstGeom prst="rect">
+            <a:avLst/>
+          </a:prstGeom>
+          <a:noFill/>
+          <a:ln/>
+        </p:spPr>
+        <p:txBody>
+          <a:bodyPr wrap="square" lIns="0" tIns="0" rIns="0" bIns="0" rtlCol="0" anchor="ctr"/>
+          <a:lstStyle/>
+          <a:p>
+            <a:pPr indent="0" marL="0">
+              <a:buNone/>
+            </a:pPr>
+            <a:r>
+              <a:rPr lang="en-US" sz="3400" b="1" dirty="0">
+                <a:solidFill>
+                  <a:schemeClr val="accent1"/>
+                </a:solidFill>
+                <a:latin typeface="Cambria" pitchFamily="34" charset="0"/>
+                <a:ea typeface="Cambria" pitchFamily="34" charset="-122"/>
+                <a:cs typeface="Cambria" pitchFamily="34" charset="-120"/>
+              </a:rPr>
+              <a:t>40K+</a:t>
+            </a:r>
+            <a:endParaRPr lang="en-US" sz="3400" dirty="0"/>
+          </a:p>
+        </p:txBody>
+      </p:sp>
+      <p:sp>
+        <p:nvSpPr>
+          <p:cNvPr id="8" name="Target label 1"/>
+          <p:cNvSpPr txBox="1"/>
+          <p:nvPr/>
+        </p:nvSpPr>
+        <p:spPr>
+          <a:xfrm>
+            <a:off x="640080" y="2633472"/>
+            <a:ext cx="1600200" cy="502920"/>
+          </a:xfrm>
+          <a:prstGeom prst="rect">
+            <a:avLst/>
+          </a:prstGeom>
+          <a:noFill/>
+          <a:ln/>
+        </p:spPr>
+        <p:txBody>
+          <a:bodyPr wrap="square" lIns="0" tIns="0" rIns="0" bIns="0" rtlCol="0" anchor="t"/>
+          <a:lstStyle/>
+          <a:p>
+            <a:pPr indent="0" marL="0">
+              <a:buNone/>
+            </a:pPr>
+            <a:r>
+              <a:rPr lang="en-US" sz="1200" dirty="0">
+                <a:solidFill>
+                  <a:schemeClr val="tx2"/>
+                </a:solidFill>
+              </a:rPr>
+              <a:t>people nearby see The Daily Cup</a:t>
+            </a:r>
+            <a:endParaRPr lang="en-US" sz="1200" dirty="0"/>
+          </a:p>
+        </p:txBody>
+      </p:sp>
+      <p:sp>
+        <p:nvSpPr>
+          <p:cNvPr id="9" name="Target card 2"/>
           <p:cNvSpPr/>
           <p:nvPr/>
         </p:nvSpPr>
         <p:spPr>
           <a:xfrm>
-            <a:off x="1426464" y="1536192"/>
-            <a:ext cx="384048" cy="384048"/>
+            <a:off x="2560320" y="1325880"/>
+            <a:ext cx="1920240" cy="1874520"/>
+          </a:xfrm>
+          <a:prstGeom prst="roundRect">
+            <a:avLst>
+              <a:gd name="adj" fmla="val 5854"/>
+            </a:avLst>
+          </a:prstGeom>
+          <a:solidFill>
+            <a:schemeClr val="bg2"/>
+          </a:solidFill>
+          <a:ln/>
+        </p:spPr>
+      </p:sp>
+      <p:sp>
+        <p:nvSpPr>
+          <p:cNvPr id="10" name="Target 2 circle"/>
+          <p:cNvSpPr/>
+          <p:nvPr/>
+        </p:nvSpPr>
+        <p:spPr>
+          <a:xfrm>
+            <a:off x="2743200" y="1481328"/>
+            <a:ext cx="475488" cy="475488"/>
           </a:xfrm>
           <a:prstGeom prst="ellipse">
             <a:avLst/>
           </a:prstGeom>
           <a:solidFill>
-            <a:schemeClr val="accent4"/>
+            <a:schemeClr val="tx2"/>
           </a:solidFill>
           <a:ln/>
         </p:spPr>
       </p:sp>
       <p:pic>
         <p:nvPicPr>
-          <p:cNvPr id="8" name="Increase 1 icon" descr="Increase 1">    </p:cNvPr>
+          <p:cNvPr id="11" name="Target 2 icon" descr="Target 2">    </p:cNvPr>
           <p:cNvPicPr>
             <a:picLocks noChangeAspect="1"/>
           </p:cNvPicPr>
@@ -8810,8 +11012,8 @@
         </p:blipFill>
         <p:spPr>
           <a:xfrm>
-            <a:off x="1530157" y="1639885"/>
-            <a:ext cx="176662" cy="176662"/>
+            <a:off x="2871582" y="1609710"/>
+            <a:ext cx="218724" cy="218724"/>
           </a:xfrm>
           <a:prstGeom prst="rect">
             <a:avLst/>
@@ -8820,14 +11022,53 @@
       </p:pic>
       <p:sp>
         <p:nvSpPr>
-          <p:cNvPr id="9" name="Result text 1"/>
+          <p:cNvPr id="12" name="Target value 2"/>
           <p:cNvSpPr txBox="1"/>
           <p:nvPr/>
         </p:nvSpPr>
         <p:spPr>
           <a:xfrm>
-            <a:off x="621792" y="2194560"/>
-            <a:ext cx="1280160" cy="868680"/>
+            <a:off x="2743200" y="2057400"/>
+            <a:ext cx="1600200" cy="548640"/>
+          </a:xfrm>
+          <a:prstGeom prst="rect">
+            <a:avLst/>
+          </a:prstGeom>
+          <a:noFill/>
+          <a:ln/>
+        </p:spPr>
+        <p:txBody>
+          <a:bodyPr wrap="square" lIns="0" tIns="0" rIns="0" bIns="0" rtlCol="0" anchor="ctr"/>
+          <a:lstStyle/>
+          <a:p>
+            <a:pPr indent="0" marL="0">
+              <a:buNone/>
+            </a:pPr>
+            <a:r>
+              <a:rPr lang="en-US" sz="3400" b="1" dirty="0">
+                <a:solidFill>
+                  <a:schemeClr val="accent1"/>
+                </a:solidFill>
+                <a:latin typeface="Cambria" pitchFamily="34" charset="0"/>
+                <a:ea typeface="Cambria" pitchFamily="34" charset="-122"/>
+                <a:cs typeface="Cambria" pitchFamily="34" charset="-120"/>
+              </a:rPr>
+              <a:t>+500</a:t>
+            </a:r>
+            <a:endParaRPr lang="en-US" sz="3400" dirty="0"/>
+          </a:p>
+        </p:txBody>
+      </p:sp>
+      <p:sp>
+        <p:nvSpPr>
+          <p:cNvPr id="13" name="Target label 2"/>
+          <p:cNvSpPr txBox="1"/>
+          <p:nvPr/>
+        </p:nvSpPr>
+        <p:spPr>
+          <a:xfrm>
+            <a:off x="2743200" y="2633472"/>
+            <a:ext cx="1600200" cy="502920"/>
           </a:xfrm>
           <a:prstGeom prst="rect">
             <a:avLst/>
@@ -8843,45 +11084,31 @@
               <a:buNone/>
             </a:pPr>
             <a:r>
-              <a:rPr lang="en-US" sz="1500" b="1" dirty="0">
+              <a:rPr lang="en-US" sz="1200" dirty="0">
                 <a:solidFill>
                   <a:schemeClr val="tx2"/>
                 </a:solidFill>
               </a:rPr>
-              <a:t>More followers</a:t>
-            </a:r>
-            <a:endParaRPr lang="en-US" sz="1500" dirty="0"/>
-          </a:p>
-          <a:p>
-            <a:pPr indent="0" marL="0">
-              <a:buNone/>
-            </a:pPr>
-            <a:r>
-              <a:rPr lang="en-US" sz="1200" dirty="0">
-                <a:solidFill>
-                  <a:schemeClr val="tx1"/>
-                </a:solidFill>
-              </a:rPr>
-              <a:t>and engagement</a:t>
-            </a:r>
-            <a:endParaRPr lang="en-US" sz="1500" dirty="0"/>
-          </a:p>
-        </p:txBody>
-      </p:sp>
-      <p:sp>
-        <p:nvSpPr>
-          <p:cNvPr id="10" name="Result card 2"/>
+              <a:t>new Instagram followers</a:t>
+            </a:r>
+            <a:endParaRPr lang="en-US" sz="1200" dirty="0"/>
+          </a:p>
+        </p:txBody>
+      </p:sp>
+      <p:sp>
+        <p:nvSpPr>
+          <p:cNvPr id="14" name="Target card 3"/>
           <p:cNvSpPr/>
           <p:nvPr/>
         </p:nvSpPr>
         <p:spPr>
           <a:xfrm>
-            <a:off x="2139696" y="1325880"/>
-            <a:ext cx="1517904" cy="1828800"/>
+            <a:off x="4663440" y="1325880"/>
+            <a:ext cx="1920240" cy="1874520"/>
           </a:xfrm>
           <a:prstGeom prst="roundRect">
             <a:avLst>
-              <a:gd name="adj" fmla="val 7229"/>
+              <a:gd name="adj" fmla="val 5854"/>
             </a:avLst>
           </a:prstGeom>
           <a:solidFill>
@@ -8892,14 +11119,14 @@
       </p:sp>
       <p:sp>
         <p:nvSpPr>
-          <p:cNvPr id="11" name="Inquiries circle"/>
+          <p:cNvPr id="15" name="Target 3 circle"/>
           <p:cNvSpPr/>
           <p:nvPr/>
         </p:nvSpPr>
         <p:spPr>
           <a:xfrm>
-            <a:off x="2304288" y="1490472"/>
-            <a:ext cx="548640" cy="548640"/>
+            <a:off x="4846320" y="1481328"/>
+            <a:ext cx="475488" cy="475488"/>
           </a:xfrm>
           <a:prstGeom prst="ellipse">
             <a:avLst/>
@@ -8912,7 +11139,7 @@
       </p:sp>
       <p:pic>
         <p:nvPicPr>
-          <p:cNvPr id="12" name="Inquiries icon" descr="Inquiries">    </p:cNvPr>
+          <p:cNvPr id="16" name="Target 3 icon" descr="Target 3">    </p:cNvPr>
           <p:cNvPicPr>
             <a:picLocks noChangeAspect="1"/>
           </p:cNvPicPr>
@@ -8926,8 +11153,8 @@
         </p:blipFill>
         <p:spPr>
           <a:xfrm>
-            <a:off x="2452421" y="1638605"/>
-            <a:ext cx="252374" cy="252374"/>
+            <a:off x="4974702" y="1609710"/>
+            <a:ext cx="218724" cy="218724"/>
           </a:xfrm>
           <a:prstGeom prst="rect">
             <a:avLst/>
@@ -8936,17 +11163,94 @@
       </p:pic>
       <p:sp>
         <p:nvSpPr>
-          <p:cNvPr id="13" name="Increase 2 circle"/>
+          <p:cNvPr id="17" name="Target value 3"/>
+          <p:cNvSpPr txBox="1"/>
+          <p:nvPr/>
+        </p:nvSpPr>
+        <p:spPr>
+          <a:xfrm>
+            <a:off x="4846320" y="2057400"/>
+            <a:ext cx="1600200" cy="548640"/>
+          </a:xfrm>
+          <a:prstGeom prst="rect">
+            <a:avLst/>
+          </a:prstGeom>
+          <a:noFill/>
+          <a:ln/>
+        </p:spPr>
+        <p:txBody>
+          <a:bodyPr wrap="square" lIns="0" tIns="0" rIns="0" bIns="0" rtlCol="0" anchor="ctr"/>
+          <a:lstStyle/>
+          <a:p>
+            <a:pPr indent="0" marL="0">
+              <a:buNone/>
+            </a:pPr>
+            <a:r>
+              <a:rPr lang="en-US" sz="3400" b="1" dirty="0">
+                <a:solidFill>
+                  <a:schemeClr val="accent1"/>
+                </a:solidFill>
+                <a:latin typeface="Cambria" pitchFamily="34" charset="0"/>
+                <a:ea typeface="Cambria" pitchFamily="34" charset="-122"/>
+                <a:cs typeface="Cambria" pitchFamily="34" charset="-120"/>
+              </a:rPr>
+              <a:t>100+</a:t>
+            </a:r>
+            <a:endParaRPr lang="en-US" sz="3400" dirty="0"/>
+          </a:p>
+        </p:txBody>
+      </p:sp>
+      <p:sp>
+        <p:nvSpPr>
+          <p:cNvPr id="18" name="Target label 3"/>
+          <p:cNvSpPr txBox="1"/>
+          <p:nvPr/>
+        </p:nvSpPr>
+        <p:spPr>
+          <a:xfrm>
+            <a:off x="4846320" y="2633472"/>
+            <a:ext cx="1600200" cy="502920"/>
+          </a:xfrm>
+          <a:prstGeom prst="rect">
+            <a:avLst/>
+          </a:prstGeom>
+          <a:noFill/>
+          <a:ln/>
+        </p:spPr>
+        <p:txBody>
+          <a:bodyPr wrap="square" lIns="0" tIns="0" rIns="0" bIns="0" rtlCol="0" anchor="t"/>
+          <a:lstStyle/>
+          <a:p>
+            <a:pPr indent="0" marL="0">
+              <a:buNone/>
+            </a:pPr>
+            <a:r>
+              <a:rPr lang="en-US" sz="1200" dirty="0">
+                <a:solidFill>
+                  <a:schemeClr val="tx2"/>
+                </a:solidFill>
+              </a:rPr>
+              <a:t>messages, calls and direction requests</a:t>
+            </a:r>
+            <a:endParaRPr lang="en-US" sz="1200" dirty="0"/>
+          </a:p>
+        </p:txBody>
+      </p:sp>
+      <p:sp>
+        <p:nvSpPr>
+          <p:cNvPr id="19" name="Target card 4"/>
           <p:cNvSpPr/>
           <p:nvPr/>
         </p:nvSpPr>
         <p:spPr>
           <a:xfrm>
-            <a:off x="3108960" y="1536192"/>
-            <a:ext cx="384048" cy="384048"/>
-          </a:xfrm>
-          <a:prstGeom prst="ellipse">
-            <a:avLst/>
+            <a:off x="6766560" y="1325880"/>
+            <a:ext cx="1920240" cy="1874520"/>
+          </a:xfrm>
+          <a:prstGeom prst="roundRect">
+            <a:avLst>
+              <a:gd name="adj" fmla="val 5854"/>
+            </a:avLst>
           </a:prstGeom>
           <a:solidFill>
             <a:schemeClr val="accent4"/>
@@ -8954,9 +11258,29 @@
           <a:ln/>
         </p:spPr>
       </p:sp>
+      <p:sp>
+        <p:nvSpPr>
+          <p:cNvPr id="20" name="Target 4 circle"/>
+          <p:cNvSpPr/>
+          <p:nvPr/>
+        </p:nvSpPr>
+        <p:spPr>
+          <a:xfrm>
+            <a:off x="6949440" y="1481328"/>
+            <a:ext cx="475488" cy="475488"/>
+          </a:xfrm>
+          <a:prstGeom prst="ellipse">
+            <a:avLst/>
+          </a:prstGeom>
+          <a:solidFill>
+            <a:schemeClr val="bg1"/>
+          </a:solidFill>
+          <a:ln/>
+        </p:spPr>
+      </p:sp>
       <p:pic>
         <p:nvPicPr>
-          <p:cNvPr id="14" name="Increase 2 icon" descr="Increase 2">    </p:cNvPr>
+          <p:cNvPr id="21" name="Target 4 icon" descr="Target 4">    </p:cNvPr>
           <p:cNvPicPr>
             <a:picLocks noChangeAspect="1"/>
           </p:cNvPicPr>
@@ -8970,8 +11294,8 @@
         </p:blipFill>
         <p:spPr>
           <a:xfrm>
-            <a:off x="3212653" y="1639885"/>
-            <a:ext cx="176662" cy="176662"/>
+            <a:off x="7077822" y="1609710"/>
+            <a:ext cx="218724" cy="218724"/>
           </a:xfrm>
           <a:prstGeom prst="rect">
             <a:avLst/>
@@ -8980,14 +11304,53 @@
       </p:pic>
       <p:sp>
         <p:nvSpPr>
-          <p:cNvPr id="15" name="Result text 2"/>
+          <p:cNvPr id="22" name="Target value 4"/>
           <p:cNvSpPr txBox="1"/>
           <p:nvPr/>
         </p:nvSpPr>
         <p:spPr>
           <a:xfrm>
-            <a:off x="2304288" y="2194560"/>
-            <a:ext cx="1280160" cy="868680"/>
+            <a:off x="6949440" y="2057400"/>
+            <a:ext cx="1600200" cy="548640"/>
+          </a:xfrm>
+          <a:prstGeom prst="rect">
+            <a:avLst/>
+          </a:prstGeom>
+          <a:noFill/>
+          <a:ln/>
+        </p:spPr>
+        <p:txBody>
+          <a:bodyPr wrap="square" lIns="0" tIns="0" rIns="0" bIns="0" rtlCol="0" anchor="ctr"/>
+          <a:lstStyle/>
+          <a:p>
+            <a:pPr indent="0" marL="0">
+              <a:buNone/>
+            </a:pPr>
+            <a:r>
+              <a:rPr lang="en-US" sz="3400" b="1" dirty="0">
+                <a:solidFill>
+                  <a:schemeClr val="bg1"/>
+                </a:solidFill>
+                <a:latin typeface="Cambria" pitchFamily="34" charset="0"/>
+                <a:ea typeface="Cambria" pitchFamily="34" charset="-122"/>
+                <a:cs typeface="Cambria" pitchFamily="34" charset="-120"/>
+              </a:rPr>
+              <a:t>+10</a:t>
+            </a:r>
+            <a:endParaRPr lang="en-US" sz="3400" dirty="0"/>
+          </a:p>
+        </p:txBody>
+      </p:sp>
+      <p:sp>
+        <p:nvSpPr>
+          <p:cNvPr id="23" name="Target label 4"/>
+          <p:cNvSpPr txBox="1"/>
+          <p:nvPr/>
+        </p:nvSpPr>
+        <p:spPr>
+          <a:xfrm>
+            <a:off x="6949440" y="2633472"/>
+            <a:ext cx="1600200" cy="502920"/>
           </a:xfrm>
           <a:prstGeom prst="rect">
             <a:avLst/>
@@ -9003,66 +11366,32 @@
               <a:buNone/>
             </a:pPr>
             <a:r>
-              <a:rPr lang="en-US" sz="1500" b="1" dirty="0">
-                <a:solidFill>
-                  <a:schemeClr val="tx2"/>
-                </a:solidFill>
-              </a:rPr>
-              <a:t>More inquiries</a:t>
-            </a:r>
-            <a:endParaRPr lang="en-US" sz="1500" dirty="0"/>
-          </a:p>
-          <a:p>
-            <a:pPr indent="0" marL="0">
-              <a:buNone/>
-            </a:pPr>
-            <a:r>
               <a:rPr lang="en-US" sz="1200" dirty="0">
                 <a:solidFill>
-                  <a:schemeClr val="tx1"/>
-                </a:solidFill>
-              </a:rPr>
-              <a:t>from customers</a:t>
-            </a:r>
-            <a:endParaRPr lang="en-US" sz="1500" dirty="0"/>
-          </a:p>
-        </p:txBody>
-      </p:sp>
-      <p:sp>
-        <p:nvSpPr>
-          <p:cNvPr id="16" name="Result card 3"/>
+                  <a:schemeClr val="bg1"/>
+                </a:solidFill>
+              </a:rPr>
+              <a:t>extra customers every day</a:t>
+            </a:r>
+            <a:endParaRPr lang="en-US" sz="1200" dirty="0"/>
+          </a:p>
+        </p:txBody>
+      </p:sp>
+      <p:sp>
+        <p:nvSpPr>
+          <p:cNvPr id="24" name="Report box"/>
           <p:cNvSpPr/>
           <p:nvPr/>
         </p:nvSpPr>
         <p:spPr>
           <a:xfrm>
-            <a:off x="3822192" y="1325880"/>
-            <a:ext cx="1517904" cy="1828800"/>
+            <a:off x="457200" y="3383280"/>
+            <a:ext cx="8229600" cy="868680"/>
           </a:xfrm>
           <a:prstGeom prst="roundRect">
             <a:avLst>
-              <a:gd name="adj" fmla="val 7229"/>
+              <a:gd name="adj" fmla="val 12632"/>
             </a:avLst>
-          </a:prstGeom>
-          <a:solidFill>
-            <a:schemeClr val="bg2"/>
-          </a:solidFill>
-          <a:ln/>
-        </p:spPr>
-      </p:sp>
-      <p:sp>
-        <p:nvSpPr>
-          <p:cNvPr id="17" name="Awareness circle"/>
-          <p:cNvSpPr/>
-          <p:nvPr/>
-        </p:nvSpPr>
-        <p:spPr>
-          <a:xfrm>
-            <a:off x="3986784" y="1490472"/>
-            <a:ext cx="548640" cy="548640"/>
-          </a:xfrm>
-          <a:prstGeom prst="ellipse">
-            <a:avLst/>
           </a:prstGeom>
           <a:solidFill>
             <a:schemeClr val="tx2"/>
@@ -9070,9 +11399,29 @@
           <a:ln/>
         </p:spPr>
       </p:sp>
+      <p:sp>
+        <p:nvSpPr>
+          <p:cNvPr id="25" name="Weekly report circle"/>
+          <p:cNvSpPr/>
+          <p:nvPr/>
+        </p:nvSpPr>
+        <p:spPr>
+          <a:xfrm>
+            <a:off x="685800" y="3538728"/>
+            <a:ext cx="548640" cy="548640"/>
+          </a:xfrm>
+          <a:prstGeom prst="ellipse">
+            <a:avLst/>
+          </a:prstGeom>
+          <a:solidFill>
+            <a:schemeClr val="accent4"/>
+          </a:solidFill>
+          <a:ln/>
+        </p:spPr>
+      </p:sp>
       <p:pic>
         <p:nvPicPr>
-          <p:cNvPr id="18" name="Awareness icon" descr="Awareness">    </p:cNvPr>
+          <p:cNvPr id="26" name="Weekly report icon" descr="Weekly report">    </p:cNvPr>
           <p:cNvPicPr>
             <a:picLocks noChangeAspect="1"/>
           </p:cNvPicPr>
@@ -9086,7 +11435,7 @@
         </p:blipFill>
         <p:spPr>
           <a:xfrm>
-            <a:off x="4134917" y="1638605"/>
+            <a:off x="833933" y="3686861"/>
             <a:ext cx="252374" cy="252374"/>
           </a:xfrm>
           <a:prstGeom prst="rect">
@@ -9096,531 +11445,87 @@
       </p:pic>
       <p:sp>
         <p:nvSpPr>
-          <p:cNvPr id="19" name="Increase 3 circle"/>
-          <p:cNvSpPr/>
-          <p:nvPr/>
-        </p:nvSpPr>
-        <p:spPr>
-          <a:xfrm>
-            <a:off x="4791456" y="1536192"/>
-            <a:ext cx="384048" cy="384048"/>
-          </a:xfrm>
-          <a:prstGeom prst="ellipse">
-            <a:avLst/>
-          </a:prstGeom>
-          <a:solidFill>
-            <a:schemeClr val="accent4"/>
-          </a:solidFill>
-          <a:ln/>
-        </p:spPr>
-      </p:sp>
-      <p:pic>
-        <p:nvPicPr>
-          <p:cNvPr id="20" name="Increase 3 icon" descr="Increase 3">    </p:cNvPr>
-          <p:cNvPicPr>
-            <a:picLocks noChangeAspect="1"/>
-          </p:cNvPicPr>
-          <p:nvPr/>
-        </p:nvPicPr>
-        <p:blipFill>
-          <a:blip r:embed="rId6"/>
-          <a:stretch>
-            <a:fillRect/>
-          </a:stretch>
-        </p:blipFill>
-        <p:spPr>
-          <a:xfrm>
-            <a:off x="4895149" y="1639885"/>
-            <a:ext cx="176662" cy="176662"/>
-          </a:xfrm>
-          <a:prstGeom prst="rect">
-            <a:avLst/>
-          </a:prstGeom>
-        </p:spPr>
-      </p:pic>
-      <p:sp>
-        <p:nvSpPr>
-          <p:cNvPr id="21" name="Result text 3"/>
+          <p:cNvPr id="27" name="Report text"/>
           <p:cNvSpPr txBox="1"/>
           <p:nvPr/>
         </p:nvSpPr>
         <p:spPr>
           <a:xfrm>
-            <a:off x="3986784" y="2194560"/>
-            <a:ext cx="1280160" cy="868680"/>
-          </a:xfrm>
-          <a:prstGeom prst="rect">
-            <a:avLst/>
-          </a:prstGeom>
-          <a:noFill/>
-          <a:ln/>
-        </p:spPr>
-        <p:txBody>
-          <a:bodyPr wrap="square" lIns="0" tIns="0" rIns="0" bIns="0" rtlCol="0" anchor="t"/>
+            <a:off x="1463040" y="3383280"/>
+            <a:ext cx="7040880" cy="868680"/>
+          </a:xfrm>
+          <a:prstGeom prst="rect">
+            <a:avLst/>
+          </a:prstGeom>
+          <a:noFill/>
+          <a:ln/>
+        </p:spPr>
+        <p:txBody>
+          <a:bodyPr wrap="square" lIns="0" tIns="0" rIns="0" bIns="0" rtlCol="0" anchor="ctr"/>
           <a:lstStyle/>
           <a:p>
             <a:pPr indent="0" marL="0">
               <a:buNone/>
             </a:pPr>
             <a:r>
-              <a:rPr lang="en-US" sz="1500" b="1" dirty="0">
-                <a:solidFill>
-                  <a:schemeClr val="tx2"/>
-                </a:solidFill>
-              </a:rPr>
-              <a:t>More awareness</a:t>
-            </a:r>
-            <a:endParaRPr lang="en-US" sz="1500" dirty="0"/>
+              <a:rPr lang="en-US" sz="1700" b="1" dirty="0">
+                <a:solidFill>
+                  <a:schemeClr val="bg1"/>
+                </a:solidFill>
+              </a:rPr>
+              <a:t>You see every number, every week</a:t>
+            </a:r>
+            <a:endParaRPr lang="en-US" sz="1700" dirty="0"/>
           </a:p>
           <a:p>
             <a:pPr indent="0" marL="0">
               <a:buNone/>
             </a:pPr>
             <a:r>
-              <a:rPr lang="en-US" sz="1200" dirty="0">
-                <a:solidFill>
-                  <a:schemeClr val="tx1"/>
-                </a:solidFill>
-              </a:rPr>
-              <a:t>of the café</a:t>
-            </a:r>
-            <a:endParaRPr lang="en-US" sz="1500" dirty="0"/>
-          </a:p>
-        </p:txBody>
-      </p:sp>
-      <p:sp>
-        <p:nvSpPr>
-          <p:cNvPr id="22" name="Result card 4"/>
-          <p:cNvSpPr/>
-          <p:nvPr/>
-        </p:nvSpPr>
-        <p:spPr>
-          <a:xfrm>
-            <a:off x="5504688" y="1325880"/>
-            <a:ext cx="1517904" cy="1828800"/>
-          </a:xfrm>
-          <a:prstGeom prst="roundRect">
-            <a:avLst>
-              <a:gd name="adj" fmla="val 7229"/>
-            </a:avLst>
-          </a:prstGeom>
-          <a:solidFill>
-            <a:schemeClr val="bg2"/>
-          </a:solidFill>
-          <a:ln/>
-        </p:spPr>
-      </p:sp>
-      <p:sp>
-        <p:nvSpPr>
-          <p:cNvPr id="23" name="Visits circle"/>
-          <p:cNvSpPr/>
-          <p:nvPr/>
-        </p:nvSpPr>
-        <p:spPr>
-          <a:xfrm>
-            <a:off x="5669280" y="1490472"/>
-            <a:ext cx="548640" cy="548640"/>
-          </a:xfrm>
-          <a:prstGeom prst="ellipse">
-            <a:avLst/>
-          </a:prstGeom>
-          <a:solidFill>
-            <a:schemeClr val="tx2"/>
-          </a:solidFill>
-          <a:ln/>
-        </p:spPr>
-      </p:sp>
-      <p:pic>
-        <p:nvPicPr>
-          <p:cNvPr id="24" name="Visits icon" descr="Visits">    </p:cNvPr>
-          <p:cNvPicPr>
-            <a:picLocks noChangeAspect="1"/>
-          </p:cNvPicPr>
-          <p:nvPr/>
-        </p:nvPicPr>
-        <p:blipFill>
-          <a:blip r:embed="rId7"/>
-          <a:stretch>
-            <a:fillRect/>
-          </a:stretch>
-        </p:blipFill>
-        <p:spPr>
-          <a:xfrm>
-            <a:off x="5817413" y="1638605"/>
-            <a:ext cx="252374" cy="252374"/>
-          </a:xfrm>
-          <a:prstGeom prst="rect">
-            <a:avLst/>
-          </a:prstGeom>
-        </p:spPr>
-      </p:pic>
-      <p:sp>
-        <p:nvSpPr>
-          <p:cNvPr id="25" name="Increase 4 circle"/>
-          <p:cNvSpPr/>
-          <p:nvPr/>
-        </p:nvSpPr>
-        <p:spPr>
-          <a:xfrm>
-            <a:off x="6473952" y="1536192"/>
-            <a:ext cx="384048" cy="384048"/>
-          </a:xfrm>
-          <a:prstGeom prst="ellipse">
-            <a:avLst/>
-          </a:prstGeom>
-          <a:solidFill>
-            <a:schemeClr val="accent4"/>
-          </a:solidFill>
-          <a:ln/>
-        </p:spPr>
-      </p:sp>
-      <p:pic>
-        <p:nvPicPr>
-          <p:cNvPr id="26" name="Increase 4 icon" descr="Increase 4">    </p:cNvPr>
-          <p:cNvPicPr>
-            <a:picLocks noChangeAspect="1"/>
-          </p:cNvPicPr>
-          <p:nvPr/>
-        </p:nvPicPr>
-        <p:blipFill>
-          <a:blip r:embed="rId8"/>
-          <a:stretch>
-            <a:fillRect/>
-          </a:stretch>
-        </p:blipFill>
-        <p:spPr>
-          <a:xfrm>
-            <a:off x="6577645" y="1639885"/>
-            <a:ext cx="176662" cy="176662"/>
-          </a:xfrm>
-          <a:prstGeom prst="rect">
-            <a:avLst/>
-          </a:prstGeom>
-        </p:spPr>
-      </p:pic>
-      <p:sp>
-        <p:nvSpPr>
-          <p:cNvPr id="27" name="Result text 4"/>
+              <a:rPr lang="en-US" sz="1300" dirty="0">
+                <a:solidFill>
+                  <a:schemeClr val="accent2"/>
+                </a:solidFill>
+              </a:rPr>
+              <a:t>A simple weekly report: reach, followers, messages, visits and sales</a:t>
+            </a:r>
+            <a:endParaRPr lang="en-US" sz="1700" dirty="0"/>
+          </a:p>
+        </p:txBody>
+      </p:sp>
+      <p:sp>
+        <p:nvSpPr>
+          <p:cNvPr id="28" name="Targets footnote"/>
           <p:cNvSpPr txBox="1"/>
           <p:nvPr/>
         </p:nvSpPr>
         <p:spPr>
           <a:xfrm>
-            <a:off x="5669280" y="2194560"/>
-            <a:ext cx="1280160" cy="868680"/>
-          </a:xfrm>
-          <a:prstGeom prst="rect">
-            <a:avLst/>
-          </a:prstGeom>
-          <a:noFill/>
-          <a:ln/>
-        </p:spPr>
-        <p:txBody>
-          <a:bodyPr wrap="square" lIns="0" tIns="0" rIns="0" bIns="0" rtlCol="0" anchor="t"/>
+            <a:off x="457200" y="4343400"/>
+            <a:ext cx="8229600" cy="274320"/>
+          </a:xfrm>
+          <a:prstGeom prst="rect">
+            <a:avLst/>
+          </a:prstGeom>
+          <a:noFill/>
+          <a:ln/>
+        </p:spPr>
+        <p:txBody>
+          <a:bodyPr wrap="square" lIns="0" tIns="0" rIns="0" bIns="0" rtlCol="0" anchor="ctr"/>
           <a:lstStyle/>
           <a:p>
             <a:pPr indent="0" marL="0">
               <a:buNone/>
             </a:pPr>
             <a:r>
-              <a:rPr lang="en-US" sz="1500" b="1" dirty="0">
-                <a:solidFill>
-                  <a:schemeClr val="tx2"/>
-                </a:solidFill>
-              </a:rPr>
-              <a:t>More visits</a:t>
-            </a:r>
-            <a:endParaRPr lang="en-US" sz="1500" dirty="0"/>
-          </a:p>
-          <a:p>
-            <a:pPr indent="0" marL="0">
-              <a:buNone/>
-            </a:pPr>
-            <a:r>
-              <a:rPr lang="en-US" sz="1200" dirty="0">
-                <a:solidFill>
-                  <a:schemeClr val="tx1"/>
-                </a:solidFill>
-              </a:rPr>
-              <a:t>from new customers</a:t>
-            </a:r>
-            <a:endParaRPr lang="en-US" sz="1500" dirty="0"/>
-          </a:p>
-        </p:txBody>
-      </p:sp>
-      <p:sp>
-        <p:nvSpPr>
-          <p:cNvPr id="28" name="Result card 5"/>
-          <p:cNvSpPr/>
-          <p:nvPr/>
-        </p:nvSpPr>
-        <p:spPr>
-          <a:xfrm>
-            <a:off x="7187184" y="1325880"/>
-            <a:ext cx="1517904" cy="1828800"/>
-          </a:xfrm>
-          <a:prstGeom prst="roundRect">
-            <a:avLst>
-              <a:gd name="adj" fmla="val 7229"/>
-            </a:avLst>
-          </a:prstGeom>
-          <a:solidFill>
-            <a:schemeClr val="bg2"/>
-          </a:solidFill>
-          <a:ln/>
-        </p:spPr>
-      </p:sp>
-      <p:sp>
-        <p:nvSpPr>
-          <p:cNvPr id="29" name="Sales circle"/>
-          <p:cNvSpPr/>
-          <p:nvPr/>
-        </p:nvSpPr>
-        <p:spPr>
-          <a:xfrm>
-            <a:off x="7351776" y="1490472"/>
-            <a:ext cx="548640" cy="548640"/>
-          </a:xfrm>
-          <a:prstGeom prst="ellipse">
-            <a:avLst/>
-          </a:prstGeom>
-          <a:solidFill>
-            <a:schemeClr val="tx2"/>
-          </a:solidFill>
-          <a:ln/>
-        </p:spPr>
-      </p:sp>
-      <p:pic>
-        <p:nvPicPr>
-          <p:cNvPr id="30" name="Sales icon" descr="Sales">    </p:cNvPr>
-          <p:cNvPicPr>
-            <a:picLocks noChangeAspect="1"/>
-          </p:cNvPicPr>
-          <p:nvPr/>
-        </p:nvPicPr>
-        <p:blipFill>
-          <a:blip r:embed="rId9"/>
-          <a:stretch>
-            <a:fillRect/>
-          </a:stretch>
-        </p:blipFill>
-        <p:spPr>
-          <a:xfrm>
-            <a:off x="7499909" y="1638605"/>
-            <a:ext cx="252374" cy="252374"/>
-          </a:xfrm>
-          <a:prstGeom prst="rect">
-            <a:avLst/>
-          </a:prstGeom>
-        </p:spPr>
-      </p:pic>
-      <p:sp>
-        <p:nvSpPr>
-          <p:cNvPr id="31" name="Increase 5 circle"/>
-          <p:cNvSpPr/>
-          <p:nvPr/>
-        </p:nvSpPr>
-        <p:spPr>
-          <a:xfrm>
-            <a:off x="8156448" y="1536192"/>
-            <a:ext cx="384048" cy="384048"/>
-          </a:xfrm>
-          <a:prstGeom prst="ellipse">
-            <a:avLst/>
-          </a:prstGeom>
-          <a:solidFill>
-            <a:schemeClr val="accent4"/>
-          </a:solidFill>
-          <a:ln/>
-        </p:spPr>
-      </p:sp>
-      <p:pic>
-        <p:nvPicPr>
-          <p:cNvPr id="32" name="Increase 5 icon" descr="Increase 5">    </p:cNvPr>
-          <p:cNvPicPr>
-            <a:picLocks noChangeAspect="1"/>
-          </p:cNvPicPr>
-          <p:nvPr/>
-        </p:nvPicPr>
-        <p:blipFill>
-          <a:blip r:embed="rId10"/>
-          <a:stretch>
-            <a:fillRect/>
-          </a:stretch>
-        </p:blipFill>
-        <p:spPr>
-          <a:xfrm>
-            <a:off x="8260141" y="1639885"/>
-            <a:ext cx="176662" cy="176662"/>
-          </a:xfrm>
-          <a:prstGeom prst="rect">
-            <a:avLst/>
-          </a:prstGeom>
-        </p:spPr>
-      </p:pic>
-      <p:sp>
-        <p:nvSpPr>
-          <p:cNvPr id="33" name="Result text 5"/>
-          <p:cNvSpPr txBox="1"/>
-          <p:nvPr/>
-        </p:nvSpPr>
-        <p:spPr>
-          <a:xfrm>
-            <a:off x="7351776" y="2194560"/>
-            <a:ext cx="1280160" cy="868680"/>
-          </a:xfrm>
-          <a:prstGeom prst="rect">
-            <a:avLst/>
-          </a:prstGeom>
-          <a:noFill/>
-          <a:ln/>
-        </p:spPr>
-        <p:txBody>
-          <a:bodyPr wrap="square" lIns="0" tIns="0" rIns="0" bIns="0" rtlCol="0" anchor="t"/>
-          <a:lstStyle/>
-          <a:p>
-            <a:pPr indent="0" marL="0">
-              <a:buNone/>
-            </a:pPr>
-            <a:r>
-              <a:rPr lang="en-US" sz="1500" b="1" dirty="0">
-                <a:solidFill>
-                  <a:schemeClr val="tx2"/>
-                </a:solidFill>
-              </a:rPr>
-              <a:t>More sales</a:t>
-            </a:r>
-            <a:endParaRPr lang="en-US" sz="1500" dirty="0"/>
-          </a:p>
-          <a:p>
-            <a:pPr indent="0" marL="0">
-              <a:buNone/>
-            </a:pPr>
-            <a:r>
-              <a:rPr lang="en-US" sz="1200" dirty="0">
-                <a:solidFill>
-                  <a:schemeClr val="tx1"/>
-                </a:solidFill>
-              </a:rPr>
-              <a:t>performance</a:t>
-            </a:r>
-            <a:endParaRPr lang="en-US" sz="1500" dirty="0"/>
-          </a:p>
-        </p:txBody>
-      </p:sp>
-      <p:sp>
-        <p:nvSpPr>
-          <p:cNvPr id="34" name="Tracking box"/>
-          <p:cNvSpPr/>
-          <p:nvPr/>
-        </p:nvSpPr>
-        <p:spPr>
-          <a:xfrm>
-            <a:off x="457200" y="3429000"/>
-            <a:ext cx="8229600" cy="1097280"/>
-          </a:xfrm>
-          <a:prstGeom prst="roundRect">
-            <a:avLst>
-              <a:gd name="adj" fmla="val 10000"/>
-            </a:avLst>
-          </a:prstGeom>
-          <a:solidFill>
-            <a:schemeClr val="tx2"/>
-          </a:solidFill>
-          <a:ln/>
-        </p:spPr>
-      </p:sp>
-      <p:sp>
-        <p:nvSpPr>
-          <p:cNvPr id="35" name="Tracking circle"/>
-          <p:cNvSpPr/>
-          <p:nvPr/>
-        </p:nvSpPr>
-        <p:spPr>
-          <a:xfrm>
-            <a:off x="731520" y="3657600"/>
-            <a:ext cx="640080" cy="640080"/>
-          </a:xfrm>
-          <a:prstGeom prst="ellipse">
-            <a:avLst/>
-          </a:prstGeom>
-          <a:solidFill>
-            <a:schemeClr val="accent4"/>
-          </a:solidFill>
-          <a:ln/>
-        </p:spPr>
-      </p:sp>
-      <p:pic>
-        <p:nvPicPr>
-          <p:cNvPr id="36" name="Tracking icon" descr="Tracking">    </p:cNvPr>
-          <p:cNvPicPr>
-            <a:picLocks noChangeAspect="1"/>
-          </p:cNvPicPr>
-          <p:nvPr/>
-        </p:nvPicPr>
-        <p:blipFill>
-          <a:blip r:embed="rId11"/>
-          <a:stretch>
-            <a:fillRect/>
-          </a:stretch>
-        </p:blipFill>
-        <p:spPr>
-          <a:xfrm>
-            <a:off x="904342" y="3830422"/>
-            <a:ext cx="294437" cy="294437"/>
-          </a:xfrm>
-          <a:prstGeom prst="rect">
-            <a:avLst/>
-          </a:prstGeom>
-        </p:spPr>
-      </p:pic>
-      <p:sp>
-        <p:nvSpPr>
-          <p:cNvPr id="37" name="Tracking text"/>
-          <p:cNvSpPr txBox="1"/>
-          <p:nvPr/>
-        </p:nvSpPr>
-        <p:spPr>
-          <a:xfrm>
-            <a:off x="1600200" y="3429000"/>
-            <a:ext cx="6858000" cy="1097280"/>
-          </a:xfrm>
-          <a:prstGeom prst="rect">
-            <a:avLst/>
-          </a:prstGeom>
-          <a:noFill/>
-          <a:ln/>
-        </p:spPr>
-        <p:txBody>
-          <a:bodyPr wrap="square" lIns="0" tIns="0" rIns="0" bIns="0" rtlCol="0" anchor="ctr"/>
-          <a:lstStyle/>
-          <a:p>
-            <a:pPr indent="0" marL="0">
-              <a:buNone/>
-            </a:pPr>
-            <a:r>
-              <a:rPr lang="en-US" sz="1800" b="1" dirty="0">
-                <a:solidFill>
-                  <a:schemeClr val="bg1"/>
-                </a:solidFill>
-              </a:rPr>
-              <a:t>We track the results</a:t>
-            </a:r>
-            <a:endParaRPr lang="en-US" sz="1800" dirty="0"/>
-          </a:p>
-          <a:p>
-            <a:pPr indent="0" marL="0">
-              <a:buNone/>
-            </a:pPr>
-            <a:r>
-              <a:rPr lang="en-US" sz="1400" dirty="0">
-                <a:solidFill>
-                  <a:schemeClr val="accent2"/>
-                </a:solidFill>
-              </a:rPr>
-              <a:t>to understand what works best</a:t>
-            </a:r>
-            <a:endParaRPr lang="en-US" sz="1800" dirty="0"/>
+              <a:rPr lang="en-US" sz="1000" dirty="0">
+                <a:solidFill>
+                  <a:schemeClr val="accent5"/>
+                </a:solidFill>
+              </a:rPr>
+              <a:t>Targets are based on a 4,000 EGP monthly ad budget and are confirmed after the week-1 review.</a:t>
+            </a:r>
+            <a:endParaRPr lang="en-US" sz="1000" dirty="0"/>
           </a:p>
         </p:txBody>
       </p:sp>

</xml_diff>

<commit_message>
Rename agency to Pulse Marketing in café proposal
Co-Authored-By: Claude Opus 5.5 <noreply@anthropic.com>
Claude-Session: https://claude.ai/code/session_01FBuHsgfNN7NePtiYw7LpVx
</commit_message>
<xml_diff>
--- a/Cafe_Marketing_Proposal.pptx
+++ b/Cafe_Marketing_Proposal.pptx
@@ -119,30 +119,30 @@
   <p:extLst>
     <p:ext uri="{521415D9-36F7-43E2-AB2F-B90AF26B5E84}">
       <p14:sectionLst xmlns:p14="http://schemas.microsoft.com/office/powerpoint/2010/main">
-        <p14:section name="Introduction" id="{5bdd043f-870c-001b-56d1-4f9a39e0baaa}">
+        <p14:section name="Introduction" id="{33733bff-e9df-b0c2-3dc2-4376b8d3825b}">
           <p14:sldIdLst>
             <p14:sldId id="256"/>
             <p14:sldId id="257"/>
           </p14:sldIdLst>
         </p14:section>
-        <p14:section name="Problem" id="{057a16e2-1dc4-0da3-83e4-3b2bf742f064}">
+        <p14:section name="Problem" id="{92c6a357-9071-3fab-a54b-7fa77c1daa9e}">
           <p14:sldIdLst>
             <p14:sldId id="258"/>
           </p14:sldIdLst>
         </p14:section>
-        <p14:section name="Solution" id="{8df52afd-9d71-7ab7-b465-7a541c8ca3f4}">
+        <p14:section name="Solution" id="{579ec1d9-eeec-67e5-85e3-53d1b045bee1}">
           <p14:sldIdLst>
             <p14:sldId id="259"/>
             <p14:sldId id="260"/>
           </p14:sldIdLst>
         </p14:section>
-        <p14:section name="Budget and Timeline" id="{2856a4ab-21f2-bd0d-858c-a26653fdd40c}">
+        <p14:section name="Budget and Timeline" id="{1aaccea8-3f76-2192-f254-b5ce94dde054}">
           <p14:sldIdLst>
             <p14:sldId id="261"/>
             <p14:sldId id="262"/>
           </p14:sldIdLst>
         </p14:section>
-        <p14:section name="Results" id="{313db6e8-18c3-467d-971e-c40fbfb32d21}">
+        <p14:section name="Results" id="{2bf6baa4-62cb-c82a-1b23-212b4545c333}">
           <p14:sldIdLst>
             <p14:sldId id="263"/>
             <p14:sldId id="264"/>
@@ -150,12 +150,12 @@
             <p14:sldId id="266"/>
           </p14:sldIdLst>
         </p14:section>
-        <p14:section name="Why Us" id="{5037e329-baf9-e1bc-c8fa-db23593521ba}">
+        <p14:section name="Why Us" id="{66f9dc16-9b36-10ed-7ac9-95150426782c}">
           <p14:sldIdLst>
             <p14:sldId id="267"/>
           </p14:sldIdLst>
         </p14:section>
-        <p14:section name="Conclusion" id="{c088e8e0-617b-067e-7990-23dda1b90d8a}">
+        <p14:section name="Conclusion" id="{463fe7da-3c4c-fa5e-3a2b-8bd82a3fba89}">
           <p14:sldIdLst>
             <p14:sldId id="268"/>
           </p14:sldIdLst>
@@ -1134,7 +1134,7 @@
           <a:p>
             <a:r>
               <a:rPr lang="en-US" dirty="0"/>
-              <a:t>Introduce yourselves and BrandBrew Marketing.
+              <a:t>Introduce yourselves and Pulse Marketing.
 "Today we'll show you how we can help The Daily Cup reach more customers and grow its business."</a:t>
             </a:r>
             <a:endParaRPr lang="en-US" dirty="0"/>
@@ -2613,7 +2613,7 @@
                   <a:schemeClr val="accent5"/>
                 </a:solidFill>
               </a:rPr>
-              <a:t>BrandBrew Marketing  |  Digital Marketing Proposal for The Daily Cup</a:t>
+              <a:t>Pulse Marketing  |  Digital Marketing Proposal for The Daily Cup</a:t>
             </a:r>
             <a:endParaRPr lang="en-US" sz="1000" dirty="0"/>
           </a:p>
@@ -3045,7 +3045,7 @@
                   <a:schemeClr val="accent2"/>
                 </a:solidFill>
               </a:rPr>
-              <a:t>PRESENTED BY BRANDBREW MARKETING</a:t>
+              <a:t>PRESENTED BY PULSE MARKETING</a:t>
             </a:r>
             <a:endParaRPr lang="en-US" sz="1200" dirty="0"/>
           </a:p>
@@ -4484,7 +4484,7 @@
                 <a:ea typeface="Cambria" pitchFamily="34" charset="-122"/>
                 <a:cs typeface="Cambria" pitchFamily="34" charset="-120"/>
               </a:rPr>
-              <a:t>Why BrandBrew Marketing</a:t>
+              <a:t>Why Pulse Marketing</a:t>
             </a:r>
             <a:endParaRPr lang="en-US" sz="3200" dirty="0"/>
           </a:p>
@@ -5617,7 +5617,7 @@
                   <a:schemeClr val="accent2"/>
                 </a:solidFill>
               </a:rPr>
-              <a:t>BrandBrew Marketing   |   [Phone]   |   [Email]</a:t>
+              <a:t>Pulse Marketing   |   [Phone]   |   [Email]</a:t>
             </a:r>
             <a:endParaRPr lang="en-US" sz="1300" dirty="0"/>
           </a:p>

</xml_diff>

<commit_message>
Add team names to café proposal cover and presenter notes
Co-Authored-By: Claude Opus 5.5 <noreply@anthropic.com>
Claude-Session: https://claude.ai/code/session_01FBuHsgfNN7NePtiYw7LpVx
</commit_message>
<xml_diff>
--- a/Cafe_Marketing_Proposal.pptx
+++ b/Cafe_Marketing_Proposal.pptx
@@ -119,30 +119,30 @@
   <p:extLst>
     <p:ext uri="{521415D9-36F7-43E2-AB2F-B90AF26B5E84}">
       <p14:sectionLst xmlns:p14="http://schemas.microsoft.com/office/powerpoint/2010/main">
-        <p14:section name="Introduction" id="{33733bff-e9df-b0c2-3dc2-4376b8d3825b}">
+        <p14:section name="Introduction" id="{d7c1ff54-7a78-1b6c-608b-45865889dd00}">
           <p14:sldIdLst>
             <p14:sldId id="256"/>
             <p14:sldId id="257"/>
           </p14:sldIdLst>
         </p14:section>
-        <p14:section name="Problem" id="{92c6a357-9071-3fab-a54b-7fa77c1daa9e}">
+        <p14:section name="Problem" id="{ccc356aa-3ae6-09fe-fc72-29573b0b6dd6}">
           <p14:sldIdLst>
             <p14:sldId id="258"/>
           </p14:sldIdLst>
         </p14:section>
-        <p14:section name="Solution" id="{579ec1d9-eeec-67e5-85e3-53d1b045bee1}">
+        <p14:section name="Solution" id="{4f24179e-7ae3-5a27-8bfd-e3a8e41d4513}">
           <p14:sldIdLst>
             <p14:sldId id="259"/>
             <p14:sldId id="260"/>
           </p14:sldIdLst>
         </p14:section>
-        <p14:section name="Budget and Timeline" id="{1aaccea8-3f76-2192-f254-b5ce94dde054}">
+        <p14:section name="Budget and Timeline" id="{29df7fb2-5b0d-cd43-c034-d9512f563e2d}">
           <p14:sldIdLst>
             <p14:sldId id="261"/>
             <p14:sldId id="262"/>
           </p14:sldIdLst>
         </p14:section>
-        <p14:section name="Results" id="{2bf6baa4-62cb-c82a-1b23-212b4545c333}">
+        <p14:section name="Results" id="{14f31e6a-5b88-9126-9644-8c745f83252d}">
           <p14:sldIdLst>
             <p14:sldId id="263"/>
             <p14:sldId id="264"/>
@@ -150,12 +150,12 @@
             <p14:sldId id="266"/>
           </p14:sldIdLst>
         </p14:section>
-        <p14:section name="Why Us" id="{66f9dc16-9b36-10ed-7ac9-95150426782c}">
+        <p14:section name="Why Us" id="{be00e101-3fb4-d1af-33b7-aa2dacaaa3c0}">
           <p14:sldIdLst>
             <p14:sldId id="267"/>
           </p14:sldIdLst>
         </p14:section>
-        <p14:section name="Conclusion" id="{463fe7da-3c4c-fa5e-3a2b-8bd82a3fba89}">
+        <p14:section name="Conclusion" id="{3c4da55e-699d-63cd-d0b4-18c39f47c786}">
           <p14:sldIdLst>
             <p14:sldId id="268"/>
           </p14:sldIdLst>
@@ -1134,8 +1134,10 @@
           <a:p>
             <a:r>
               <a:rPr lang="en-US" dirty="0"/>
-              <a:t>Introduce yourselves and Pulse Marketing.
-"Today we'll show you how we can help The Daily Cup reach more customers and grow its business."</a:t>
+              <a:t>Presenter: Rahma Khaled
+"Good morning, and thank you for meeting us today. We are the team from Pulse Marketing, and our job is to keep your brand's pulse strong.
+My name is Rahma Khaled, and with me are Aya Reda, Mahmoud Ibrahim and Abader Zarif.
+Today we'll show you a simple plan to help The Daily Cup get more customers and more sales."</a:t>
             </a:r>
             <a:endParaRPr lang="en-US" dirty="0"/>
           </a:p>
@@ -1223,7 +1225,8 @@
           <a:p>
             <a:r>
               <a:rPr lang="en-US" dirty="0"/>
-              <a:t>This is the most important slide for the owner: the plan pays for itself.
+              <a:t>Presenter: Mahmoud Ibrahim
+This is the most important slide for the owner: the plan pays for itself.
 - Each customer spends about 150 EGP. After ingredients, the café keeps about 100 EGP.
 - 13,000 EGP divided by 100 EGP = 130 customers a month, which is less than 5 extra customers a day.
 - Our target is 10 extra customers a day: 10 × 30 days × 100 EGP = about 30,000 EGP extra profit per month, more than double the cost.
@@ -1315,7 +1318,8 @@
           <a:p>
             <a:r>
               <a:rPr lang="en-US" dirty="0"/>
-              <a:t>After the first month, we plan to:
+              <a:t>Presenter: Abader Zarif
+After the first month, we plan to:
 - Work with local food influencers.
 - Launch loyalty programs for regular customers.
 - Create seasonal offers.
@@ -1408,7 +1412,8 @@
           <a:p>
             <a:r>
               <a:rPr lang="en-US" dirty="0"/>
-              <a:t>Why the owner should choose us:
+              <a:t>Presenter: Abader Zarif
+Why the owner should choose us:
 - Café specialists: we focus on cafés and restaurants, so we know what brings people in.
 - Your own team: one dedicated account manager for The Daily Cup.
 - Weekly reports: the owner sees exactly what their money does.
@@ -1503,7 +1508,8 @@
           <a:p>
             <a:r>
               <a:rPr lang="en-US" dirty="0"/>
-              <a:t>Summary: The Daily Cup gets more visibility, more customers and more sales, and the plan pays for itself with less than 5 extra customers a day.
+              <a:t>Presenter: Abader Zarif
+Summary: The Daily Cup gets more visibility, more customers and more sales, and the plan pays for itself with less than 5 extra customers a day.
 Clear next steps (shown on the right):
 1. Approve the proposal today.
 2. We do a free audit of the café's pages in week 1.
@@ -1598,7 +1604,8 @@
           <a:p>
             <a:r>
               <a:rPr lang="en-US" dirty="0"/>
-              <a:t>Our marketing agency wants to help The Daily Cup grow its business.
+              <a:t>Presenter: Rahma Khaled
+Our marketing agency wants to help The Daily Cup grow its business.
 Our goals are to:
 - Increase brand awareness.
 - Attract more customers.
@@ -1692,7 +1699,8 @@
           <a:p>
             <a:r>
               <a:rPr lang="en-US" dirty="0"/>
-              <a:t>The café may face some challenges:
+              <a:t>Presenter: Rahma Khaled
+The café may face some challenges:
 - Low brand awareness.
 - Few followers and low engagement on social media.
 - Strong competition from other cafés.
@@ -1785,7 +1793,8 @@
           <a:p>
             <a:r>
               <a:rPr lang="en-US" dirty="0"/>
-              <a:t>Our agency offers four main services:
+              <a:t>Presenter: Aya Reda
+Our agency offers four main services:
 - Social Media Management: create regular posts, reels, and stories.
 - Paid Advertising: run Facebook and Instagram ads.
 - Content Creation: take attractive photos and videos of products.
@@ -1877,7 +1886,8 @@
           <a:p>
             <a:r>
               <a:rPr lang="en-US" dirty="0"/>
-              <a:t>We will follow five simple steps:
+              <a:t>Presenter: Aya Reda
+We will follow five simple steps:
 1. Research the market and competitors.
 2. Identify the target audience.
 3. Create a monthly content plan.
@@ -1970,7 +1980,8 @@
           <a:p>
             <a:r>
               <a:rPr lang="en-US" dirty="0"/>
-              <a:t>Monthly budget:
+              <a:t>Presenter: Aya Reda
+Monthly budget:
 - Social media management: 5,000 EGP
 - Paid advertising: 4,000 EGP
 - Content creation: 3,000 EGP
@@ -2064,7 +2075,8 @@
           <a:p>
             <a:r>
               <a:rPr lang="en-US" dirty="0"/>
-              <a:t>Week 1: Research and planning.
+              <a:t>Presenter: Mahmoud Ibrahim
+Week 1: Research and planning.
 Week 2: Content creation.
 Week 3: Launch marketing campaigns.
 Week 4: Measure results and improve.</a:t>
@@ -2155,7 +2167,8 @@
           <a:p>
             <a:r>
               <a:rPr lang="en-US" dirty="0"/>
-              <a:t>Working with our agency will help the café:
+              <a:t>Presenter: Mahmoud Ibrahim
+Working with our agency will help the café:
 - Reach more people.
 - Attract new customers.
 - Build a strong brand.
@@ -2248,7 +2261,8 @@
           <a:p>
             <a:r>
               <a:rPr lang="en-US" dirty="0"/>
-              <a:t>These are our targets for the first month:
+              <a:t>Presenter: Mahmoud Ibrahim
+These are our targets for the first month:
 - 40,000+ people in the area see The Daily Cup through ads and content.
 - 500+ new Instagram followers.
 - 100+ messages, calls and direction requests.
@@ -3130,9 +3144,189 @@
           </a:p>
         </p:txBody>
       </p:sp>
+      <p:sp>
+        <p:nvSpPr>
+          <p:cNvPr id="5" name="Team label"/>
+          <p:cNvSpPr txBox="1"/>
+          <p:nvPr/>
+        </p:nvSpPr>
+        <p:spPr>
+          <a:xfrm>
+            <a:off x="548640" y="3429000"/>
+            <a:ext cx="4389120" cy="274320"/>
+          </a:xfrm>
+          <a:prstGeom prst="rect">
+            <a:avLst/>
+          </a:prstGeom>
+          <a:noFill/>
+          <a:ln/>
+        </p:spPr>
+        <p:txBody>
+          <a:bodyPr wrap="square" lIns="0" tIns="0" rIns="0" bIns="0" rtlCol="0" anchor="ctr"/>
+          <a:lstStyle/>
+          <a:p>
+            <a:pPr indent="0" marL="0">
+              <a:buNone/>
+            </a:pPr>
+            <a:r>
+              <a:rPr lang="en-US" sz="1100" b="1" spc="300" kern="0" dirty="0">
+                <a:solidFill>
+                  <a:schemeClr val="accent2"/>
+                </a:solidFill>
+              </a:rPr>
+              <a:t>OUR TEAM</a:t>
+            </a:r>
+            <a:endParaRPr lang="en-US" sz="1100" dirty="0"/>
+          </a:p>
+        </p:txBody>
+      </p:sp>
+      <p:sp>
+        <p:nvSpPr>
+          <p:cNvPr id="6" name="Team member 1"/>
+          <p:cNvSpPr txBox="1"/>
+          <p:nvPr/>
+        </p:nvSpPr>
+        <p:spPr>
+          <a:xfrm>
+            <a:off x="548640" y="3749040"/>
+            <a:ext cx="2103120" cy="320040"/>
+          </a:xfrm>
+          <a:prstGeom prst="rect">
+            <a:avLst/>
+          </a:prstGeom>
+          <a:noFill/>
+          <a:ln/>
+        </p:spPr>
+        <p:txBody>
+          <a:bodyPr wrap="square" lIns="0" tIns="0" rIns="0" bIns="0" rtlCol="0" anchor="ctr"/>
+          <a:lstStyle/>
+          <a:p>
+            <a:pPr indent="0" marL="0">
+              <a:buNone/>
+            </a:pPr>
+            <a:r>
+              <a:rPr lang="en-US" sz="1400" dirty="0">
+                <a:solidFill>
+                  <a:schemeClr val="bg1"/>
+                </a:solidFill>
+              </a:rPr>
+              <a:t>Rahma Khaled</a:t>
+            </a:r>
+            <a:endParaRPr lang="en-US" sz="1400" dirty="0"/>
+          </a:p>
+        </p:txBody>
+      </p:sp>
+      <p:sp>
+        <p:nvSpPr>
+          <p:cNvPr id="7" name="Team member 2"/>
+          <p:cNvSpPr txBox="1"/>
+          <p:nvPr/>
+        </p:nvSpPr>
+        <p:spPr>
+          <a:xfrm>
+            <a:off x="2743200" y="3749040"/>
+            <a:ext cx="2103120" cy="320040"/>
+          </a:xfrm>
+          <a:prstGeom prst="rect">
+            <a:avLst/>
+          </a:prstGeom>
+          <a:noFill/>
+          <a:ln/>
+        </p:spPr>
+        <p:txBody>
+          <a:bodyPr wrap="square" lIns="0" tIns="0" rIns="0" bIns="0" rtlCol="0" anchor="ctr"/>
+          <a:lstStyle/>
+          <a:p>
+            <a:pPr indent="0" marL="0">
+              <a:buNone/>
+            </a:pPr>
+            <a:r>
+              <a:rPr lang="en-US" sz="1400" dirty="0">
+                <a:solidFill>
+                  <a:schemeClr val="bg1"/>
+                </a:solidFill>
+              </a:rPr>
+              <a:t>Aya Reda</a:t>
+            </a:r>
+            <a:endParaRPr lang="en-US" sz="1400" dirty="0"/>
+          </a:p>
+        </p:txBody>
+      </p:sp>
+      <p:sp>
+        <p:nvSpPr>
+          <p:cNvPr id="8" name="Team member 3"/>
+          <p:cNvSpPr txBox="1"/>
+          <p:nvPr/>
+        </p:nvSpPr>
+        <p:spPr>
+          <a:xfrm>
+            <a:off x="548640" y="4114800"/>
+            <a:ext cx="2103120" cy="320040"/>
+          </a:xfrm>
+          <a:prstGeom prst="rect">
+            <a:avLst/>
+          </a:prstGeom>
+          <a:noFill/>
+          <a:ln/>
+        </p:spPr>
+        <p:txBody>
+          <a:bodyPr wrap="square" lIns="0" tIns="0" rIns="0" bIns="0" rtlCol="0" anchor="ctr"/>
+          <a:lstStyle/>
+          <a:p>
+            <a:pPr indent="0" marL="0">
+              <a:buNone/>
+            </a:pPr>
+            <a:r>
+              <a:rPr lang="en-US" sz="1400" dirty="0">
+                <a:solidFill>
+                  <a:schemeClr val="bg1"/>
+                </a:solidFill>
+              </a:rPr>
+              <a:t>Mahmoud Ibrahim</a:t>
+            </a:r>
+            <a:endParaRPr lang="en-US" sz="1400" dirty="0"/>
+          </a:p>
+        </p:txBody>
+      </p:sp>
+      <p:sp>
+        <p:nvSpPr>
+          <p:cNvPr id="9" name="Team member 4"/>
+          <p:cNvSpPr txBox="1"/>
+          <p:nvPr/>
+        </p:nvSpPr>
+        <p:spPr>
+          <a:xfrm>
+            <a:off x="2743200" y="4114800"/>
+            <a:ext cx="2103120" cy="320040"/>
+          </a:xfrm>
+          <a:prstGeom prst="rect">
+            <a:avLst/>
+          </a:prstGeom>
+          <a:noFill/>
+          <a:ln/>
+        </p:spPr>
+        <p:txBody>
+          <a:bodyPr wrap="square" lIns="0" tIns="0" rIns="0" bIns="0" rtlCol="0" anchor="ctr"/>
+          <a:lstStyle/>
+          <a:p>
+            <a:pPr indent="0" marL="0">
+              <a:buNone/>
+            </a:pPr>
+            <a:r>
+              <a:rPr lang="en-US" sz="1400" dirty="0">
+                <a:solidFill>
+                  <a:schemeClr val="bg1"/>
+                </a:solidFill>
+              </a:rPr>
+              <a:t>Abader Zarif</a:t>
+            </a:r>
+            <a:endParaRPr lang="en-US" sz="1400" dirty="0"/>
+          </a:p>
+        </p:txBody>
+      </p:sp>
       <p:pic>
         <p:nvPicPr>
-          <p:cNvPr id="5" name="Café illustration" descr="Café illustration">    </p:cNvPr>
+          <p:cNvPr id="10" name="Café illustration" descr="Café illustration">    </p:cNvPr>
           <p:cNvPicPr>
             <a:picLocks noChangeAspect="1"/>
           </p:cNvPicPr>

</xml_diff>

<commit_message>
Remove phone and email placeholders from café proposal
Co-Authored-By: Claude Opus 5.5 <noreply@anthropic.com>
Claude-Session: https://claude.ai/code/session_01FBuHsgfNN7NePtiYw7LpVx
</commit_message>
<xml_diff>
--- a/Cafe_Marketing_Proposal.pptx
+++ b/Cafe_Marketing_Proposal.pptx
@@ -119,30 +119,30 @@
   <p:extLst>
     <p:ext uri="{521415D9-36F7-43E2-AB2F-B90AF26B5E84}">
       <p14:sectionLst xmlns:p14="http://schemas.microsoft.com/office/powerpoint/2010/main">
-        <p14:section name="Introduction" id="{d7c1ff54-7a78-1b6c-608b-45865889dd00}">
+        <p14:section name="Introduction" id="{08a8b1f2-d5ad-2bd9-c46b-a606016f6350}">
           <p14:sldIdLst>
             <p14:sldId id="256"/>
             <p14:sldId id="257"/>
           </p14:sldIdLst>
         </p14:section>
-        <p14:section name="Problem" id="{ccc356aa-3ae6-09fe-fc72-29573b0b6dd6}">
+        <p14:section name="Problem" id="{49812344-6752-3291-0893-27d6f7c2e5f9}">
           <p14:sldIdLst>
             <p14:sldId id="258"/>
           </p14:sldIdLst>
         </p14:section>
-        <p14:section name="Solution" id="{4f24179e-7ae3-5a27-8bfd-e3a8e41d4513}">
+        <p14:section name="Solution" id="{f67508d9-6785-ef07-4fd8-46d1e64a7374}">
           <p14:sldIdLst>
             <p14:sldId id="259"/>
             <p14:sldId id="260"/>
           </p14:sldIdLst>
         </p14:section>
-        <p14:section name="Budget and Timeline" id="{29df7fb2-5b0d-cd43-c034-d9512f563e2d}">
+        <p14:section name="Budget and Timeline" id="{15b30892-75d5-aa2c-5948-54b1034b9a01}">
           <p14:sldIdLst>
             <p14:sldId id="261"/>
             <p14:sldId id="262"/>
           </p14:sldIdLst>
         </p14:section>
-        <p14:section name="Results" id="{14f31e6a-5b88-9126-9644-8c745f83252d}">
+        <p14:section name="Results" id="{8b10a6ce-e896-b47e-f866-dc11f1713591}">
           <p14:sldIdLst>
             <p14:sldId id="263"/>
             <p14:sldId id="264"/>
@@ -150,12 +150,12 @@
             <p14:sldId id="266"/>
           </p14:sldIdLst>
         </p14:section>
-        <p14:section name="Why Us" id="{be00e101-3fb4-d1af-33b7-aa2dacaaa3c0}">
+        <p14:section name="Why Us" id="{3deec604-ea42-db30-ffdb-4d6977355b59}">
           <p14:sldIdLst>
             <p14:sldId id="267"/>
           </p14:sldIdLst>
         </p14:section>
-        <p14:section name="Conclusion" id="{3c4da55e-699d-63cd-d0b4-18c39f47c786}">
+        <p14:section name="Conclusion" id="{5e7f0011-6733-d368-5483-b8c20fd57d87}">
           <p14:sldIdLst>
             <p14:sldId id="268"/>
           </p14:sldIdLst>
@@ -5783,7 +5783,7 @@
       </p:sp>
       <p:sp>
         <p:nvSpPr>
-          <p:cNvPr id="8" name="Contact details"/>
+          <p:cNvPr id="8" name="Agency name"/>
           <p:cNvSpPr txBox="1"/>
           <p:nvPr/>
         </p:nvSpPr>
@@ -5811,7 +5811,7 @@
                   <a:schemeClr val="accent2"/>
                 </a:solidFill>
               </a:rPr>
-              <a:t>Pulse Marketing   |   [Phone]   |   [Email]</a:t>
+              <a:t>Pulse Marketing</a:t>
             </a:r>
             <a:endParaRPr lang="en-US" sz="1300" dirty="0"/>
           </a:p>

</xml_diff>